<commit_message>
25/04/2026: Images for the oral presentation added, and class materials for the research skills class
</commit_message>
<xml_diff>
--- a/Oral_presentation/Oral_Presentation.pptx
+++ b/Oral_presentation/Oral_Presentation.pptx
@@ -209,7 +209,7 @@
           <a:p>
             <a:fld id="{CA1E58A6-B5FA-4B3B-BC1A-ECF1AECB335E}" type="datetimeFigureOut">
               <a:rPr lang="en-AU" smtClean="0"/>
-              <a:t>20/04/2026</a:t>
+              <a:t>21/04/2026</a:t>
             </a:fld>
             <a:endParaRPr lang="en-AU"/>
           </a:p>
@@ -626,7 +626,7 @@
           <a:p>
             <a:fld id="{DFC75409-981D-470B-8D60-DE1F0F2289A4}" type="datetime1">
               <a:rPr lang="en-AU" smtClean="0"/>
-              <a:t>20/04/2026</a:t>
+              <a:t>21/04/2026</a:t>
             </a:fld>
             <a:endParaRPr lang="en-AU"/>
           </a:p>
@@ -826,7 +826,7 @@
           <a:p>
             <a:fld id="{F901EF7E-0D07-468E-9199-9CAA2292480B}" type="datetime1">
               <a:rPr lang="en-AU" smtClean="0"/>
-              <a:t>20/04/2026</a:t>
+              <a:t>21/04/2026</a:t>
             </a:fld>
             <a:endParaRPr lang="en-AU"/>
           </a:p>
@@ -1036,7 +1036,7 @@
           <a:p>
             <a:fld id="{B0406FED-A910-4DF0-AA19-BFAD69440E90}" type="datetime1">
               <a:rPr lang="en-AU" smtClean="0"/>
-              <a:t>20/04/2026</a:t>
+              <a:t>21/04/2026</a:t>
             </a:fld>
             <a:endParaRPr lang="en-AU"/>
           </a:p>
@@ -1236,7 +1236,7 @@
           <a:p>
             <a:fld id="{69CCE75F-3F19-48B7-AC6E-2A69D63E7872}" type="datetime1">
               <a:rPr lang="en-AU" smtClean="0"/>
-              <a:t>20/04/2026</a:t>
+              <a:t>21/04/2026</a:t>
             </a:fld>
             <a:endParaRPr lang="en-AU"/>
           </a:p>
@@ -1512,7 +1512,7 @@
           <a:p>
             <a:fld id="{E6628635-DA37-4CD1-A4A5-642A9202D05F}" type="datetime1">
               <a:rPr lang="en-AU" smtClean="0"/>
-              <a:t>20/04/2026</a:t>
+              <a:t>21/04/2026</a:t>
             </a:fld>
             <a:endParaRPr lang="en-AU"/>
           </a:p>
@@ -1780,7 +1780,7 @@
           <a:p>
             <a:fld id="{77035A01-6FFD-4D46-B652-19100245DAC4}" type="datetime1">
               <a:rPr lang="en-AU" smtClean="0"/>
-              <a:t>20/04/2026</a:t>
+              <a:t>21/04/2026</a:t>
             </a:fld>
             <a:endParaRPr lang="en-AU"/>
           </a:p>
@@ -2195,7 +2195,7 @@
           <a:p>
             <a:fld id="{5BD18141-3524-4573-A4D9-3DF19BB26B65}" type="datetime1">
               <a:rPr lang="en-AU" smtClean="0"/>
-              <a:t>20/04/2026</a:t>
+              <a:t>21/04/2026</a:t>
             </a:fld>
             <a:endParaRPr lang="en-AU"/>
           </a:p>
@@ -2337,7 +2337,7 @@
           <a:p>
             <a:fld id="{09FA7A4A-A5A5-448E-8D3D-73D7307D3E2A}" type="datetime1">
               <a:rPr lang="en-AU" smtClean="0"/>
-              <a:t>20/04/2026</a:t>
+              <a:t>21/04/2026</a:t>
             </a:fld>
             <a:endParaRPr lang="en-AU"/>
           </a:p>
@@ -2450,7 +2450,7 @@
           <a:p>
             <a:fld id="{554680C4-847D-407D-9F6D-7724EAF273B7}" type="datetime1">
               <a:rPr lang="en-AU" smtClean="0"/>
-              <a:t>20/04/2026</a:t>
+              <a:t>21/04/2026</a:t>
             </a:fld>
             <a:endParaRPr lang="en-AU"/>
           </a:p>
@@ -2763,7 +2763,7 @@
           <a:p>
             <a:fld id="{E3434D61-1A14-4D3E-BCB8-657AA9B01B2A}" type="datetime1">
               <a:rPr lang="en-AU" smtClean="0"/>
-              <a:t>20/04/2026</a:t>
+              <a:t>21/04/2026</a:t>
             </a:fld>
             <a:endParaRPr lang="en-AU"/>
           </a:p>
@@ -3052,7 +3052,7 @@
           <a:p>
             <a:fld id="{100C1F26-DC41-4676-9A8C-A9C42AEA0B18}" type="datetime1">
               <a:rPr lang="en-AU" smtClean="0"/>
-              <a:t>20/04/2026</a:t>
+              <a:t>21/04/2026</a:t>
             </a:fld>
             <a:endParaRPr lang="en-AU"/>
           </a:p>
@@ -3295,7 +3295,7 @@
           <a:p>
             <a:fld id="{6D249E5D-CC30-48BA-A2A1-2B2106A32E6C}" type="datetime1">
               <a:rPr lang="en-AU" smtClean="0"/>
-              <a:t>20/04/2026</a:t>
+              <a:t>21/04/2026</a:t>
             </a:fld>
             <a:endParaRPr lang="en-AU"/>
           </a:p>
@@ -3836,7 +3836,7 @@
 </file>
 
 <file path=ppt/slides/slide10.xml><?xml version="1.0" encoding="utf-8"?>
-<p:sld xmlns:a="http://schemas.openxmlformats.org/drawingml/2006/main" xmlns:r="http://schemas.openxmlformats.org/officeDocument/2006/relationships" xmlns:p="http://schemas.openxmlformats.org/presentationml/2006/main" show="0">
+<p:sld xmlns:a="http://schemas.openxmlformats.org/drawingml/2006/main" xmlns:r="http://schemas.openxmlformats.org/officeDocument/2006/relationships" xmlns:p="http://schemas.openxmlformats.org/presentationml/2006/main">
   <p:cSld>
     <p:spTree>
       <p:nvGrpSpPr>
@@ -3944,17 +3944,89 @@
           <a:p>
             <a:r>
               <a:rPr lang="en-AU" dirty="0"/>
-              <a:t>If early flux excesses correlate with specific environmental properties this could help identify the progenitor properties of early excess and it could help constrain SNe Ia to include in cosmological samples</a:t>
-            </a:r>
-          </a:p>
-          <a:p>
-            <a:r>
-              <a:rPr lang="en-AU" dirty="0"/>
-              <a:t>Due to how limited sample sizes have been of early excess SNe Ia have been they have been difficult to study. Now with LSST the chances of finding them are greater, opening up the possibility of studying the objects.</a:t>
-            </a:r>
-          </a:p>
-        </p:txBody>
-      </p:sp>
+              <a:t>How do early excess flux SNe Ia correlate with host galaxy properties? </a:t>
+            </a:r>
+          </a:p>
+          <a:p>
+            <a:pPr marL="0" indent="0">
+              <a:buNone/>
+            </a:pPr>
+            <a:endParaRPr lang="en-AU" dirty="0"/>
+          </a:p>
+        </p:txBody>
+      </p:sp>
+      <p:pic>
+        <p:nvPicPr>
+          <p:cNvPr id="6" name="Picture 5">
+            <a:extLst>
+              <a:ext uri="{FF2B5EF4-FFF2-40B4-BE49-F238E27FC236}">
+                <a16:creationId xmlns:a16="http://schemas.microsoft.com/office/drawing/2014/main" id="{9F27D2F2-1328-C59E-176E-B40224B95356}"/>
+              </a:ext>
+            </a:extLst>
+          </p:cNvPr>
+          <p:cNvPicPr>
+            <a:picLocks noChangeAspect="1"/>
+          </p:cNvPicPr>
+          <p:nvPr/>
+        </p:nvPicPr>
+        <p:blipFill>
+          <a:blip r:embed="rId3">
+            <a:extLst>
+              <a:ext uri="{28A0092B-C50C-407E-A947-70E740481C1C}">
+                <a14:useLocalDpi xmlns:a14="http://schemas.microsoft.com/office/drawing/2010/main" val="0"/>
+              </a:ext>
+            </a:extLst>
+          </a:blip>
+          <a:stretch>
+            <a:fillRect/>
+          </a:stretch>
+        </p:blipFill>
+        <p:spPr>
+          <a:xfrm>
+            <a:off x="277945" y="3664955"/>
+            <a:ext cx="6014093" cy="2173676"/>
+          </a:xfrm>
+          <a:prstGeom prst="rect">
+            <a:avLst/>
+          </a:prstGeom>
+        </p:spPr>
+      </p:pic>
+      <p:pic>
+        <p:nvPicPr>
+          <p:cNvPr id="8" name="Picture 7">
+            <a:extLst>
+              <a:ext uri="{FF2B5EF4-FFF2-40B4-BE49-F238E27FC236}">
+                <a16:creationId xmlns:a16="http://schemas.microsoft.com/office/drawing/2014/main" id="{A55D23B5-1FB3-DC00-E3C1-52864883826C}"/>
+              </a:ext>
+            </a:extLst>
+          </p:cNvPr>
+          <p:cNvPicPr>
+            <a:picLocks noChangeAspect="1"/>
+          </p:cNvPicPr>
+          <p:nvPr/>
+        </p:nvPicPr>
+        <p:blipFill>
+          <a:blip r:embed="rId4">
+            <a:extLst>
+              <a:ext uri="{28A0092B-C50C-407E-A947-70E740481C1C}">
+                <a14:useLocalDpi xmlns:a14="http://schemas.microsoft.com/office/drawing/2010/main" val="0"/>
+              </a:ext>
+            </a:extLst>
+          </a:blip>
+          <a:stretch>
+            <a:fillRect/>
+          </a:stretch>
+        </p:blipFill>
+        <p:spPr>
+          <a:xfrm>
+            <a:off x="6569983" y="2622767"/>
+            <a:ext cx="4184791" cy="4010877"/>
+          </a:xfrm>
+          <a:prstGeom prst="rect">
+            <a:avLst/>
+          </a:prstGeom>
+        </p:spPr>
+      </p:pic>
     </p:spTree>
     <p:extLst>
       <p:ext uri="{BB962C8B-B14F-4D97-AF65-F5344CB8AC3E}">
@@ -4077,29 +4149,61 @@
           <a:p>
             <a:r>
               <a:rPr lang="en-AU" dirty="0"/>
-              <a:t>Describe how Rubin enables the LSST survey which produces a high volume of alerts per night. </a:t>
-            </a:r>
-          </a:p>
-          <a:p>
+              <a:t>With Rubin and LSST producing 10 million alerts per night, the chances of finding </a:t>
+            </a:r>
+            <a:r>
+              <a:rPr lang="en-AU" dirty="0" err="1"/>
+              <a:t>EEx</a:t>
+            </a:r>
+            <a:r>
+              <a:rPr lang="en-AU" dirty="0"/>
+              <a:t> SNe Ia are better than they ever have been!</a:t>
+            </a:r>
+          </a:p>
+          <a:p>
+            <a:pPr marL="0" indent="0">
+              <a:buNone/>
+            </a:pPr>
             <a:endParaRPr lang="en-AU" dirty="0"/>
           </a:p>
-          <a:p>
-            <a:r>
-              <a:rPr lang="en-AU" dirty="0"/>
-              <a:t>High volume of alerts necessitates the use of the Fink broker to derive samples for study without tedious visual inspection.</a:t>
-            </a:r>
-          </a:p>
-          <a:p>
-            <a:endParaRPr lang="en-AU" dirty="0"/>
-          </a:p>
-          <a:p>
-            <a:r>
-              <a:rPr lang="en-AU" dirty="0"/>
-              <a:t>Describe how Fink’s specific active learning architecture will help enable faster initial analysis of the interesting alerts. </a:t>
-            </a:r>
-          </a:p>
-        </p:txBody>
-      </p:sp>
+        </p:txBody>
+      </p:sp>
+      <p:pic>
+        <p:nvPicPr>
+          <p:cNvPr id="6" name="Picture 5">
+            <a:extLst>
+              <a:ext uri="{FF2B5EF4-FFF2-40B4-BE49-F238E27FC236}">
+                <a16:creationId xmlns:a16="http://schemas.microsoft.com/office/drawing/2014/main" id="{AC25E318-1D6E-01A5-9B6C-771FCE8F5B6E}"/>
+              </a:ext>
+            </a:extLst>
+          </p:cNvPr>
+          <p:cNvPicPr>
+            <a:picLocks noChangeAspect="1"/>
+          </p:cNvPicPr>
+          <p:nvPr/>
+        </p:nvPicPr>
+        <p:blipFill>
+          <a:blip r:embed="rId3">
+            <a:extLst>
+              <a:ext uri="{28A0092B-C50C-407E-A947-70E740481C1C}">
+                <a14:useLocalDpi xmlns:a14="http://schemas.microsoft.com/office/drawing/2010/main" val="0"/>
+              </a:ext>
+            </a:extLst>
+          </a:blip>
+          <a:stretch>
+            <a:fillRect/>
+          </a:stretch>
+        </p:blipFill>
+        <p:spPr>
+          <a:xfrm>
+            <a:off x="3500928" y="2749553"/>
+            <a:ext cx="5190144" cy="3793902"/>
+          </a:xfrm>
+          <a:prstGeom prst="rect">
+            <a:avLst/>
+          </a:prstGeom>
+        </p:spPr>
+      </p:pic>
     </p:spTree>
     <p:extLst>
       <p:ext uri="{BB962C8B-B14F-4D97-AF65-F5344CB8AC3E}">
@@ -4394,7 +4498,15 @@
             </a:r>
             <a:r>
               <a:rPr lang="en-AU" dirty="0"/>
-              <a:t> SNe Ia against host galaxy properties to determine if there is a trend in where SNe Ia occur.</a:t>
+              <a:t> SNe Ia against host galaxy mass, DLR, colour and SFR to determine how </a:t>
+            </a:r>
+            <a:r>
+              <a:rPr lang="en-AU" dirty="0" err="1"/>
+              <a:t>Eex</a:t>
+            </a:r>
+            <a:r>
+              <a:rPr lang="en-AU" dirty="0"/>
+              <a:t> SNe Ia trend with these features.</a:t>
             </a:r>
           </a:p>
           <a:p>
@@ -6636,6 +6748,114 @@
           </a:p>
         </p:txBody>
       </p:sp>
+      <p:pic>
+        <p:nvPicPr>
+          <p:cNvPr id="7" name="Picture 6">
+            <a:extLst>
+              <a:ext uri="{FF2B5EF4-FFF2-40B4-BE49-F238E27FC236}">
+                <a16:creationId xmlns:a16="http://schemas.microsoft.com/office/drawing/2014/main" id="{A7D4CAA6-AF0E-8168-E964-FD907ECBACCE}"/>
+              </a:ext>
+            </a:extLst>
+          </p:cNvPr>
+          <p:cNvPicPr>
+            <a:picLocks noChangeAspect="1"/>
+          </p:cNvPicPr>
+          <p:nvPr/>
+        </p:nvPicPr>
+        <p:blipFill>
+          <a:blip r:embed="rId3">
+            <a:extLst>
+              <a:ext uri="{28A0092B-C50C-407E-A947-70E740481C1C}">
+                <a14:useLocalDpi xmlns:a14="http://schemas.microsoft.com/office/drawing/2010/main" val="0"/>
+              </a:ext>
+            </a:extLst>
+          </a:blip>
+          <a:stretch>
+            <a:fillRect/>
+          </a:stretch>
+        </p:blipFill>
+        <p:spPr>
+          <a:xfrm>
+            <a:off x="816535" y="3429000"/>
+            <a:ext cx="3022459" cy="2271042"/>
+          </a:xfrm>
+          <a:prstGeom prst="rect">
+            <a:avLst/>
+          </a:prstGeom>
+        </p:spPr>
+      </p:pic>
+      <p:pic>
+        <p:nvPicPr>
+          <p:cNvPr id="9" name="Picture 8">
+            <a:extLst>
+              <a:ext uri="{FF2B5EF4-FFF2-40B4-BE49-F238E27FC236}">
+                <a16:creationId xmlns:a16="http://schemas.microsoft.com/office/drawing/2014/main" id="{01F0B274-435A-24DB-2506-66435BFEC1A4}"/>
+              </a:ext>
+            </a:extLst>
+          </p:cNvPr>
+          <p:cNvPicPr>
+            <a:picLocks noChangeAspect="1"/>
+          </p:cNvPicPr>
+          <p:nvPr/>
+        </p:nvPicPr>
+        <p:blipFill>
+          <a:blip r:embed="rId4">
+            <a:extLst>
+              <a:ext uri="{28A0092B-C50C-407E-A947-70E740481C1C}">
+                <a14:useLocalDpi xmlns:a14="http://schemas.microsoft.com/office/drawing/2010/main" val="0"/>
+              </a:ext>
+            </a:extLst>
+          </a:blip>
+          <a:stretch>
+            <a:fillRect/>
+          </a:stretch>
+        </p:blipFill>
+        <p:spPr>
+          <a:xfrm>
+            <a:off x="4584770" y="3429000"/>
+            <a:ext cx="3022459" cy="2823858"/>
+          </a:xfrm>
+          <a:prstGeom prst="rect">
+            <a:avLst/>
+          </a:prstGeom>
+        </p:spPr>
+      </p:pic>
+      <p:pic>
+        <p:nvPicPr>
+          <p:cNvPr id="11" name="Picture 10">
+            <a:extLst>
+              <a:ext uri="{FF2B5EF4-FFF2-40B4-BE49-F238E27FC236}">
+                <a16:creationId xmlns:a16="http://schemas.microsoft.com/office/drawing/2014/main" id="{5918CAA6-D564-15A9-D7D5-ED012FE9E947}"/>
+              </a:ext>
+            </a:extLst>
+          </p:cNvPr>
+          <p:cNvPicPr>
+            <a:picLocks noChangeAspect="1"/>
+          </p:cNvPicPr>
+          <p:nvPr/>
+        </p:nvPicPr>
+        <p:blipFill>
+          <a:blip r:embed="rId5">
+            <a:extLst>
+              <a:ext uri="{28A0092B-C50C-407E-A947-70E740481C1C}">
+                <a14:useLocalDpi xmlns:a14="http://schemas.microsoft.com/office/drawing/2010/main" val="0"/>
+              </a:ext>
+            </a:extLst>
+          </a:blip>
+          <a:stretch>
+            <a:fillRect/>
+          </a:stretch>
+        </p:blipFill>
+        <p:spPr>
+          <a:xfrm>
+            <a:off x="8423764" y="3429000"/>
+            <a:ext cx="3022459" cy="2405269"/>
+          </a:xfrm>
+          <a:prstGeom prst="rect">
+            <a:avLst/>
+          </a:prstGeom>
+        </p:spPr>
+      </p:pic>
     </p:spTree>
     <p:extLst>
       <p:ext uri="{BB962C8B-B14F-4D97-AF65-F5344CB8AC3E}">

</xml_diff>

<commit_message>
29/04/2026: Made edits to slides for the oral presentation of literature review and project proposal started finding extra-galactic candidates using Fink API
</commit_message>
<xml_diff>
--- a/Oral_presentation/Oral_Presentation.pptx
+++ b/Oral_presentation/Oral_Presentation.pptx
@@ -5,22 +5,18 @@
     <p:sldMasterId id="2147483648" r:id="rId1"/>
   </p:sldMasterIdLst>
   <p:notesMasterIdLst>
-    <p:notesMasterId r:id="rId15"/>
+    <p:notesMasterId r:id="rId11"/>
   </p:notesMasterIdLst>
   <p:sldIdLst>
     <p:sldId id="256" r:id="rId2"/>
     <p:sldId id="257" r:id="rId3"/>
-    <p:sldId id="265" r:id="rId4"/>
-    <p:sldId id="266" r:id="rId5"/>
-    <p:sldId id="267" r:id="rId6"/>
-    <p:sldId id="258" r:id="rId7"/>
-    <p:sldId id="268" r:id="rId8"/>
-    <p:sldId id="259" r:id="rId9"/>
-    <p:sldId id="260" r:id="rId10"/>
-    <p:sldId id="261" r:id="rId11"/>
-    <p:sldId id="262" r:id="rId12"/>
-    <p:sldId id="263" r:id="rId13"/>
-    <p:sldId id="264" r:id="rId14"/>
+    <p:sldId id="266" r:id="rId4"/>
+    <p:sldId id="265" r:id="rId5"/>
+    <p:sldId id="259" r:id="rId6"/>
+    <p:sldId id="260" r:id="rId7"/>
+    <p:sldId id="264" r:id="rId8"/>
+    <p:sldId id="267" r:id="rId9"/>
+    <p:sldId id="268" r:id="rId10"/>
   </p:sldIdLst>
   <p:sldSz cx="12192000" cy="6858000"/>
   <p:notesSz cx="7315200" cy="9601200"/>
@@ -209,7 +205,7 @@
           <a:p>
             <a:fld id="{CA1E58A6-B5FA-4B3B-BC1A-ECF1AECB335E}" type="datetimeFigureOut">
               <a:rPr lang="en-AU" smtClean="0"/>
-              <a:t>21/04/2026</a:t>
+              <a:t>29/04/2026</a:t>
             </a:fld>
             <a:endParaRPr lang="en-AU"/>
           </a:p>
@@ -624,9 +620,9 @@
           <a:bodyPr/>
           <a:lstStyle/>
           <a:p>
-            <a:fld id="{DFC75409-981D-470B-8D60-DE1F0F2289A4}" type="datetime1">
+            <a:fld id="{FDFF1C0A-DBEE-4FE2-852B-82F11989E8A8}" type="datetime1">
               <a:rPr lang="en-AU" smtClean="0"/>
-              <a:t>21/04/2026</a:t>
+              <a:t>29/04/2026</a:t>
             </a:fld>
             <a:endParaRPr lang="en-AU"/>
           </a:p>
@@ -824,9 +820,9 @@
           <a:bodyPr/>
           <a:lstStyle/>
           <a:p>
-            <a:fld id="{F901EF7E-0D07-468E-9199-9CAA2292480B}" type="datetime1">
+            <a:fld id="{0B756B61-0096-4C58-ACC2-A1879528B12C}" type="datetime1">
               <a:rPr lang="en-AU" smtClean="0"/>
-              <a:t>21/04/2026</a:t>
+              <a:t>29/04/2026</a:t>
             </a:fld>
             <a:endParaRPr lang="en-AU"/>
           </a:p>
@@ -1034,9 +1030,9 @@
           <a:bodyPr/>
           <a:lstStyle/>
           <a:p>
-            <a:fld id="{B0406FED-A910-4DF0-AA19-BFAD69440E90}" type="datetime1">
+            <a:fld id="{7FD94802-E000-4AA6-AAA6-10910B20F9C7}" type="datetime1">
               <a:rPr lang="en-AU" smtClean="0"/>
-              <a:t>21/04/2026</a:t>
+              <a:t>29/04/2026</a:t>
             </a:fld>
             <a:endParaRPr lang="en-AU"/>
           </a:p>
@@ -1234,9 +1230,9 @@
           <a:bodyPr/>
           <a:lstStyle/>
           <a:p>
-            <a:fld id="{69CCE75F-3F19-48B7-AC6E-2A69D63E7872}" type="datetime1">
+            <a:fld id="{22904B64-59A1-43FD-A621-718A7387472C}" type="datetime1">
               <a:rPr lang="en-AU" smtClean="0"/>
-              <a:t>21/04/2026</a:t>
+              <a:t>29/04/2026</a:t>
             </a:fld>
             <a:endParaRPr lang="en-AU"/>
           </a:p>
@@ -1510,9 +1506,9 @@
           <a:bodyPr/>
           <a:lstStyle/>
           <a:p>
-            <a:fld id="{E6628635-DA37-4CD1-A4A5-642A9202D05F}" type="datetime1">
+            <a:fld id="{99326B86-071E-4515-930A-F55E3C3EE194}" type="datetime1">
               <a:rPr lang="en-AU" smtClean="0"/>
-              <a:t>21/04/2026</a:t>
+              <a:t>29/04/2026</a:t>
             </a:fld>
             <a:endParaRPr lang="en-AU"/>
           </a:p>
@@ -1778,9 +1774,9 @@
           <a:bodyPr/>
           <a:lstStyle/>
           <a:p>
-            <a:fld id="{77035A01-6FFD-4D46-B652-19100245DAC4}" type="datetime1">
+            <a:fld id="{CDC87059-F666-41C9-8FAB-AA5146F3FF07}" type="datetime1">
               <a:rPr lang="en-AU" smtClean="0"/>
-              <a:t>21/04/2026</a:t>
+              <a:t>29/04/2026</a:t>
             </a:fld>
             <a:endParaRPr lang="en-AU"/>
           </a:p>
@@ -2193,9 +2189,9 @@
           <a:bodyPr/>
           <a:lstStyle/>
           <a:p>
-            <a:fld id="{5BD18141-3524-4573-A4D9-3DF19BB26B65}" type="datetime1">
+            <a:fld id="{4931922F-AC76-4557-B850-17936BEC57CD}" type="datetime1">
               <a:rPr lang="en-AU" smtClean="0"/>
-              <a:t>21/04/2026</a:t>
+              <a:t>29/04/2026</a:t>
             </a:fld>
             <a:endParaRPr lang="en-AU"/>
           </a:p>
@@ -2335,9 +2331,9 @@
           <a:bodyPr/>
           <a:lstStyle/>
           <a:p>
-            <a:fld id="{09FA7A4A-A5A5-448E-8D3D-73D7307D3E2A}" type="datetime1">
+            <a:fld id="{5FD4AD57-261B-4308-8154-628BF8DC3A87}" type="datetime1">
               <a:rPr lang="en-AU" smtClean="0"/>
-              <a:t>21/04/2026</a:t>
+              <a:t>29/04/2026</a:t>
             </a:fld>
             <a:endParaRPr lang="en-AU"/>
           </a:p>
@@ -2448,9 +2444,9 @@
           <a:bodyPr/>
           <a:lstStyle/>
           <a:p>
-            <a:fld id="{554680C4-847D-407D-9F6D-7724EAF273B7}" type="datetime1">
+            <a:fld id="{511D5AC2-A68E-45A5-B4B8-629D21A8D68D}" type="datetime1">
               <a:rPr lang="en-AU" smtClean="0"/>
-              <a:t>21/04/2026</a:t>
+              <a:t>29/04/2026</a:t>
             </a:fld>
             <a:endParaRPr lang="en-AU"/>
           </a:p>
@@ -2761,9 +2757,9 @@
           <a:bodyPr/>
           <a:lstStyle/>
           <a:p>
-            <a:fld id="{E3434D61-1A14-4D3E-BCB8-657AA9B01B2A}" type="datetime1">
+            <a:fld id="{11A0A4F9-681A-41D6-8425-C45A9FA1042F}" type="datetime1">
               <a:rPr lang="en-AU" smtClean="0"/>
-              <a:t>21/04/2026</a:t>
+              <a:t>29/04/2026</a:t>
             </a:fld>
             <a:endParaRPr lang="en-AU"/>
           </a:p>
@@ -3050,9 +3046,9 @@
           <a:bodyPr/>
           <a:lstStyle/>
           <a:p>
-            <a:fld id="{100C1F26-DC41-4676-9A8C-A9C42AEA0B18}" type="datetime1">
+            <a:fld id="{6DD43FD3-C9E7-4676-B279-9A8841C441C7}" type="datetime1">
               <a:rPr lang="en-AU" smtClean="0"/>
-              <a:t>21/04/2026</a:t>
+              <a:t>29/04/2026</a:t>
             </a:fld>
             <a:endParaRPr lang="en-AU"/>
           </a:p>
@@ -3293,9 +3289,9 @@
             </a:lvl1pPr>
           </a:lstStyle>
           <a:p>
-            <a:fld id="{6D249E5D-CC30-48BA-A2A1-2B2106A32E6C}" type="datetime1">
+            <a:fld id="{3770AA3F-019E-456E-8699-AA2A3442A186}" type="datetime1">
               <a:rPr lang="en-AU" smtClean="0"/>
-              <a:t>21/04/2026</a:t>
+              <a:t>29/04/2026</a:t>
             </a:fld>
             <a:endParaRPr lang="en-AU"/>
           </a:p>
@@ -3835,701 +3831,6 @@
 </p:sld>
 </file>
 
-<file path=ppt/slides/slide10.xml><?xml version="1.0" encoding="utf-8"?>
-<p:sld xmlns:a="http://schemas.openxmlformats.org/drawingml/2006/main" xmlns:r="http://schemas.openxmlformats.org/officeDocument/2006/relationships" xmlns:p="http://schemas.openxmlformats.org/presentationml/2006/main">
-  <p:cSld>
-    <p:spTree>
-      <p:nvGrpSpPr>
-        <p:cNvPr id="1" name=""/>
-        <p:cNvGrpSpPr/>
-        <p:nvPr/>
-      </p:nvGrpSpPr>
-      <p:grpSpPr>
-        <a:xfrm>
-          <a:off x="0" y="0"/>
-          <a:ext cx="0" cy="0"/>
-          <a:chOff x="0" y="0"/>
-          <a:chExt cx="0" cy="0"/>
-        </a:xfrm>
-      </p:grpSpPr>
-      <p:pic>
-        <p:nvPicPr>
-          <p:cNvPr id="4" name="Picture 3">
-            <a:extLst>
-              <a:ext uri="{FF2B5EF4-FFF2-40B4-BE49-F238E27FC236}">
-                <a16:creationId xmlns:a16="http://schemas.microsoft.com/office/drawing/2014/main" id="{E1191619-22A1-49DC-D40D-E5A232C5BCD2}"/>
-              </a:ext>
-            </a:extLst>
-          </p:cNvPr>
-          <p:cNvPicPr>
-            <a:picLocks noChangeAspect="1"/>
-          </p:cNvPicPr>
-          <p:nvPr/>
-        </p:nvPicPr>
-        <p:blipFill>
-          <a:blip r:embed="rId2">
-            <a:extLst>
-              <a:ext uri="{28A0092B-C50C-407E-A947-70E740481C1C}">
-                <a14:useLocalDpi xmlns:a14="http://schemas.microsoft.com/office/drawing/2010/main" val="0"/>
-              </a:ext>
-            </a:extLst>
-          </a:blip>
-          <a:stretch>
-            <a:fillRect/>
-          </a:stretch>
-        </p:blipFill>
-        <p:spPr>
-          <a:xfrm>
-            <a:off x="0" y="0"/>
-            <a:ext cx="12192000" cy="6858000"/>
-          </a:xfrm>
-          <a:prstGeom prst="rect">
-            <a:avLst/>
-          </a:prstGeom>
-        </p:spPr>
-      </p:pic>
-      <p:sp>
-        <p:nvSpPr>
-          <p:cNvPr id="2" name="Title 1">
-            <a:extLst>
-              <a:ext uri="{FF2B5EF4-FFF2-40B4-BE49-F238E27FC236}">
-                <a16:creationId xmlns:a16="http://schemas.microsoft.com/office/drawing/2014/main" id="{30616BCB-5670-4C35-046A-9AD3A5C2E8E6}"/>
-              </a:ext>
-            </a:extLst>
-          </p:cNvPr>
-          <p:cNvSpPr>
-            <a:spLocks noGrp="1"/>
-          </p:cNvSpPr>
-          <p:nvPr>
-            <p:ph type="title"/>
-          </p:nvPr>
-        </p:nvSpPr>
-        <p:spPr/>
-        <p:txBody>
-          <a:bodyPr/>
-          <a:lstStyle/>
-          <a:p>
-            <a:r>
-              <a:rPr lang="en-AU" dirty="0"/>
-              <a:t>Early Excess and Host Environments</a:t>
-            </a:r>
-          </a:p>
-        </p:txBody>
-      </p:sp>
-      <p:sp>
-        <p:nvSpPr>
-          <p:cNvPr id="3" name="Content Placeholder 2">
-            <a:extLst>
-              <a:ext uri="{FF2B5EF4-FFF2-40B4-BE49-F238E27FC236}">
-                <a16:creationId xmlns:a16="http://schemas.microsoft.com/office/drawing/2014/main" id="{ECE88610-2531-EB44-2FDE-F3856D1AF884}"/>
-              </a:ext>
-            </a:extLst>
-          </p:cNvPr>
-          <p:cNvSpPr>
-            <a:spLocks noGrp="1"/>
-          </p:cNvSpPr>
-          <p:nvPr>
-            <p:ph idx="1"/>
-          </p:nvPr>
-        </p:nvSpPr>
-        <p:spPr>
-          <a:xfrm>
-            <a:off x="838200" y="1825625"/>
-            <a:ext cx="10098024" cy="4351338"/>
-          </a:xfrm>
-        </p:spPr>
-        <p:txBody>
-          <a:bodyPr/>
-          <a:lstStyle/>
-          <a:p>
-            <a:r>
-              <a:rPr lang="en-AU" dirty="0"/>
-              <a:t>How do early excess flux SNe Ia correlate with host galaxy properties? </a:t>
-            </a:r>
-          </a:p>
-          <a:p>
-            <a:pPr marL="0" indent="0">
-              <a:buNone/>
-            </a:pPr>
-            <a:endParaRPr lang="en-AU" dirty="0"/>
-          </a:p>
-        </p:txBody>
-      </p:sp>
-      <p:pic>
-        <p:nvPicPr>
-          <p:cNvPr id="6" name="Picture 5">
-            <a:extLst>
-              <a:ext uri="{FF2B5EF4-FFF2-40B4-BE49-F238E27FC236}">
-                <a16:creationId xmlns:a16="http://schemas.microsoft.com/office/drawing/2014/main" id="{9F27D2F2-1328-C59E-176E-B40224B95356}"/>
-              </a:ext>
-            </a:extLst>
-          </p:cNvPr>
-          <p:cNvPicPr>
-            <a:picLocks noChangeAspect="1"/>
-          </p:cNvPicPr>
-          <p:nvPr/>
-        </p:nvPicPr>
-        <p:blipFill>
-          <a:blip r:embed="rId3">
-            <a:extLst>
-              <a:ext uri="{28A0092B-C50C-407E-A947-70E740481C1C}">
-                <a14:useLocalDpi xmlns:a14="http://schemas.microsoft.com/office/drawing/2010/main" val="0"/>
-              </a:ext>
-            </a:extLst>
-          </a:blip>
-          <a:stretch>
-            <a:fillRect/>
-          </a:stretch>
-        </p:blipFill>
-        <p:spPr>
-          <a:xfrm>
-            <a:off x="277945" y="3664955"/>
-            <a:ext cx="6014093" cy="2173676"/>
-          </a:xfrm>
-          <a:prstGeom prst="rect">
-            <a:avLst/>
-          </a:prstGeom>
-        </p:spPr>
-      </p:pic>
-      <p:pic>
-        <p:nvPicPr>
-          <p:cNvPr id="8" name="Picture 7">
-            <a:extLst>
-              <a:ext uri="{FF2B5EF4-FFF2-40B4-BE49-F238E27FC236}">
-                <a16:creationId xmlns:a16="http://schemas.microsoft.com/office/drawing/2014/main" id="{A55D23B5-1FB3-DC00-E3C1-52864883826C}"/>
-              </a:ext>
-            </a:extLst>
-          </p:cNvPr>
-          <p:cNvPicPr>
-            <a:picLocks noChangeAspect="1"/>
-          </p:cNvPicPr>
-          <p:nvPr/>
-        </p:nvPicPr>
-        <p:blipFill>
-          <a:blip r:embed="rId4">
-            <a:extLst>
-              <a:ext uri="{28A0092B-C50C-407E-A947-70E740481C1C}">
-                <a14:useLocalDpi xmlns:a14="http://schemas.microsoft.com/office/drawing/2010/main" val="0"/>
-              </a:ext>
-            </a:extLst>
-          </a:blip>
-          <a:stretch>
-            <a:fillRect/>
-          </a:stretch>
-        </p:blipFill>
-        <p:spPr>
-          <a:xfrm>
-            <a:off x="6569983" y="2622767"/>
-            <a:ext cx="4184791" cy="4010877"/>
-          </a:xfrm>
-          <a:prstGeom prst="rect">
-            <a:avLst/>
-          </a:prstGeom>
-        </p:spPr>
-      </p:pic>
-    </p:spTree>
-    <p:extLst>
-      <p:ext uri="{BB962C8B-B14F-4D97-AF65-F5344CB8AC3E}">
-        <p14:creationId xmlns:p14="http://schemas.microsoft.com/office/powerpoint/2010/main" val="4109929243"/>
-      </p:ext>
-    </p:extLst>
-  </p:cSld>
-  <p:clrMapOvr>
-    <a:masterClrMapping/>
-  </p:clrMapOvr>
-</p:sld>
-</file>
-
-<file path=ppt/slides/slide11.xml><?xml version="1.0" encoding="utf-8"?>
-<p:sld xmlns:a="http://schemas.openxmlformats.org/drawingml/2006/main" xmlns:r="http://schemas.openxmlformats.org/officeDocument/2006/relationships" xmlns:p="http://schemas.openxmlformats.org/presentationml/2006/main">
-  <p:cSld>
-    <p:spTree>
-      <p:nvGrpSpPr>
-        <p:cNvPr id="1" name=""/>
-        <p:cNvGrpSpPr/>
-        <p:nvPr/>
-      </p:nvGrpSpPr>
-      <p:grpSpPr>
-        <a:xfrm>
-          <a:off x="0" y="0"/>
-          <a:ext cx="0" cy="0"/>
-          <a:chOff x="0" y="0"/>
-          <a:chExt cx="0" cy="0"/>
-        </a:xfrm>
-      </p:grpSpPr>
-      <p:pic>
-        <p:nvPicPr>
-          <p:cNvPr id="4" name="Picture 3">
-            <a:extLst>
-              <a:ext uri="{FF2B5EF4-FFF2-40B4-BE49-F238E27FC236}">
-                <a16:creationId xmlns:a16="http://schemas.microsoft.com/office/drawing/2014/main" id="{703D765F-E034-C9FA-551E-0CA2E6E6B289}"/>
-              </a:ext>
-            </a:extLst>
-          </p:cNvPr>
-          <p:cNvPicPr>
-            <a:picLocks noChangeAspect="1"/>
-          </p:cNvPicPr>
-          <p:nvPr/>
-        </p:nvPicPr>
-        <p:blipFill>
-          <a:blip r:embed="rId2">
-            <a:extLst>
-              <a:ext uri="{28A0092B-C50C-407E-A947-70E740481C1C}">
-                <a14:useLocalDpi xmlns:a14="http://schemas.microsoft.com/office/drawing/2010/main" val="0"/>
-              </a:ext>
-            </a:extLst>
-          </a:blip>
-          <a:stretch>
-            <a:fillRect/>
-          </a:stretch>
-        </p:blipFill>
-        <p:spPr>
-          <a:xfrm>
-            <a:off x="0" y="0"/>
-            <a:ext cx="12192000" cy="6858000"/>
-          </a:xfrm>
-          <a:prstGeom prst="rect">
-            <a:avLst/>
-          </a:prstGeom>
-        </p:spPr>
-      </p:pic>
-      <p:sp>
-        <p:nvSpPr>
-          <p:cNvPr id="2" name="Title 1">
-            <a:extLst>
-              <a:ext uri="{FF2B5EF4-FFF2-40B4-BE49-F238E27FC236}">
-                <a16:creationId xmlns:a16="http://schemas.microsoft.com/office/drawing/2014/main" id="{7071D7AD-DA65-6B8B-1F47-2D014A9CE896}"/>
-              </a:ext>
-            </a:extLst>
-          </p:cNvPr>
-          <p:cNvSpPr>
-            <a:spLocks noGrp="1"/>
-          </p:cNvSpPr>
-          <p:nvPr>
-            <p:ph type="title"/>
-          </p:nvPr>
-        </p:nvSpPr>
-        <p:spPr/>
-        <p:txBody>
-          <a:bodyPr/>
-          <a:lstStyle/>
-          <a:p>
-            <a:r>
-              <a:rPr lang="en-AU" dirty="0"/>
-              <a:t>Rubin, LSST and Fink </a:t>
-            </a:r>
-          </a:p>
-        </p:txBody>
-      </p:sp>
-      <p:sp>
-        <p:nvSpPr>
-          <p:cNvPr id="3" name="Content Placeholder 2">
-            <a:extLst>
-              <a:ext uri="{FF2B5EF4-FFF2-40B4-BE49-F238E27FC236}">
-                <a16:creationId xmlns:a16="http://schemas.microsoft.com/office/drawing/2014/main" id="{2C9A65E8-15EF-C574-A4E0-B2D7BCAF3F4D}"/>
-              </a:ext>
-            </a:extLst>
-          </p:cNvPr>
-          <p:cNvSpPr>
-            <a:spLocks noGrp="1"/>
-          </p:cNvSpPr>
-          <p:nvPr>
-            <p:ph idx="1"/>
-          </p:nvPr>
-        </p:nvSpPr>
-        <p:spPr>
-          <a:xfrm>
-            <a:off x="838200" y="1825625"/>
-            <a:ext cx="10125456" cy="4351338"/>
-          </a:xfrm>
-        </p:spPr>
-        <p:txBody>
-          <a:bodyPr/>
-          <a:lstStyle/>
-          <a:p>
-            <a:r>
-              <a:rPr lang="en-AU" dirty="0"/>
-              <a:t>With Rubin and LSST producing 10 million alerts per night, the chances of finding </a:t>
-            </a:r>
-            <a:r>
-              <a:rPr lang="en-AU" dirty="0" err="1"/>
-              <a:t>EEx</a:t>
-            </a:r>
-            <a:r>
-              <a:rPr lang="en-AU" dirty="0"/>
-              <a:t> SNe Ia are better than they ever have been!</a:t>
-            </a:r>
-          </a:p>
-          <a:p>
-            <a:pPr marL="0" indent="0">
-              <a:buNone/>
-            </a:pPr>
-            <a:endParaRPr lang="en-AU" dirty="0"/>
-          </a:p>
-        </p:txBody>
-      </p:sp>
-      <p:pic>
-        <p:nvPicPr>
-          <p:cNvPr id="6" name="Picture 5">
-            <a:extLst>
-              <a:ext uri="{FF2B5EF4-FFF2-40B4-BE49-F238E27FC236}">
-                <a16:creationId xmlns:a16="http://schemas.microsoft.com/office/drawing/2014/main" id="{AC25E318-1D6E-01A5-9B6C-771FCE8F5B6E}"/>
-              </a:ext>
-            </a:extLst>
-          </p:cNvPr>
-          <p:cNvPicPr>
-            <a:picLocks noChangeAspect="1"/>
-          </p:cNvPicPr>
-          <p:nvPr/>
-        </p:nvPicPr>
-        <p:blipFill>
-          <a:blip r:embed="rId3">
-            <a:extLst>
-              <a:ext uri="{28A0092B-C50C-407E-A947-70E740481C1C}">
-                <a14:useLocalDpi xmlns:a14="http://schemas.microsoft.com/office/drawing/2010/main" val="0"/>
-              </a:ext>
-            </a:extLst>
-          </a:blip>
-          <a:stretch>
-            <a:fillRect/>
-          </a:stretch>
-        </p:blipFill>
-        <p:spPr>
-          <a:xfrm>
-            <a:off x="3500928" y="2749553"/>
-            <a:ext cx="5190144" cy="3793902"/>
-          </a:xfrm>
-          <a:prstGeom prst="rect">
-            <a:avLst/>
-          </a:prstGeom>
-        </p:spPr>
-      </p:pic>
-    </p:spTree>
-    <p:extLst>
-      <p:ext uri="{BB962C8B-B14F-4D97-AF65-F5344CB8AC3E}">
-        <p14:creationId xmlns:p14="http://schemas.microsoft.com/office/powerpoint/2010/main" val="643775713"/>
-      </p:ext>
-    </p:extLst>
-  </p:cSld>
-  <p:clrMapOvr>
-    <a:masterClrMapping/>
-  </p:clrMapOvr>
-</p:sld>
-</file>
-
-<file path=ppt/slides/slide12.xml><?xml version="1.0" encoding="utf-8"?>
-<p:sld xmlns:a="http://schemas.openxmlformats.org/drawingml/2006/main" xmlns:r="http://schemas.openxmlformats.org/officeDocument/2006/relationships" xmlns:p="http://schemas.openxmlformats.org/presentationml/2006/main">
-  <p:cSld>
-    <p:spTree>
-      <p:nvGrpSpPr>
-        <p:cNvPr id="1" name=""/>
-        <p:cNvGrpSpPr/>
-        <p:nvPr/>
-      </p:nvGrpSpPr>
-      <p:grpSpPr>
-        <a:xfrm>
-          <a:off x="0" y="0"/>
-          <a:ext cx="0" cy="0"/>
-          <a:chOff x="0" y="0"/>
-          <a:chExt cx="0" cy="0"/>
-        </a:xfrm>
-      </p:grpSpPr>
-      <p:pic>
-        <p:nvPicPr>
-          <p:cNvPr id="4" name="Picture 3">
-            <a:extLst>
-              <a:ext uri="{FF2B5EF4-FFF2-40B4-BE49-F238E27FC236}">
-                <a16:creationId xmlns:a16="http://schemas.microsoft.com/office/drawing/2014/main" id="{D87603D6-85A9-58B4-1F4C-A02ACFB1AF3B}"/>
-              </a:ext>
-            </a:extLst>
-          </p:cNvPr>
-          <p:cNvPicPr>
-            <a:picLocks noChangeAspect="1"/>
-          </p:cNvPicPr>
-          <p:nvPr/>
-        </p:nvPicPr>
-        <p:blipFill>
-          <a:blip r:embed="rId2">
-            <a:extLst>
-              <a:ext uri="{28A0092B-C50C-407E-A947-70E740481C1C}">
-                <a14:useLocalDpi xmlns:a14="http://schemas.microsoft.com/office/drawing/2010/main" val="0"/>
-              </a:ext>
-            </a:extLst>
-          </a:blip>
-          <a:stretch>
-            <a:fillRect/>
-          </a:stretch>
-        </p:blipFill>
-        <p:spPr>
-          <a:xfrm>
-            <a:off x="0" y="0"/>
-            <a:ext cx="12192000" cy="6858000"/>
-          </a:xfrm>
-          <a:prstGeom prst="rect">
-            <a:avLst/>
-          </a:prstGeom>
-        </p:spPr>
-      </p:pic>
-      <p:sp>
-        <p:nvSpPr>
-          <p:cNvPr id="2" name="Title 1">
-            <a:extLst>
-              <a:ext uri="{FF2B5EF4-FFF2-40B4-BE49-F238E27FC236}">
-                <a16:creationId xmlns:a16="http://schemas.microsoft.com/office/drawing/2014/main" id="{24DAD0EE-5A20-2929-24D4-776ECF2C9BA5}"/>
-              </a:ext>
-            </a:extLst>
-          </p:cNvPr>
-          <p:cNvSpPr>
-            <a:spLocks noGrp="1"/>
-          </p:cNvSpPr>
-          <p:nvPr>
-            <p:ph type="title"/>
-          </p:nvPr>
-        </p:nvSpPr>
-        <p:spPr/>
-        <p:txBody>
-          <a:bodyPr/>
-          <a:lstStyle/>
-          <a:p>
-            <a:r>
-              <a:rPr lang="en-AU" dirty="0"/>
-              <a:t>Aims</a:t>
-            </a:r>
-          </a:p>
-        </p:txBody>
-      </p:sp>
-      <p:sp>
-        <p:nvSpPr>
-          <p:cNvPr id="3" name="Content Placeholder 2">
-            <a:extLst>
-              <a:ext uri="{FF2B5EF4-FFF2-40B4-BE49-F238E27FC236}">
-                <a16:creationId xmlns:a16="http://schemas.microsoft.com/office/drawing/2014/main" id="{5DB9041A-8BE0-4984-F4FD-5191EB1FC8C3}"/>
-              </a:ext>
-            </a:extLst>
-          </p:cNvPr>
-          <p:cNvSpPr>
-            <a:spLocks noGrp="1"/>
-          </p:cNvSpPr>
-          <p:nvPr>
-            <p:ph idx="1"/>
-          </p:nvPr>
-        </p:nvSpPr>
-        <p:spPr/>
-        <p:txBody>
-          <a:bodyPr/>
-          <a:lstStyle/>
-          <a:p>
-            <a:r>
-              <a:rPr lang="en-AU" dirty="0"/>
-              <a:t>To detect and classify the early excess flux SNe Ia and investigate incidence rate as a function of host galaxy properties such as stellar mass, </a:t>
-            </a:r>
-            <a:r>
-              <a:rPr lang="en-AU" dirty="0" err="1"/>
-              <a:t>sSFR</a:t>
-            </a:r>
-            <a:r>
-              <a:rPr lang="en-AU" dirty="0"/>
-              <a:t> and colour. </a:t>
-            </a:r>
-          </a:p>
-          <a:p>
-            <a:pPr marL="0" indent="0">
-              <a:buNone/>
-            </a:pPr>
-            <a:endParaRPr lang="en-AU" dirty="0"/>
-          </a:p>
-        </p:txBody>
-      </p:sp>
-    </p:spTree>
-    <p:extLst>
-      <p:ext uri="{BB962C8B-B14F-4D97-AF65-F5344CB8AC3E}">
-        <p14:creationId xmlns:p14="http://schemas.microsoft.com/office/powerpoint/2010/main" val="101350449"/>
-      </p:ext>
-    </p:extLst>
-  </p:cSld>
-  <p:clrMapOvr>
-    <a:masterClrMapping/>
-  </p:clrMapOvr>
-</p:sld>
-</file>
-
-<file path=ppt/slides/slide13.xml><?xml version="1.0" encoding="utf-8"?>
-<p:sld xmlns:a="http://schemas.openxmlformats.org/drawingml/2006/main" xmlns:r="http://schemas.openxmlformats.org/officeDocument/2006/relationships" xmlns:p="http://schemas.openxmlformats.org/presentationml/2006/main">
-  <p:cSld>
-    <p:spTree>
-      <p:nvGrpSpPr>
-        <p:cNvPr id="1" name=""/>
-        <p:cNvGrpSpPr/>
-        <p:nvPr/>
-      </p:nvGrpSpPr>
-      <p:grpSpPr>
-        <a:xfrm>
-          <a:off x="0" y="0"/>
-          <a:ext cx="0" cy="0"/>
-          <a:chOff x="0" y="0"/>
-          <a:chExt cx="0" cy="0"/>
-        </a:xfrm>
-      </p:grpSpPr>
-      <p:pic>
-        <p:nvPicPr>
-          <p:cNvPr id="4" name="Picture 3">
-            <a:extLst>
-              <a:ext uri="{FF2B5EF4-FFF2-40B4-BE49-F238E27FC236}">
-                <a16:creationId xmlns:a16="http://schemas.microsoft.com/office/drawing/2014/main" id="{8CF574DC-4061-64A8-AC59-2B0A2C2A1F6F}"/>
-              </a:ext>
-            </a:extLst>
-          </p:cNvPr>
-          <p:cNvPicPr>
-            <a:picLocks noChangeAspect="1"/>
-          </p:cNvPicPr>
-          <p:nvPr/>
-        </p:nvPicPr>
-        <p:blipFill>
-          <a:blip r:embed="rId2">
-            <a:extLst>
-              <a:ext uri="{28A0092B-C50C-407E-A947-70E740481C1C}">
-                <a14:useLocalDpi xmlns:a14="http://schemas.microsoft.com/office/drawing/2010/main" val="0"/>
-              </a:ext>
-            </a:extLst>
-          </a:blip>
-          <a:stretch>
-            <a:fillRect/>
-          </a:stretch>
-        </p:blipFill>
-        <p:spPr>
-          <a:xfrm>
-            <a:off x="0" y="0"/>
-            <a:ext cx="12192000" cy="6858000"/>
-          </a:xfrm>
-          <a:prstGeom prst="rect">
-            <a:avLst/>
-          </a:prstGeom>
-        </p:spPr>
-      </p:pic>
-      <p:sp>
-        <p:nvSpPr>
-          <p:cNvPr id="2" name="Title 1">
-            <a:extLst>
-              <a:ext uri="{FF2B5EF4-FFF2-40B4-BE49-F238E27FC236}">
-                <a16:creationId xmlns:a16="http://schemas.microsoft.com/office/drawing/2014/main" id="{E1D5E06E-FEB0-5583-C474-C6291C4A628C}"/>
-              </a:ext>
-            </a:extLst>
-          </p:cNvPr>
-          <p:cNvSpPr>
-            <a:spLocks noGrp="1"/>
-          </p:cNvSpPr>
-          <p:nvPr>
-            <p:ph type="title"/>
-          </p:nvPr>
-        </p:nvSpPr>
-        <p:spPr/>
-        <p:txBody>
-          <a:bodyPr/>
-          <a:lstStyle/>
-          <a:p>
-            <a:r>
-              <a:rPr lang="en-AU" dirty="0"/>
-              <a:t>Planned Method</a:t>
-            </a:r>
-          </a:p>
-        </p:txBody>
-      </p:sp>
-      <p:sp>
-        <p:nvSpPr>
-          <p:cNvPr id="3" name="Content Placeholder 2">
-            <a:extLst>
-              <a:ext uri="{FF2B5EF4-FFF2-40B4-BE49-F238E27FC236}">
-                <a16:creationId xmlns:a16="http://schemas.microsoft.com/office/drawing/2014/main" id="{0DE6BE5B-DA27-4C06-E559-3561B9464E7E}"/>
-              </a:ext>
-            </a:extLst>
-          </p:cNvPr>
-          <p:cNvSpPr>
-            <a:spLocks noGrp="1"/>
-          </p:cNvSpPr>
-          <p:nvPr>
-            <p:ph idx="1"/>
-          </p:nvPr>
-        </p:nvSpPr>
-        <p:spPr>
-          <a:xfrm>
-            <a:off x="838200" y="1825625"/>
-            <a:ext cx="9110472" cy="4351338"/>
-          </a:xfrm>
-        </p:spPr>
-        <p:txBody>
-          <a:bodyPr>
-            <a:normAutofit/>
-          </a:bodyPr>
-          <a:lstStyle/>
-          <a:p>
-            <a:r>
-              <a:rPr lang="en-AU" dirty="0"/>
-              <a:t>Use Fink to gather the sample of early excess flux candidates for Ias.</a:t>
-            </a:r>
-          </a:p>
-          <a:p>
-            <a:r>
-              <a:rPr lang="en-AU" dirty="0"/>
-              <a:t>Using SALT3 light curve fitting model to correct for stretch and colour and identify SNe. Using residuals method from Deckers et al., 2022 to find </a:t>
-            </a:r>
-            <a:r>
-              <a:rPr lang="en-AU" dirty="0" err="1"/>
-              <a:t>Eex</a:t>
-            </a:r>
-            <a:r>
-              <a:rPr lang="en-AU" dirty="0"/>
-              <a:t>.</a:t>
-            </a:r>
-          </a:p>
-          <a:p>
-            <a:r>
-              <a:rPr lang="en-AU" dirty="0"/>
-              <a:t>Host matching using DLR method to determine the hosts of the samples SNe Ia.</a:t>
-            </a:r>
-          </a:p>
-          <a:p>
-            <a:r>
-              <a:rPr lang="en-AU" dirty="0"/>
-              <a:t>Binning of </a:t>
-            </a:r>
-            <a:r>
-              <a:rPr lang="en-AU" dirty="0" err="1"/>
-              <a:t>EEx</a:t>
-            </a:r>
-            <a:r>
-              <a:rPr lang="en-AU" dirty="0"/>
-              <a:t> SNe Ia against host galaxy mass, DLR, colour and SFR to determine how </a:t>
-            </a:r>
-            <a:r>
-              <a:rPr lang="en-AU" dirty="0" err="1"/>
-              <a:t>Eex</a:t>
-            </a:r>
-            <a:r>
-              <a:rPr lang="en-AU" dirty="0"/>
-              <a:t> SNe Ia trend with these features.</a:t>
-            </a:r>
-          </a:p>
-          <a:p>
-            <a:pPr marL="0" indent="0">
-              <a:buNone/>
-            </a:pPr>
-            <a:endParaRPr lang="en-AU" dirty="0"/>
-          </a:p>
-        </p:txBody>
-      </p:sp>
-    </p:spTree>
-    <p:extLst>
-      <p:ext uri="{BB962C8B-B14F-4D97-AF65-F5344CB8AC3E}">
-        <p14:creationId xmlns:p14="http://schemas.microsoft.com/office/powerpoint/2010/main" val="2898617131"/>
-      </p:ext>
-    </p:extLst>
-  </p:cSld>
-  <p:clrMapOvr>
-    <a:masterClrMapping/>
-  </p:clrMapOvr>
-</p:sld>
-</file>
-
 <file path=ppt/slides/slide2.xml><?xml version="1.0" encoding="utf-8"?>
 <p:sld xmlns:a="http://schemas.openxmlformats.org/drawingml/2006/main" xmlns:r="http://schemas.openxmlformats.org/officeDocument/2006/relationships" xmlns:p="http://schemas.openxmlformats.org/presentationml/2006/main">
   <p:cSld>
@@ -4606,7 +3907,7 @@
           <a:p>
             <a:r>
               <a:rPr lang="en-AU" dirty="0"/>
-              <a:t>Introduction	</a:t>
+              <a:t>Rubin and LSST</a:t>
             </a:r>
           </a:p>
         </p:txBody>
@@ -4641,7 +3942,41 @@
           <a:p>
             <a:r>
               <a:rPr lang="en-AU" dirty="0"/>
-              <a:t>SNe Ia are standardizable candles.</a:t>
+              <a:t>Rubin telescope</a:t>
+            </a:r>
+          </a:p>
+          <a:p>
+            <a:pPr lvl="1"/>
+            <a:r>
+              <a:rPr lang="en-AU" dirty="0"/>
+              <a:t>8.36 metre aperture</a:t>
+            </a:r>
+          </a:p>
+          <a:p>
+            <a:pPr lvl="1"/>
+            <a:r>
+              <a:rPr lang="en-AU" dirty="0"/>
+              <a:t>320.5 – 1084.5 nm</a:t>
+            </a:r>
+          </a:p>
+          <a:p>
+            <a:r>
+              <a:rPr lang="en-AU" dirty="0"/>
+              <a:t>LSST</a:t>
+            </a:r>
+          </a:p>
+          <a:p>
+            <a:pPr lvl="1"/>
+            <a:r>
+              <a:rPr lang="en-AU" dirty="0"/>
+              <a:t>Observe the southern skies</a:t>
+            </a:r>
+          </a:p>
+          <a:p>
+            <a:pPr lvl="1"/>
+            <a:r>
+              <a:rPr lang="en-AU" dirty="0"/>
+              <a:t>Produce 10 million alerts per night</a:t>
             </a:r>
           </a:p>
           <a:p>
@@ -4659,8 +3994,134 @@
           <a:p>
             <a:endParaRPr lang="en-AU" dirty="0"/>
           </a:p>
-          <a:p>
+        </p:txBody>
+      </p:sp>
+      <p:pic>
+        <p:nvPicPr>
+          <p:cNvPr id="8" name="Picture 7">
+            <a:extLst>
+              <a:ext uri="{FF2B5EF4-FFF2-40B4-BE49-F238E27FC236}">
+                <a16:creationId xmlns:a16="http://schemas.microsoft.com/office/drawing/2014/main" id="{C75D2F58-A7DC-DC31-6926-E1EBF5798064}"/>
+              </a:ext>
+            </a:extLst>
+          </p:cNvPr>
+          <p:cNvPicPr>
+            <a:picLocks noChangeAspect="1"/>
+          </p:cNvPicPr>
+          <p:nvPr/>
+        </p:nvPicPr>
+        <p:blipFill>
+          <a:blip r:embed="rId3">
+            <a:extLst>
+              <a:ext uri="{28A0092B-C50C-407E-A947-70E740481C1C}">
+                <a14:useLocalDpi xmlns:a14="http://schemas.microsoft.com/office/drawing/2010/main" val="0"/>
+              </a:ext>
+            </a:extLst>
+          </a:blip>
+          <a:stretch>
+            <a:fillRect/>
+          </a:stretch>
+        </p:blipFill>
+        <p:spPr>
+          <a:xfrm>
+            <a:off x="6909837" y="454969"/>
+            <a:ext cx="4925246" cy="3285149"/>
+          </a:xfrm>
+          <a:prstGeom prst="rect">
+            <a:avLst/>
+          </a:prstGeom>
+          <a:ln w="38100" cap="sq">
+            <a:solidFill>
+              <a:srgbClr val="000000"/>
+            </a:solidFill>
+            <a:prstDash val="solid"/>
+            <a:miter lim="800000"/>
+          </a:ln>
+          <a:effectLst>
+            <a:outerShdw blurRad="50800" dist="38100" dir="2700000" algn="tl" rotWithShape="0">
+              <a:srgbClr val="000000">
+                <a:alpha val="43000"/>
+              </a:srgbClr>
+            </a:outerShdw>
+          </a:effectLst>
+        </p:spPr>
+      </p:pic>
+      <p:sp>
+        <p:nvSpPr>
+          <p:cNvPr id="11" name="TextBox 10">
+            <a:extLst>
+              <a:ext uri="{FF2B5EF4-FFF2-40B4-BE49-F238E27FC236}">
+                <a16:creationId xmlns:a16="http://schemas.microsoft.com/office/drawing/2014/main" id="{91F87463-4370-B4F5-82EC-5A5B25200CA3}"/>
+              </a:ext>
+            </a:extLst>
+          </p:cNvPr>
+          <p:cNvSpPr txBox="1"/>
+          <p:nvPr/>
+        </p:nvSpPr>
+        <p:spPr>
+          <a:xfrm>
+            <a:off x="6909837" y="3740118"/>
+            <a:ext cx="6137500" cy="369332"/>
+          </a:xfrm>
+          <a:prstGeom prst="rect">
+            <a:avLst/>
+          </a:prstGeom>
+          <a:noFill/>
+        </p:spPr>
+        <p:txBody>
+          <a:bodyPr wrap="square">
+            <a:spAutoFit/>
+          </a:bodyPr>
+          <a:lstStyle/>
+          <a:p>
+            <a:r>
+              <a:rPr lang="en-US" dirty="0"/>
+              <a:t>(</a:t>
+            </a:r>
+            <a:r>
+              <a:rPr lang="en-US" i="1" dirty="0"/>
+              <a:t>Vera C. Rubin Press Release</a:t>
+            </a:r>
+            <a:r>
+              <a:rPr lang="en-US" dirty="0"/>
+              <a:t>)</a:t>
+            </a:r>
             <a:endParaRPr lang="en-AU" dirty="0"/>
+          </a:p>
+        </p:txBody>
+      </p:sp>
+      <p:sp>
+        <p:nvSpPr>
+          <p:cNvPr id="13" name="TextBox 12">
+            <a:extLst>
+              <a:ext uri="{FF2B5EF4-FFF2-40B4-BE49-F238E27FC236}">
+                <a16:creationId xmlns:a16="http://schemas.microsoft.com/office/drawing/2014/main" id="{084EF079-0519-A5D9-553D-186230724062}"/>
+              </a:ext>
+            </a:extLst>
+          </p:cNvPr>
+          <p:cNvSpPr txBox="1"/>
+          <p:nvPr/>
+        </p:nvSpPr>
+        <p:spPr>
+          <a:xfrm>
+            <a:off x="191861" y="6335814"/>
+            <a:ext cx="308098" cy="369332"/>
+          </a:xfrm>
+          <a:prstGeom prst="rect">
+            <a:avLst/>
+          </a:prstGeom>
+          <a:noFill/>
+        </p:spPr>
+        <p:txBody>
+          <a:bodyPr wrap="none" rtlCol="0">
+            <a:spAutoFit/>
+          </a:bodyPr>
+          <a:lstStyle/>
+          <a:p>
+            <a:r>
+              <a:rPr lang="en-AU" dirty="0"/>
+              <a:t>1</a:t>
+            </a:r>
           </a:p>
         </p:txBody>
       </p:sp>
@@ -4678,6 +4139,320 @@
 </file>
 
 <file path=ppt/slides/slide3.xml><?xml version="1.0" encoding="utf-8"?>
+<p:sld xmlns:a="http://schemas.openxmlformats.org/drawingml/2006/main" xmlns:r="http://schemas.openxmlformats.org/officeDocument/2006/relationships" xmlns:p="http://schemas.openxmlformats.org/presentationml/2006/main">
+  <p:cSld>
+    <p:spTree>
+      <p:nvGrpSpPr>
+        <p:cNvPr id="1" name="">
+          <a:extLst>
+            <a:ext uri="{FF2B5EF4-FFF2-40B4-BE49-F238E27FC236}">
+              <a16:creationId xmlns:a16="http://schemas.microsoft.com/office/drawing/2014/main" id="{92D40D70-0B87-C718-C1F3-DBAEDA575E75}"/>
+            </a:ext>
+          </a:extLst>
+        </p:cNvPr>
+        <p:cNvGrpSpPr/>
+        <p:nvPr/>
+      </p:nvGrpSpPr>
+      <p:grpSpPr>
+        <a:xfrm>
+          <a:off x="0" y="0"/>
+          <a:ext cx="0" cy="0"/>
+          <a:chOff x="0" y="0"/>
+          <a:chExt cx="0" cy="0"/>
+        </a:xfrm>
+      </p:grpSpPr>
+      <p:pic>
+        <p:nvPicPr>
+          <p:cNvPr id="4" name="Picture 3">
+            <a:extLst>
+              <a:ext uri="{FF2B5EF4-FFF2-40B4-BE49-F238E27FC236}">
+                <a16:creationId xmlns:a16="http://schemas.microsoft.com/office/drawing/2014/main" id="{813A4E71-8744-2022-9278-0C2494916B99}"/>
+              </a:ext>
+            </a:extLst>
+          </p:cNvPr>
+          <p:cNvPicPr>
+            <a:picLocks noChangeAspect="1"/>
+          </p:cNvPicPr>
+          <p:nvPr/>
+        </p:nvPicPr>
+        <p:blipFill>
+          <a:blip r:embed="rId2">
+            <a:extLst>
+              <a:ext uri="{28A0092B-C50C-407E-A947-70E740481C1C}">
+                <a14:useLocalDpi xmlns:a14="http://schemas.microsoft.com/office/drawing/2010/main" val="0"/>
+              </a:ext>
+            </a:extLst>
+          </a:blip>
+          <a:stretch>
+            <a:fillRect/>
+          </a:stretch>
+        </p:blipFill>
+        <p:spPr>
+          <a:xfrm>
+            <a:off x="0" y="0"/>
+            <a:ext cx="12192000" cy="6858000"/>
+          </a:xfrm>
+          <a:prstGeom prst="rect">
+            <a:avLst/>
+          </a:prstGeom>
+        </p:spPr>
+      </p:pic>
+      <p:sp>
+        <p:nvSpPr>
+          <p:cNvPr id="2" name="Title 1">
+            <a:extLst>
+              <a:ext uri="{FF2B5EF4-FFF2-40B4-BE49-F238E27FC236}">
+                <a16:creationId xmlns:a16="http://schemas.microsoft.com/office/drawing/2014/main" id="{379E3798-863F-D885-70AC-276D7107990C}"/>
+              </a:ext>
+            </a:extLst>
+          </p:cNvPr>
+          <p:cNvSpPr>
+            <a:spLocks noGrp="1"/>
+          </p:cNvSpPr>
+          <p:nvPr>
+            <p:ph type="title"/>
+          </p:nvPr>
+        </p:nvSpPr>
+        <p:spPr/>
+        <p:txBody>
+          <a:bodyPr/>
+          <a:lstStyle/>
+          <a:p>
+            <a:r>
+              <a:rPr lang="en-AU" dirty="0"/>
+              <a:t>What are SN Ia?</a:t>
+            </a:r>
+          </a:p>
+        </p:txBody>
+      </p:sp>
+      <p:sp>
+        <p:nvSpPr>
+          <p:cNvPr id="3" name="Content Placeholder 2">
+            <a:extLst>
+              <a:ext uri="{FF2B5EF4-FFF2-40B4-BE49-F238E27FC236}">
+                <a16:creationId xmlns:a16="http://schemas.microsoft.com/office/drawing/2014/main" id="{D5FC0C8F-ED85-53D4-6C92-BCEC969B49A1}"/>
+              </a:ext>
+            </a:extLst>
+          </p:cNvPr>
+          <p:cNvSpPr>
+            <a:spLocks noGrp="1"/>
+          </p:cNvSpPr>
+          <p:nvPr>
+            <p:ph idx="1"/>
+          </p:nvPr>
+        </p:nvSpPr>
+        <p:spPr>
+          <a:xfrm>
+            <a:off x="838200" y="1825625"/>
+            <a:ext cx="9787128" cy="4351338"/>
+          </a:xfrm>
+        </p:spPr>
+        <p:txBody>
+          <a:bodyPr>
+            <a:normAutofit/>
+          </a:bodyPr>
+          <a:lstStyle/>
+          <a:p>
+            <a:r>
+              <a:rPr lang="en-AU" dirty="0"/>
+              <a:t>The explosion of a carbon-oxygen white dwarf </a:t>
+            </a:r>
+          </a:p>
+        </p:txBody>
+      </p:sp>
+      <p:pic>
+        <p:nvPicPr>
+          <p:cNvPr id="7" name="Picture 6">
+            <a:extLst>
+              <a:ext uri="{FF2B5EF4-FFF2-40B4-BE49-F238E27FC236}">
+                <a16:creationId xmlns:a16="http://schemas.microsoft.com/office/drawing/2014/main" id="{01EBE7C4-380F-2218-8852-1D66F8B826CF}"/>
+              </a:ext>
+            </a:extLst>
+          </p:cNvPr>
+          <p:cNvPicPr>
+            <a:picLocks noChangeAspect="1"/>
+          </p:cNvPicPr>
+          <p:nvPr/>
+        </p:nvPicPr>
+        <p:blipFill>
+          <a:blip r:embed="rId3">
+            <a:extLst>
+              <a:ext uri="{28A0092B-C50C-407E-A947-70E740481C1C}">
+                <a14:useLocalDpi xmlns:a14="http://schemas.microsoft.com/office/drawing/2010/main" val="0"/>
+              </a:ext>
+            </a:extLst>
+          </a:blip>
+          <a:stretch>
+            <a:fillRect/>
+          </a:stretch>
+        </p:blipFill>
+        <p:spPr>
+          <a:xfrm>
+            <a:off x="838200" y="2952908"/>
+            <a:ext cx="5019582" cy="2642872"/>
+          </a:xfrm>
+          <a:prstGeom prst="rect">
+            <a:avLst/>
+          </a:prstGeom>
+          <a:ln w="38100" cap="sq">
+            <a:solidFill>
+              <a:srgbClr val="000000"/>
+            </a:solidFill>
+            <a:prstDash val="solid"/>
+            <a:miter lim="800000"/>
+          </a:ln>
+          <a:effectLst>
+            <a:outerShdw blurRad="50800" dist="38100" dir="2700000" algn="tl" rotWithShape="0">
+              <a:srgbClr val="000000">
+                <a:alpha val="43000"/>
+              </a:srgbClr>
+            </a:outerShdw>
+          </a:effectLst>
+        </p:spPr>
+      </p:pic>
+      <p:pic>
+        <p:nvPicPr>
+          <p:cNvPr id="11" name="Picture 10">
+            <a:extLst>
+              <a:ext uri="{FF2B5EF4-FFF2-40B4-BE49-F238E27FC236}">
+                <a16:creationId xmlns:a16="http://schemas.microsoft.com/office/drawing/2014/main" id="{962BFC33-D111-E9FF-33B4-BC6275A9A9A6}"/>
+              </a:ext>
+            </a:extLst>
+          </p:cNvPr>
+          <p:cNvPicPr>
+            <a:picLocks noChangeAspect="1"/>
+          </p:cNvPicPr>
+          <p:nvPr/>
+        </p:nvPicPr>
+        <p:blipFill>
+          <a:blip r:embed="rId4">
+            <a:extLst>
+              <a:ext uri="{28A0092B-C50C-407E-A947-70E740481C1C}">
+                <a14:useLocalDpi xmlns:a14="http://schemas.microsoft.com/office/drawing/2010/main" val="0"/>
+              </a:ext>
+            </a:extLst>
+          </a:blip>
+          <a:stretch>
+            <a:fillRect/>
+          </a:stretch>
+        </p:blipFill>
+        <p:spPr>
+          <a:xfrm>
+            <a:off x="6254273" y="2952908"/>
+            <a:ext cx="5099527" cy="2679737"/>
+          </a:xfrm>
+          <a:prstGeom prst="rect">
+            <a:avLst/>
+          </a:prstGeom>
+          <a:ln w="38100" cap="sq">
+            <a:solidFill>
+              <a:srgbClr val="000000"/>
+            </a:solidFill>
+            <a:prstDash val="solid"/>
+            <a:miter lim="800000"/>
+          </a:ln>
+          <a:effectLst>
+            <a:outerShdw blurRad="50800" dist="38100" dir="2700000" algn="tl" rotWithShape="0">
+              <a:srgbClr val="000000">
+                <a:alpha val="43000"/>
+              </a:srgbClr>
+            </a:outerShdw>
+          </a:effectLst>
+        </p:spPr>
+      </p:pic>
+      <p:sp>
+        <p:nvSpPr>
+          <p:cNvPr id="13" name="TextBox 12">
+            <a:extLst>
+              <a:ext uri="{FF2B5EF4-FFF2-40B4-BE49-F238E27FC236}">
+                <a16:creationId xmlns:a16="http://schemas.microsoft.com/office/drawing/2014/main" id="{4B657402-F4AB-F510-FFAB-F326178340DC}"/>
+              </a:ext>
+            </a:extLst>
+          </p:cNvPr>
+          <p:cNvSpPr txBox="1"/>
+          <p:nvPr/>
+        </p:nvSpPr>
+        <p:spPr>
+          <a:xfrm>
+            <a:off x="838200" y="5632645"/>
+            <a:ext cx="6137500" cy="369332"/>
+          </a:xfrm>
+          <a:prstGeom prst="rect">
+            <a:avLst/>
+          </a:prstGeom>
+          <a:noFill/>
+        </p:spPr>
+        <p:txBody>
+          <a:bodyPr wrap="square">
+            <a:spAutoFit/>
+          </a:bodyPr>
+          <a:lstStyle/>
+          <a:p>
+            <a:r>
+              <a:rPr lang="en-US" dirty="0"/>
+              <a:t>(</a:t>
+            </a:r>
+            <a:r>
+              <a:rPr lang="en-US" i="1" dirty="0"/>
+              <a:t>NASA Image and Video Library</a:t>
+            </a:r>
+            <a:r>
+              <a:rPr lang="en-US" dirty="0"/>
+              <a:t>)</a:t>
+            </a:r>
+            <a:endParaRPr lang="en-AU" dirty="0"/>
+          </a:p>
+        </p:txBody>
+      </p:sp>
+      <p:sp>
+        <p:nvSpPr>
+          <p:cNvPr id="15" name="TextBox 14">
+            <a:extLst>
+              <a:ext uri="{FF2B5EF4-FFF2-40B4-BE49-F238E27FC236}">
+                <a16:creationId xmlns:a16="http://schemas.microsoft.com/office/drawing/2014/main" id="{C7C16CC8-A628-4A09-A9AA-48BFE6708A7A}"/>
+              </a:ext>
+            </a:extLst>
+          </p:cNvPr>
+          <p:cNvSpPr txBox="1"/>
+          <p:nvPr/>
+        </p:nvSpPr>
+        <p:spPr>
+          <a:xfrm>
+            <a:off x="191861" y="6335814"/>
+            <a:ext cx="308098" cy="369332"/>
+          </a:xfrm>
+          <a:prstGeom prst="rect">
+            <a:avLst/>
+          </a:prstGeom>
+          <a:noFill/>
+        </p:spPr>
+        <p:txBody>
+          <a:bodyPr wrap="none" rtlCol="0">
+            <a:spAutoFit/>
+          </a:bodyPr>
+          <a:lstStyle/>
+          <a:p>
+            <a:r>
+              <a:rPr lang="en-AU" dirty="0"/>
+              <a:t>2</a:t>
+            </a:r>
+          </a:p>
+        </p:txBody>
+      </p:sp>
+    </p:spTree>
+    <p:extLst>
+      <p:ext uri="{BB962C8B-B14F-4D97-AF65-F5344CB8AC3E}">
+        <p14:creationId xmlns:p14="http://schemas.microsoft.com/office/powerpoint/2010/main" val="3620831151"/>
+      </p:ext>
+    </p:extLst>
+  </p:cSld>
+  <p:clrMapOvr>
+    <a:masterClrMapping/>
+  </p:clrMapOvr>
+</p:sld>
+</file>
+
+<file path=ppt/slides/slide4.xml><?xml version="1.0" encoding="utf-8"?>
 <p:sld xmlns:a="http://schemas.openxmlformats.org/drawingml/2006/main" xmlns:r="http://schemas.openxmlformats.org/officeDocument/2006/relationships" xmlns:p="http://schemas.openxmlformats.org/presentationml/2006/main">
   <p:cSld>
     <p:spTree>
@@ -4759,7 +4534,7 @@
           <a:p>
             <a:r>
               <a:rPr lang="en-AU" dirty="0"/>
-              <a:t>Introduction	</a:t>
+              <a:t>SNe Ia – Why?</a:t>
             </a:r>
           </a:p>
         </p:txBody>
@@ -4794,8 +4569,11 @@
           <a:p>
             <a:r>
               <a:rPr lang="en-AU" dirty="0"/>
-              <a:t>SNe Ia are standardizable candles.</a:t>
-            </a:r>
+              <a:t>SNe Ia are standardizable candles</a:t>
+            </a:r>
+          </a:p>
+          <a:p>
+            <a:endParaRPr lang="en-AU" dirty="0"/>
           </a:p>
           <a:p>
             <a:endParaRPr lang="en-AU" dirty="0"/>
@@ -4819,10 +4597,10 @@
       </p:sp>
       <p:pic>
         <p:nvPicPr>
-          <p:cNvPr id="6" name="Picture 5">
-            <a:extLst>
-              <a:ext uri="{FF2B5EF4-FFF2-40B4-BE49-F238E27FC236}">
-                <a16:creationId xmlns:a16="http://schemas.microsoft.com/office/drawing/2014/main" id="{500635EF-93ED-06E6-79FD-853142D2A0DD}"/>
+          <p:cNvPr id="10" name="Picture 9">
+            <a:extLst>
+              <a:ext uri="{FF2B5EF4-FFF2-40B4-BE49-F238E27FC236}">
+                <a16:creationId xmlns:a16="http://schemas.microsoft.com/office/drawing/2014/main" id="{61AA9387-B3C7-E5C2-543E-8228625B60FD}"/>
               </a:ext>
             </a:extLst>
           </p:cNvPr>
@@ -4832,21 +4610,15 @@
           <p:nvPr/>
         </p:nvPicPr>
         <p:blipFill>
-          <a:blip r:embed="rId3">
-            <a:extLst>
-              <a:ext uri="{28A0092B-C50C-407E-A947-70E740481C1C}">
-                <a14:useLocalDpi xmlns:a14="http://schemas.microsoft.com/office/drawing/2010/main" val="0"/>
-              </a:ext>
-            </a:extLst>
-          </a:blip>
+          <a:blip r:embed="rId3"/>
           <a:stretch>
             <a:fillRect/>
           </a:stretch>
         </p:blipFill>
         <p:spPr>
           <a:xfrm>
-            <a:off x="3802280" y="2853257"/>
-            <a:ext cx="4401473" cy="2480413"/>
+            <a:off x="3620560" y="2365295"/>
+            <a:ext cx="4950879" cy="4020660"/>
           </a:xfrm>
           <a:prstGeom prst="rect">
             <a:avLst/>
@@ -4855,10 +4627,10 @@
       </p:pic>
       <p:sp>
         <p:nvSpPr>
-          <p:cNvPr id="8" name="TextBox 7">
-            <a:extLst>
-              <a:ext uri="{FF2B5EF4-FFF2-40B4-BE49-F238E27FC236}">
-                <a16:creationId xmlns:a16="http://schemas.microsoft.com/office/drawing/2014/main" id="{CEBDF837-8BAE-9C24-BAB1-BA1746C432FD}"/>
+          <p:cNvPr id="12" name="TextBox 11">
+            <a:extLst>
+              <a:ext uri="{FF2B5EF4-FFF2-40B4-BE49-F238E27FC236}">
+                <a16:creationId xmlns:a16="http://schemas.microsoft.com/office/drawing/2014/main" id="{EE6DD526-8938-C3DF-B2D7-128FAF5CF3DB}"/>
               </a:ext>
             </a:extLst>
           </p:cNvPr>
@@ -4867,8 +4639,8 @@
         </p:nvSpPr>
         <p:spPr>
           <a:xfrm>
-            <a:off x="3688819" y="5385984"/>
-            <a:ext cx="6136952" cy="369332"/>
+            <a:off x="3620560" y="6201289"/>
+            <a:ext cx="6095256" cy="369332"/>
           </a:xfrm>
           <a:prstGeom prst="rect">
             <a:avLst/>
@@ -4882,10 +4654,44 @@
           <a:lstStyle/>
           <a:p>
             <a:r>
-              <a:rPr lang="en-US"/>
-              <a:t>(“Accelerating Expansion of the Universe,” 2026)</a:t>
-            </a:r>
-            <a:endParaRPr lang="en-AU" dirty="0"/>
+              <a:rPr lang="en-AU" dirty="0"/>
+              <a:t>(Dado &amp; Dar, 2015.)</a:t>
+            </a:r>
+          </a:p>
+        </p:txBody>
+      </p:sp>
+      <p:sp>
+        <p:nvSpPr>
+          <p:cNvPr id="14" name="TextBox 13">
+            <a:extLst>
+              <a:ext uri="{FF2B5EF4-FFF2-40B4-BE49-F238E27FC236}">
+                <a16:creationId xmlns:a16="http://schemas.microsoft.com/office/drawing/2014/main" id="{F906453D-F20E-2620-BDDE-EF745CAC0B37}"/>
+              </a:ext>
+            </a:extLst>
+          </p:cNvPr>
+          <p:cNvSpPr txBox="1"/>
+          <p:nvPr/>
+        </p:nvSpPr>
+        <p:spPr>
+          <a:xfrm>
+            <a:off x="191861" y="6335814"/>
+            <a:ext cx="308098" cy="369332"/>
+          </a:xfrm>
+          <a:prstGeom prst="rect">
+            <a:avLst/>
+          </a:prstGeom>
+          <a:noFill/>
+        </p:spPr>
+        <p:txBody>
+          <a:bodyPr wrap="none" rtlCol="0">
+            <a:spAutoFit/>
+          </a:bodyPr>
+          <a:lstStyle/>
+          <a:p>
+            <a:r>
+              <a:rPr lang="en-AU" dirty="0"/>
+              <a:t>3</a:t>
+            </a:r>
           </a:p>
         </p:txBody>
       </p:sp>
@@ -4902,18 +4708,12 @@
 </p:sld>
 </file>
 
-<file path=ppt/slides/slide4.xml><?xml version="1.0" encoding="utf-8"?>
+<file path=ppt/slides/slide5.xml><?xml version="1.0" encoding="utf-8"?>
 <p:sld xmlns:a="http://schemas.openxmlformats.org/drawingml/2006/main" xmlns:r="http://schemas.openxmlformats.org/officeDocument/2006/relationships" xmlns:p="http://schemas.openxmlformats.org/presentationml/2006/main">
   <p:cSld>
     <p:spTree>
       <p:nvGrpSpPr>
-        <p:cNvPr id="1" name="">
-          <a:extLst>
-            <a:ext uri="{FF2B5EF4-FFF2-40B4-BE49-F238E27FC236}">
-              <a16:creationId xmlns:a16="http://schemas.microsoft.com/office/drawing/2014/main" id="{92D40D70-0B87-C718-C1F3-DBAEDA575E75}"/>
-            </a:ext>
-          </a:extLst>
-        </p:cNvPr>
+        <p:cNvPr id="1" name=""/>
         <p:cNvGrpSpPr/>
         <p:nvPr/>
       </p:nvGrpSpPr>
@@ -4930,7 +4730,7 @@
           <p:cNvPr id="4" name="Picture 3">
             <a:extLst>
               <a:ext uri="{FF2B5EF4-FFF2-40B4-BE49-F238E27FC236}">
-                <a16:creationId xmlns:a16="http://schemas.microsoft.com/office/drawing/2014/main" id="{813A4E71-8744-2022-9278-0C2494916B99}"/>
+                <a16:creationId xmlns:a16="http://schemas.microsoft.com/office/drawing/2014/main" id="{2C4E09F2-D5A3-5470-58F4-227C9880BE98}"/>
               </a:ext>
             </a:extLst>
           </p:cNvPr>
@@ -4966,7 +4766,7 @@
           <p:cNvPr id="2" name="Title 1">
             <a:extLst>
               <a:ext uri="{FF2B5EF4-FFF2-40B4-BE49-F238E27FC236}">
-                <a16:creationId xmlns:a16="http://schemas.microsoft.com/office/drawing/2014/main" id="{379E3798-863F-D885-70AC-276D7107990C}"/>
+                <a16:creationId xmlns:a16="http://schemas.microsoft.com/office/drawing/2014/main" id="{898C01F2-403E-1B28-A1A4-DB20333CCFE3}"/>
               </a:ext>
             </a:extLst>
           </p:cNvPr>
@@ -4984,7 +4784,7 @@
           <a:p>
             <a:r>
               <a:rPr lang="en-AU" dirty="0"/>
-              <a:t>Introduction	</a:t>
+              <a:t>Early Excess Flux	</a:t>
             </a:r>
           </a:p>
         </p:txBody>
@@ -4994,7 +4794,7 @@
           <p:cNvPr id="3" name="Content Placeholder 2">
             <a:extLst>
               <a:ext uri="{FF2B5EF4-FFF2-40B4-BE49-F238E27FC236}">
-                <a16:creationId xmlns:a16="http://schemas.microsoft.com/office/drawing/2014/main" id="{D5FC0C8F-ED85-53D4-6C92-BCEC969B49A1}"/>
+                <a16:creationId xmlns:a16="http://schemas.microsoft.com/office/drawing/2014/main" id="{CB84F266-4C36-F74A-28E0-193391E8F1FE}"/>
               </a:ext>
             </a:extLst>
           </p:cNvPr>
@@ -5008,7 +4808,7 @@
         <p:spPr>
           <a:xfrm>
             <a:off x="838200" y="1825625"/>
-            <a:ext cx="9787128" cy="4351338"/>
+            <a:ext cx="5343144" cy="4351338"/>
           </a:xfrm>
         </p:spPr>
         <p:txBody>
@@ -5019,35 +4819,61 @@
           <a:p>
             <a:r>
               <a:rPr lang="en-AU" dirty="0"/>
-              <a:t>SNe Ia are standardizable candles.</a:t>
+              <a:t>In some cases, observation of SNe Ia are early and produce a bump in the light curve.</a:t>
             </a:r>
           </a:p>
           <a:p>
             <a:endParaRPr lang="en-AU" dirty="0"/>
           </a:p>
           <a:p>
-            <a:endParaRPr lang="en-AU" dirty="0"/>
-          </a:p>
-          <a:p>
-            <a:endParaRPr lang="en-AU" dirty="0"/>
-          </a:p>
-          <a:p>
-            <a:endParaRPr lang="en-AU" dirty="0"/>
-          </a:p>
-          <a:p>
-            <a:endParaRPr lang="en-AU" dirty="0"/>
-          </a:p>
-          <a:p>
-            <a:endParaRPr lang="en-AU" dirty="0"/>
+            <a:r>
+              <a:rPr lang="en-AU" dirty="0"/>
+              <a:t>Case studies have proposed companion interaction, clumping of nickel 56 and interactions with CSM</a:t>
+            </a:r>
+          </a:p>
+        </p:txBody>
+      </p:sp>
+      <p:sp>
+        <p:nvSpPr>
+          <p:cNvPr id="9" name="TextBox 8">
+            <a:extLst>
+              <a:ext uri="{FF2B5EF4-FFF2-40B4-BE49-F238E27FC236}">
+                <a16:creationId xmlns:a16="http://schemas.microsoft.com/office/drawing/2014/main" id="{78D4041E-EF53-343E-CED9-A6E511D87581}"/>
+              </a:ext>
+            </a:extLst>
+          </p:cNvPr>
+          <p:cNvSpPr txBox="1"/>
+          <p:nvPr/>
+        </p:nvSpPr>
+        <p:spPr>
+          <a:xfrm>
+            <a:off x="6181344" y="4572602"/>
+            <a:ext cx="6167628" cy="369332"/>
+          </a:xfrm>
+          <a:prstGeom prst="rect">
+            <a:avLst/>
+          </a:prstGeom>
+          <a:noFill/>
+        </p:spPr>
+        <p:txBody>
+          <a:bodyPr wrap="square">
+            <a:spAutoFit/>
+          </a:bodyPr>
+          <a:lstStyle/>
+          <a:p>
+            <a:r>
+              <a:rPr lang="en-AU" dirty="0"/>
+              <a:t>(Marion et al., 2016)</a:t>
+            </a:r>
           </a:p>
         </p:txBody>
       </p:sp>
       <p:pic>
         <p:nvPicPr>
-          <p:cNvPr id="6" name="Picture 5">
-            <a:extLst>
-              <a:ext uri="{FF2B5EF4-FFF2-40B4-BE49-F238E27FC236}">
-                <a16:creationId xmlns:a16="http://schemas.microsoft.com/office/drawing/2014/main" id="{4DC03EFC-12A0-4334-07EE-19C512A283FE}"/>
+          <p:cNvPr id="7" name="Picture 6">
+            <a:extLst>
+              <a:ext uri="{FF2B5EF4-FFF2-40B4-BE49-F238E27FC236}">
+                <a16:creationId xmlns:a16="http://schemas.microsoft.com/office/drawing/2014/main" id="{B93FB9DA-FEC2-4227-049F-B71B2E632C75}"/>
               </a:ext>
             </a:extLst>
           </p:cNvPr>
@@ -5057,33 +4883,41 @@
           <p:nvPr/>
         </p:nvPicPr>
         <p:blipFill>
-          <a:blip r:embed="rId3">
-            <a:extLst>
-              <a:ext uri="{28A0092B-C50C-407E-A947-70E740481C1C}">
-                <a14:useLocalDpi xmlns:a14="http://schemas.microsoft.com/office/drawing/2010/main" val="0"/>
-              </a:ext>
-            </a:extLst>
-          </a:blip>
+          <a:blip r:embed="rId3"/>
           <a:stretch>
             <a:fillRect/>
           </a:stretch>
         </p:blipFill>
         <p:spPr>
           <a:xfrm>
-            <a:off x="3802280" y="2853257"/>
-            <a:ext cx="4401473" cy="2480413"/>
+            <a:off x="5974317" y="681037"/>
+            <a:ext cx="5889323" cy="3760319"/>
           </a:xfrm>
           <a:prstGeom prst="rect">
             <a:avLst/>
           </a:prstGeom>
+          <a:ln w="38100" cap="sq">
+            <a:solidFill>
+              <a:srgbClr val="000000"/>
+            </a:solidFill>
+            <a:prstDash val="solid"/>
+            <a:miter lim="800000"/>
+          </a:ln>
+          <a:effectLst>
+            <a:outerShdw blurRad="50800" dist="38100" dir="2700000" algn="tl" rotWithShape="0">
+              <a:srgbClr val="000000">
+                <a:alpha val="43000"/>
+              </a:srgbClr>
+            </a:outerShdw>
+          </a:effectLst>
         </p:spPr>
       </p:pic>
       <p:sp>
         <p:nvSpPr>
-          <p:cNvPr id="8" name="TextBox 7">
-            <a:extLst>
-              <a:ext uri="{FF2B5EF4-FFF2-40B4-BE49-F238E27FC236}">
-                <a16:creationId xmlns:a16="http://schemas.microsoft.com/office/drawing/2014/main" id="{35966A15-8554-79A5-C3CE-F59E405B610D}"/>
+          <p:cNvPr id="10" name="TextBox 9">
+            <a:extLst>
+              <a:ext uri="{FF2B5EF4-FFF2-40B4-BE49-F238E27FC236}">
+                <a16:creationId xmlns:a16="http://schemas.microsoft.com/office/drawing/2014/main" id="{537B5E11-47A6-553F-4456-47232A0A53C5}"/>
               </a:ext>
             </a:extLst>
           </p:cNvPr>
@@ -5092,8 +4926,8 @@
         </p:nvSpPr>
         <p:spPr>
           <a:xfrm>
-            <a:off x="3688819" y="5385984"/>
-            <a:ext cx="6136952" cy="369332"/>
+            <a:off x="191861" y="6335814"/>
+            <a:ext cx="308098" cy="369332"/>
           </a:xfrm>
           <a:prstGeom prst="rect">
             <a:avLst/>
@@ -5101,380 +4935,74 @@
           <a:noFill/>
         </p:spPr>
         <p:txBody>
-          <a:bodyPr wrap="square">
+          <a:bodyPr wrap="none" rtlCol="0">
             <a:spAutoFit/>
           </a:bodyPr>
           <a:lstStyle/>
           <a:p>
             <a:r>
-              <a:rPr lang="en-US"/>
-              <a:t>(“Accelerating Expansion of the Universe,” 2026)</a:t>
-            </a:r>
-            <a:endParaRPr lang="en-AU" dirty="0"/>
-          </a:p>
-        </p:txBody>
-      </p:sp>
-      <p:pic>
-        <p:nvPicPr>
-          <p:cNvPr id="10" name="Picture 9">
-            <a:extLst>
-              <a:ext uri="{FF2B5EF4-FFF2-40B4-BE49-F238E27FC236}">
-                <a16:creationId xmlns:a16="http://schemas.microsoft.com/office/drawing/2014/main" id="{188268A8-2D39-DD70-B0A6-A38603E5DF45}"/>
-              </a:ext>
-            </a:extLst>
-          </p:cNvPr>
-          <p:cNvPicPr>
-            <a:picLocks noChangeAspect="1"/>
-          </p:cNvPicPr>
+              <a:rPr lang="en-AU" dirty="0"/>
+              <a:t>4</a:t>
+            </a:r>
+          </a:p>
+        </p:txBody>
+      </p:sp>
+      <p:sp>
+        <p:nvSpPr>
+          <p:cNvPr id="8" name="Oval 7">
+            <a:extLst>
+              <a:ext uri="{FF2B5EF4-FFF2-40B4-BE49-F238E27FC236}">
+                <a16:creationId xmlns:a16="http://schemas.microsoft.com/office/drawing/2014/main" id="{7C33EBE4-4839-94D7-A47F-84723FDFC834}"/>
+              </a:ext>
+            </a:extLst>
+          </p:cNvPr>
+          <p:cNvSpPr/>
           <p:nvPr/>
-        </p:nvPicPr>
-        <p:blipFill>
-          <a:blip r:embed="rId4">
-            <a:extLst>
-              <a:ext uri="{28A0092B-C50C-407E-A947-70E740481C1C}">
-                <a14:useLocalDpi xmlns:a14="http://schemas.microsoft.com/office/drawing/2010/main" val="0"/>
-              </a:ext>
-            </a:extLst>
-          </a:blip>
-          <a:stretch>
-            <a:fillRect/>
-          </a:stretch>
-        </p:blipFill>
+        </p:nvSpPr>
         <p:spPr>
           <a:xfrm>
-            <a:off x="3714750" y="1866900"/>
-            <a:ext cx="4762500" cy="3124200"/>
+            <a:off x="7504524" y="2610269"/>
+            <a:ext cx="725075" cy="1144279"/>
           </a:xfrm>
-          <a:prstGeom prst="rect">
+          <a:prstGeom prst="ellipse">
             <a:avLst/>
           </a:prstGeom>
+          <a:noFill/>
+          <a:ln>
+            <a:solidFill>
+              <a:srgbClr val="FF0000"/>
+            </a:solidFill>
+          </a:ln>
         </p:spPr>
-      </p:pic>
+        <p:style>
+          <a:lnRef idx="2">
+            <a:schemeClr val="accent1">
+              <a:shade val="15000"/>
+            </a:schemeClr>
+          </a:lnRef>
+          <a:fillRef idx="1">
+            <a:schemeClr val="accent1"/>
+          </a:fillRef>
+          <a:effectRef idx="0">
+            <a:schemeClr val="accent1"/>
+          </a:effectRef>
+          <a:fontRef idx="minor">
+            <a:schemeClr val="lt1"/>
+          </a:fontRef>
+        </p:style>
+        <p:txBody>
+          <a:bodyPr rtlCol="0" anchor="ctr"/>
+          <a:lstStyle/>
+          <a:p>
+            <a:pPr algn="ctr"/>
+            <a:endParaRPr lang="en-AU"/>
+          </a:p>
+        </p:txBody>
+      </p:sp>
     </p:spTree>
     <p:extLst>
       <p:ext uri="{BB962C8B-B14F-4D97-AF65-F5344CB8AC3E}">
-        <p14:creationId xmlns:p14="http://schemas.microsoft.com/office/powerpoint/2010/main" val="3620831151"/>
-      </p:ext>
-    </p:extLst>
-  </p:cSld>
-  <p:clrMapOvr>
-    <a:masterClrMapping/>
-  </p:clrMapOvr>
-</p:sld>
-</file>
-
-<file path=ppt/slides/slide5.xml><?xml version="1.0" encoding="utf-8"?>
-<p:sld xmlns:a="http://schemas.openxmlformats.org/drawingml/2006/main" xmlns:r="http://schemas.openxmlformats.org/officeDocument/2006/relationships" xmlns:p="http://schemas.openxmlformats.org/presentationml/2006/main">
-  <p:cSld>
-    <p:spTree>
-      <p:nvGrpSpPr>
-        <p:cNvPr id="1" name="">
-          <a:extLst>
-            <a:ext uri="{FF2B5EF4-FFF2-40B4-BE49-F238E27FC236}">
-              <a16:creationId xmlns:a16="http://schemas.microsoft.com/office/drawing/2014/main" id="{7F47CACD-8699-AD74-F4A3-D917BA20BDF0}"/>
-            </a:ext>
-          </a:extLst>
-        </p:cNvPr>
-        <p:cNvGrpSpPr/>
-        <p:nvPr/>
-      </p:nvGrpSpPr>
-      <p:grpSpPr>
-        <a:xfrm>
-          <a:off x="0" y="0"/>
-          <a:ext cx="0" cy="0"/>
-          <a:chOff x="0" y="0"/>
-          <a:chExt cx="0" cy="0"/>
-        </a:xfrm>
-      </p:grpSpPr>
-      <p:pic>
-        <p:nvPicPr>
-          <p:cNvPr id="4" name="Picture 3">
-            <a:extLst>
-              <a:ext uri="{FF2B5EF4-FFF2-40B4-BE49-F238E27FC236}">
-                <a16:creationId xmlns:a16="http://schemas.microsoft.com/office/drawing/2014/main" id="{DF62044A-7AA8-4D91-3013-A494C0AC63D2}"/>
-              </a:ext>
-            </a:extLst>
-          </p:cNvPr>
-          <p:cNvPicPr>
-            <a:picLocks noChangeAspect="1"/>
-          </p:cNvPicPr>
-          <p:nvPr/>
-        </p:nvPicPr>
-        <p:blipFill>
-          <a:blip r:embed="rId2">
-            <a:extLst>
-              <a:ext uri="{28A0092B-C50C-407E-A947-70E740481C1C}">
-                <a14:useLocalDpi xmlns:a14="http://schemas.microsoft.com/office/drawing/2010/main" val="0"/>
-              </a:ext>
-            </a:extLst>
-          </a:blip>
-          <a:stretch>
-            <a:fillRect/>
-          </a:stretch>
-        </p:blipFill>
-        <p:spPr>
-          <a:xfrm>
-            <a:off x="0" y="0"/>
-            <a:ext cx="12192000" cy="6858000"/>
-          </a:xfrm>
-          <a:prstGeom prst="rect">
-            <a:avLst/>
-          </a:prstGeom>
-        </p:spPr>
-      </p:pic>
-      <p:sp>
-        <p:nvSpPr>
-          <p:cNvPr id="2" name="Title 1">
-            <a:extLst>
-              <a:ext uri="{FF2B5EF4-FFF2-40B4-BE49-F238E27FC236}">
-                <a16:creationId xmlns:a16="http://schemas.microsoft.com/office/drawing/2014/main" id="{69F20EAB-971D-4E0B-0C28-92C0641C004C}"/>
-              </a:ext>
-            </a:extLst>
-          </p:cNvPr>
-          <p:cNvSpPr>
-            <a:spLocks noGrp="1"/>
-          </p:cNvSpPr>
-          <p:nvPr>
-            <p:ph type="title"/>
-          </p:nvPr>
-        </p:nvSpPr>
-        <p:spPr/>
-        <p:txBody>
-          <a:bodyPr/>
-          <a:lstStyle/>
-          <a:p>
-            <a:r>
-              <a:rPr lang="en-AU" dirty="0"/>
-              <a:t>Introduction	</a:t>
-            </a:r>
-          </a:p>
-        </p:txBody>
-      </p:sp>
-      <p:sp>
-        <p:nvSpPr>
-          <p:cNvPr id="3" name="Content Placeholder 2">
-            <a:extLst>
-              <a:ext uri="{FF2B5EF4-FFF2-40B4-BE49-F238E27FC236}">
-                <a16:creationId xmlns:a16="http://schemas.microsoft.com/office/drawing/2014/main" id="{C59474C7-44F8-AE55-184A-19238D62D0D8}"/>
-              </a:ext>
-            </a:extLst>
-          </p:cNvPr>
-          <p:cNvSpPr>
-            <a:spLocks noGrp="1"/>
-          </p:cNvSpPr>
-          <p:nvPr>
-            <p:ph idx="1"/>
-          </p:nvPr>
-        </p:nvSpPr>
-        <p:spPr>
-          <a:xfrm>
-            <a:off x="838200" y="1825625"/>
-            <a:ext cx="9787128" cy="4351338"/>
-          </a:xfrm>
-        </p:spPr>
-        <p:txBody>
-          <a:bodyPr>
-            <a:normAutofit/>
-          </a:bodyPr>
-          <a:lstStyle/>
-          <a:p>
-            <a:r>
-              <a:rPr lang="en-AU" dirty="0"/>
-              <a:t>SNe Ia are standardizable candles.</a:t>
-            </a:r>
-          </a:p>
-          <a:p>
-            <a:endParaRPr lang="en-AU" dirty="0"/>
-          </a:p>
-          <a:p>
-            <a:endParaRPr lang="en-AU" dirty="0"/>
-          </a:p>
-          <a:p>
-            <a:endParaRPr lang="en-AU" dirty="0"/>
-          </a:p>
-          <a:p>
-            <a:endParaRPr lang="en-AU" dirty="0"/>
-          </a:p>
-          <a:p>
-            <a:endParaRPr lang="en-AU" dirty="0"/>
-          </a:p>
-          <a:p>
-            <a:endParaRPr lang="en-AU" dirty="0"/>
-          </a:p>
-        </p:txBody>
-      </p:sp>
-      <p:pic>
-        <p:nvPicPr>
-          <p:cNvPr id="6" name="Picture 5">
-            <a:extLst>
-              <a:ext uri="{FF2B5EF4-FFF2-40B4-BE49-F238E27FC236}">
-                <a16:creationId xmlns:a16="http://schemas.microsoft.com/office/drawing/2014/main" id="{BA922176-FF46-06BB-C435-B0D54372E211}"/>
-              </a:ext>
-            </a:extLst>
-          </p:cNvPr>
-          <p:cNvPicPr>
-            <a:picLocks noChangeAspect="1"/>
-          </p:cNvPicPr>
-          <p:nvPr/>
-        </p:nvPicPr>
-        <p:blipFill>
-          <a:blip r:embed="rId3">
-            <a:extLst>
-              <a:ext uri="{28A0092B-C50C-407E-A947-70E740481C1C}">
-                <a14:useLocalDpi xmlns:a14="http://schemas.microsoft.com/office/drawing/2010/main" val="0"/>
-              </a:ext>
-            </a:extLst>
-          </a:blip>
-          <a:stretch>
-            <a:fillRect/>
-          </a:stretch>
-        </p:blipFill>
-        <p:spPr>
-          <a:xfrm>
-            <a:off x="3802280" y="2853257"/>
-            <a:ext cx="4401473" cy="2480413"/>
-          </a:xfrm>
-          <a:prstGeom prst="rect">
-            <a:avLst/>
-          </a:prstGeom>
-        </p:spPr>
-      </p:pic>
-      <p:pic>
-        <p:nvPicPr>
-          <p:cNvPr id="10" name="Picture 9">
-            <a:extLst>
-              <a:ext uri="{FF2B5EF4-FFF2-40B4-BE49-F238E27FC236}">
-                <a16:creationId xmlns:a16="http://schemas.microsoft.com/office/drawing/2014/main" id="{3CC9C2A2-7AE8-272B-F95A-FAC759088CC2}"/>
-              </a:ext>
-            </a:extLst>
-          </p:cNvPr>
-          <p:cNvPicPr>
-            <a:picLocks noChangeAspect="1"/>
-          </p:cNvPicPr>
-          <p:nvPr/>
-        </p:nvPicPr>
-        <p:blipFill>
-          <a:blip r:embed="rId4">
-            <a:extLst>
-              <a:ext uri="{28A0092B-C50C-407E-A947-70E740481C1C}">
-                <a14:useLocalDpi xmlns:a14="http://schemas.microsoft.com/office/drawing/2010/main" val="0"/>
-              </a:ext>
-            </a:extLst>
-          </a:blip>
-          <a:stretch>
-            <a:fillRect/>
-          </a:stretch>
-        </p:blipFill>
-        <p:spPr>
-          <a:xfrm>
-            <a:off x="3714750" y="1866900"/>
-            <a:ext cx="4762500" cy="3124200"/>
-          </a:xfrm>
-          <a:prstGeom prst="rect">
-            <a:avLst/>
-          </a:prstGeom>
-        </p:spPr>
-      </p:pic>
-      <p:pic>
-        <p:nvPicPr>
-          <p:cNvPr id="12" name="Picture 11">
-            <a:extLst>
-              <a:ext uri="{FF2B5EF4-FFF2-40B4-BE49-F238E27FC236}">
-                <a16:creationId xmlns:a16="http://schemas.microsoft.com/office/drawing/2014/main" id="{84A27428-0FDE-C8E5-CB92-12B8AE5B7E3A}"/>
-              </a:ext>
-            </a:extLst>
-          </p:cNvPr>
-          <p:cNvPicPr>
-            <a:picLocks noChangeAspect="1"/>
-          </p:cNvPicPr>
-          <p:nvPr/>
-        </p:nvPicPr>
-        <p:blipFill>
-          <a:blip r:embed="rId5">
-            <a:extLst>
-              <a:ext uri="{28A0092B-C50C-407E-A947-70E740481C1C}">
-                <a14:useLocalDpi xmlns:a14="http://schemas.microsoft.com/office/drawing/2010/main" val="0"/>
-              </a:ext>
-            </a:extLst>
-          </a:blip>
-          <a:stretch>
-            <a:fillRect/>
-          </a:stretch>
-        </p:blipFill>
-        <p:spPr>
-          <a:xfrm>
-            <a:off x="3758208" y="2154702"/>
-            <a:ext cx="4762499" cy="3178968"/>
-          </a:xfrm>
-          <a:prstGeom prst="rect">
-            <a:avLst/>
-          </a:prstGeom>
-        </p:spPr>
-      </p:pic>
-      <p:sp>
-        <p:nvSpPr>
-          <p:cNvPr id="14" name="TextBox 13">
-            <a:extLst>
-              <a:ext uri="{FF2B5EF4-FFF2-40B4-BE49-F238E27FC236}">
-                <a16:creationId xmlns:a16="http://schemas.microsoft.com/office/drawing/2014/main" id="{572DCA0A-0050-A31B-FAE4-94E5BA67D67B}"/>
-              </a:ext>
-            </a:extLst>
-          </p:cNvPr>
-          <p:cNvSpPr txBox="1"/>
-          <p:nvPr/>
-        </p:nvSpPr>
-        <p:spPr>
-          <a:xfrm>
-            <a:off x="3671293" y="4991100"/>
-            <a:ext cx="4696206" cy="369332"/>
-          </a:xfrm>
-          <a:prstGeom prst="rect">
-            <a:avLst/>
-          </a:prstGeom>
-          <a:noFill/>
-        </p:spPr>
-        <p:txBody>
-          <a:bodyPr wrap="square">
-            <a:spAutoFit/>
-          </a:bodyPr>
-          <a:lstStyle/>
-          <a:p>
-            <a:r>
-              <a:rPr lang="en-US" dirty="0">
-                <a:solidFill>
-                  <a:schemeClr val="bg1"/>
-                </a:solidFill>
-              </a:rPr>
-              <a:t>(</a:t>
-            </a:r>
-            <a:r>
-              <a:rPr lang="en-US" i="1" dirty="0">
-                <a:solidFill>
-                  <a:schemeClr val="bg1"/>
-                </a:solidFill>
-              </a:rPr>
-              <a:t>White Dwarf Star Spiral - NASA</a:t>
-            </a:r>
-            <a:r>
-              <a:rPr lang="en-US" dirty="0">
-                <a:solidFill>
-                  <a:schemeClr val="bg1"/>
-                </a:solidFill>
-              </a:rPr>
-              <a:t>, n.d.)</a:t>
-            </a:r>
-            <a:endParaRPr lang="en-AU" dirty="0">
-              <a:solidFill>
-                <a:schemeClr val="bg1"/>
-              </a:solidFill>
-            </a:endParaRPr>
-          </a:p>
-        </p:txBody>
-      </p:sp>
-    </p:spTree>
-    <p:extLst>
-      <p:ext uri="{BB962C8B-B14F-4D97-AF65-F5344CB8AC3E}">
-        <p14:creationId xmlns:p14="http://schemas.microsoft.com/office/powerpoint/2010/main" val="606608196"/>
+        <p14:creationId xmlns:p14="http://schemas.microsoft.com/office/powerpoint/2010/main" val="2452326653"/>
       </p:ext>
     </p:extLst>
   </p:cSld>
@@ -5506,7 +5034,257 @@
           <p:cNvPr id="4" name="Picture 3">
             <a:extLst>
               <a:ext uri="{FF2B5EF4-FFF2-40B4-BE49-F238E27FC236}">
-                <a16:creationId xmlns:a16="http://schemas.microsoft.com/office/drawing/2014/main" id="{F7F19348-401B-FC99-8DE5-F63E71F0B2FA}"/>
+                <a16:creationId xmlns:a16="http://schemas.microsoft.com/office/drawing/2014/main" id="{79C67840-4287-4411-DE2F-52855A7481AD}"/>
+              </a:ext>
+            </a:extLst>
+          </p:cNvPr>
+          <p:cNvPicPr>
+            <a:picLocks noChangeAspect="1"/>
+          </p:cNvPicPr>
+          <p:nvPr/>
+        </p:nvPicPr>
+        <p:blipFill>
+          <a:blip r:embed="rId2">
+            <a:extLst>
+              <a:ext uri="{28A0092B-C50C-407E-A947-70E740481C1C}">
+                <a14:useLocalDpi xmlns:a14="http://schemas.microsoft.com/office/drawing/2010/main" val="0"/>
+              </a:ext>
+            </a:extLst>
+          </a:blip>
+          <a:stretch>
+            <a:fillRect/>
+          </a:stretch>
+        </p:blipFill>
+        <p:spPr>
+          <a:xfrm>
+            <a:off x="0" y="-36254"/>
+            <a:ext cx="12192000" cy="6858000"/>
+          </a:xfrm>
+          <a:prstGeom prst="rect">
+            <a:avLst/>
+          </a:prstGeom>
+        </p:spPr>
+      </p:pic>
+      <p:sp>
+        <p:nvSpPr>
+          <p:cNvPr id="2" name="Title 1">
+            <a:extLst>
+              <a:ext uri="{FF2B5EF4-FFF2-40B4-BE49-F238E27FC236}">
+                <a16:creationId xmlns:a16="http://schemas.microsoft.com/office/drawing/2014/main" id="{818C63AB-6315-7F38-6415-DAAEFC8D1CDE}"/>
+              </a:ext>
+            </a:extLst>
+          </p:cNvPr>
+          <p:cNvSpPr>
+            <a:spLocks noGrp="1"/>
+          </p:cNvSpPr>
+          <p:nvPr>
+            <p:ph type="title"/>
+          </p:nvPr>
+        </p:nvSpPr>
+        <p:spPr/>
+        <p:txBody>
+          <a:bodyPr/>
+          <a:lstStyle/>
+          <a:p>
+            <a:r>
+              <a:rPr lang="en-AU" dirty="0"/>
+              <a:t>Host Galaxy Environments</a:t>
+            </a:r>
+          </a:p>
+        </p:txBody>
+      </p:sp>
+      <p:sp>
+        <p:nvSpPr>
+          <p:cNvPr id="3" name="Content Placeholder 2">
+            <a:extLst>
+              <a:ext uri="{FF2B5EF4-FFF2-40B4-BE49-F238E27FC236}">
+                <a16:creationId xmlns:a16="http://schemas.microsoft.com/office/drawing/2014/main" id="{6688A419-F0FC-D06B-A5A1-742608EC3F53}"/>
+              </a:ext>
+            </a:extLst>
+          </p:cNvPr>
+          <p:cNvSpPr>
+            <a:spLocks noGrp="1"/>
+          </p:cNvSpPr>
+          <p:nvPr>
+            <p:ph idx="1"/>
+          </p:nvPr>
+        </p:nvSpPr>
+        <p:spPr>
+          <a:xfrm>
+            <a:off x="838200" y="1825625"/>
+            <a:ext cx="5257800" cy="4351338"/>
+          </a:xfrm>
+        </p:spPr>
+        <p:txBody>
+          <a:bodyPr/>
+          <a:lstStyle/>
+          <a:p>
+            <a:r>
+              <a:rPr lang="en-AU" dirty="0"/>
+              <a:t>To improve standardisation, we search for correlations with Host galaxy properties.</a:t>
+            </a:r>
+          </a:p>
+          <a:p>
+            <a:endParaRPr lang="en-AU" dirty="0"/>
+          </a:p>
+        </p:txBody>
+      </p:sp>
+      <p:pic>
+        <p:nvPicPr>
+          <p:cNvPr id="9" name="Picture 8">
+            <a:extLst>
+              <a:ext uri="{FF2B5EF4-FFF2-40B4-BE49-F238E27FC236}">
+                <a16:creationId xmlns:a16="http://schemas.microsoft.com/office/drawing/2014/main" id="{01F0B274-435A-24DB-2506-66435BFEC1A4}"/>
+              </a:ext>
+            </a:extLst>
+          </p:cNvPr>
+          <p:cNvPicPr>
+            <a:picLocks noChangeAspect="1"/>
+          </p:cNvPicPr>
+          <p:nvPr/>
+        </p:nvPicPr>
+        <p:blipFill>
+          <a:blip r:embed="rId3">
+            <a:extLst>
+              <a:ext uri="{28A0092B-C50C-407E-A947-70E740481C1C}">
+                <a14:useLocalDpi xmlns:a14="http://schemas.microsoft.com/office/drawing/2010/main" val="0"/>
+              </a:ext>
+            </a:extLst>
+          </a:blip>
+          <a:stretch>
+            <a:fillRect/>
+          </a:stretch>
+        </p:blipFill>
+        <p:spPr>
+          <a:xfrm>
+            <a:off x="6513590" y="1603439"/>
+            <a:ext cx="3623346" cy="3385262"/>
+          </a:xfrm>
+          <a:prstGeom prst="rect">
+            <a:avLst/>
+          </a:prstGeom>
+          <a:ln w="38100" cap="sq">
+            <a:solidFill>
+              <a:srgbClr val="000000"/>
+            </a:solidFill>
+            <a:prstDash val="solid"/>
+            <a:miter lim="800000"/>
+          </a:ln>
+          <a:effectLst>
+            <a:outerShdw blurRad="50800" dist="38100" dir="2700000" algn="tl" rotWithShape="0">
+              <a:srgbClr val="000000">
+                <a:alpha val="43000"/>
+              </a:srgbClr>
+            </a:outerShdw>
+          </a:effectLst>
+        </p:spPr>
+      </p:pic>
+      <p:sp>
+        <p:nvSpPr>
+          <p:cNvPr id="6" name="TextBox 5">
+            <a:extLst>
+              <a:ext uri="{FF2B5EF4-FFF2-40B4-BE49-F238E27FC236}">
+                <a16:creationId xmlns:a16="http://schemas.microsoft.com/office/drawing/2014/main" id="{3B436A99-0494-8D69-F8B9-65F64C56A78B}"/>
+              </a:ext>
+            </a:extLst>
+          </p:cNvPr>
+          <p:cNvSpPr txBox="1"/>
+          <p:nvPr/>
+        </p:nvSpPr>
+        <p:spPr>
+          <a:xfrm>
+            <a:off x="6513590" y="4988701"/>
+            <a:ext cx="6136952" cy="369332"/>
+          </a:xfrm>
+          <a:prstGeom prst="rect">
+            <a:avLst/>
+          </a:prstGeom>
+          <a:noFill/>
+        </p:spPr>
+        <p:txBody>
+          <a:bodyPr wrap="square">
+            <a:spAutoFit/>
+          </a:bodyPr>
+          <a:lstStyle/>
+          <a:p>
+            <a:r>
+              <a:rPr lang="en-AU" dirty="0"/>
+              <a:t>(Toy et al., 2025)</a:t>
+            </a:r>
+          </a:p>
+        </p:txBody>
+      </p:sp>
+      <p:sp>
+        <p:nvSpPr>
+          <p:cNvPr id="10" name="TextBox 9">
+            <a:extLst>
+              <a:ext uri="{FF2B5EF4-FFF2-40B4-BE49-F238E27FC236}">
+                <a16:creationId xmlns:a16="http://schemas.microsoft.com/office/drawing/2014/main" id="{D1ED9F07-AD21-C725-AFF0-8BEEEAFA43A5}"/>
+              </a:ext>
+            </a:extLst>
+          </p:cNvPr>
+          <p:cNvSpPr txBox="1"/>
+          <p:nvPr/>
+        </p:nvSpPr>
+        <p:spPr>
+          <a:xfrm>
+            <a:off x="191861" y="6335814"/>
+            <a:ext cx="308098" cy="369332"/>
+          </a:xfrm>
+          <a:prstGeom prst="rect">
+            <a:avLst/>
+          </a:prstGeom>
+          <a:noFill/>
+        </p:spPr>
+        <p:txBody>
+          <a:bodyPr wrap="none" rtlCol="0">
+            <a:spAutoFit/>
+          </a:bodyPr>
+          <a:lstStyle/>
+          <a:p>
+            <a:r>
+              <a:rPr lang="en-AU" dirty="0"/>
+              <a:t>5</a:t>
+            </a:r>
+          </a:p>
+        </p:txBody>
+      </p:sp>
+    </p:spTree>
+    <p:extLst>
+      <p:ext uri="{BB962C8B-B14F-4D97-AF65-F5344CB8AC3E}">
+        <p14:creationId xmlns:p14="http://schemas.microsoft.com/office/powerpoint/2010/main" val="3741420523"/>
+      </p:ext>
+    </p:extLst>
+  </p:cSld>
+  <p:clrMapOvr>
+    <a:masterClrMapping/>
+  </p:clrMapOvr>
+</p:sld>
+</file>
+
+<file path=ppt/slides/slide7.xml><?xml version="1.0" encoding="utf-8"?>
+<p:sld xmlns:a="http://schemas.openxmlformats.org/drawingml/2006/main" xmlns:r="http://schemas.openxmlformats.org/officeDocument/2006/relationships" xmlns:p="http://schemas.openxmlformats.org/presentationml/2006/main">
+  <p:cSld>
+    <p:spTree>
+      <p:nvGrpSpPr>
+        <p:cNvPr id="1" name=""/>
+        <p:cNvGrpSpPr/>
+        <p:nvPr/>
+      </p:nvGrpSpPr>
+      <p:grpSpPr>
+        <a:xfrm>
+          <a:off x="0" y="0"/>
+          <a:ext cx="0" cy="0"/>
+          <a:chOff x="0" y="0"/>
+          <a:chExt cx="0" cy="0"/>
+        </a:xfrm>
+      </p:grpSpPr>
+      <p:pic>
+        <p:nvPicPr>
+          <p:cNvPr id="4" name="Picture 3">
+            <a:extLst>
+              <a:ext uri="{FF2B5EF4-FFF2-40B4-BE49-F238E27FC236}">
+                <a16:creationId xmlns:a16="http://schemas.microsoft.com/office/drawing/2014/main" id="{8CF574DC-4061-64A8-AC59-2B0A2C2A1F6F}"/>
               </a:ext>
             </a:extLst>
           </p:cNvPr>
@@ -5542,7 +5320,7 @@
           <p:cNvPr id="2" name="Title 1">
             <a:extLst>
               <a:ext uri="{FF2B5EF4-FFF2-40B4-BE49-F238E27FC236}">
-                <a16:creationId xmlns:a16="http://schemas.microsoft.com/office/drawing/2014/main" id="{AFE01431-6EAC-1DDB-F773-CA52BBD9DEBF}"/>
+                <a16:creationId xmlns:a16="http://schemas.microsoft.com/office/drawing/2014/main" id="{E1D5E06E-FEB0-5583-C474-C6291C4A628C}"/>
               </a:ext>
             </a:extLst>
           </p:cNvPr>
@@ -5560,856 +5338,80 @@
           <a:p>
             <a:r>
               <a:rPr lang="en-AU" dirty="0"/>
-              <a:t>SNe Ia Standardisation		</a:t>
-            </a:r>
-          </a:p>
-        </p:txBody>
-      </p:sp>
-      <mc:AlternateContent xmlns:mc="http://schemas.openxmlformats.org/markup-compatibility/2006" xmlns:a14="http://schemas.microsoft.com/office/drawing/2010/main">
-        <mc:Choice Requires="a14">
-          <p:sp>
-            <p:nvSpPr>
-              <p:cNvPr id="3" name="Content Placeholder 2">
-                <a:extLst>
-                  <a:ext uri="{FF2B5EF4-FFF2-40B4-BE49-F238E27FC236}">
-                    <a16:creationId xmlns:a16="http://schemas.microsoft.com/office/drawing/2014/main" id="{94B3334D-4971-EF70-B7DA-621DDF9409E3}"/>
-                  </a:ext>
-                </a:extLst>
-              </p:cNvPr>
-              <p:cNvSpPr>
-                <a:spLocks noGrp="1"/>
-              </p:cNvSpPr>
-              <p:nvPr>
-                <p:ph idx="1"/>
-              </p:nvPr>
-            </p:nvSpPr>
-            <p:spPr/>
-            <p:txBody>
-              <a:bodyPr>
-                <a:normAutofit/>
-              </a:bodyPr>
-              <a:lstStyle/>
-              <a:p>
-                <a:pPr marL="0" indent="0">
-                  <a:buNone/>
-                </a:pPr>
-                <a:endParaRPr lang="en-AU" dirty="0"/>
-              </a:p>
-              <a:p>
-                <a14:m>
-                  <m:oMath xmlns:m="http://schemas.openxmlformats.org/officeDocument/2006/math">
-                    <m:sSub>
-                      <m:sSubPr>
-                        <m:ctrlPr>
-                          <a:rPr lang="en-AU" i="1">
-                            <a:latin typeface="Cambria Math" panose="02040503050406030204" pitchFamily="18" charset="0"/>
-                          </a:rPr>
-                        </m:ctrlPr>
-                      </m:sSubPr>
-                      <m:e>
-                        <m:r>
-                          <a:rPr lang="en-AU" i="1">
-                            <a:latin typeface="Cambria Math" panose="02040503050406030204" pitchFamily="18" charset="0"/>
-                          </a:rPr>
-                          <m:t>𝜇</m:t>
-                        </m:r>
-                      </m:e>
-                      <m:sub>
-                        <m:r>
-                          <a:rPr lang="en-AU" i="1">
-                            <a:latin typeface="Cambria Math" panose="02040503050406030204" pitchFamily="18" charset="0"/>
-                          </a:rPr>
-                          <m:t>𝑜𝑏𝑠</m:t>
-                        </m:r>
-                      </m:sub>
-                    </m:sSub>
-                    <m:r>
-                      <a:rPr lang="en-AU" i="1">
-                        <a:latin typeface="Cambria Math" panose="02040503050406030204" pitchFamily="18" charset="0"/>
-                      </a:rPr>
-                      <m:t>=</m:t>
-                    </m:r>
-                    <m:sSubSup>
-                      <m:sSubSupPr>
-                        <m:ctrlPr>
-                          <a:rPr lang="en-AU" i="1">
-                            <a:latin typeface="Cambria Math" panose="02040503050406030204" pitchFamily="18" charset="0"/>
-                          </a:rPr>
-                        </m:ctrlPr>
-                      </m:sSubSupPr>
-                      <m:e>
-                        <m:r>
-                          <a:rPr lang="en-AU" i="1">
-                            <a:latin typeface="Cambria Math" panose="02040503050406030204" pitchFamily="18" charset="0"/>
-                          </a:rPr>
-                          <m:t>𝑚</m:t>
-                        </m:r>
-                      </m:e>
-                      <m:sub>
-                        <m:r>
-                          <a:rPr lang="en-AU" i="1">
-                            <a:latin typeface="Cambria Math" panose="02040503050406030204" pitchFamily="18" charset="0"/>
-                          </a:rPr>
-                          <m:t>𝐵</m:t>
-                        </m:r>
-                      </m:sub>
-                      <m:sup>
-                        <m:r>
-                          <a:rPr lang="en-AU" i="1">
-                            <a:latin typeface="Cambria Math" panose="02040503050406030204" pitchFamily="18" charset="0"/>
-                          </a:rPr>
-                          <m:t>∗</m:t>
-                        </m:r>
-                      </m:sup>
-                    </m:sSubSup>
-                    <m:r>
-                      <a:rPr lang="en-AU" i="1">
-                        <a:latin typeface="Cambria Math" panose="02040503050406030204" pitchFamily="18" charset="0"/>
-                      </a:rPr>
-                      <m:t>−</m:t>
-                    </m:r>
-                    <m:sSub>
-                      <m:sSubPr>
-                        <m:ctrlPr>
-                          <a:rPr lang="en-AU" i="1">
-                            <a:latin typeface="Cambria Math" panose="02040503050406030204" pitchFamily="18" charset="0"/>
-                          </a:rPr>
-                        </m:ctrlPr>
-                      </m:sSubPr>
-                      <m:e>
-                        <m:r>
-                          <a:rPr lang="en-AU" i="1">
-                            <a:latin typeface="Cambria Math" panose="02040503050406030204" pitchFamily="18" charset="0"/>
-                          </a:rPr>
-                          <m:t>𝑀</m:t>
-                        </m:r>
-                      </m:e>
-                      <m:sub>
-                        <m:r>
-                          <a:rPr lang="en-AU" i="1">
-                            <a:latin typeface="Cambria Math" panose="02040503050406030204" pitchFamily="18" charset="0"/>
-                          </a:rPr>
-                          <m:t>𝐵</m:t>
-                        </m:r>
-                      </m:sub>
-                    </m:sSub>
-                    <m:r>
-                      <a:rPr lang="en-AU" i="1">
-                        <a:latin typeface="Cambria Math" panose="02040503050406030204" pitchFamily="18" charset="0"/>
-                      </a:rPr>
-                      <m:t>+</m:t>
-                    </m:r>
-                    <m:r>
-                      <a:rPr lang="en-AU" i="1">
-                        <a:latin typeface="Cambria Math" panose="02040503050406030204" pitchFamily="18" charset="0"/>
-                      </a:rPr>
-                      <m:t>𝛼</m:t>
-                    </m:r>
-                    <m:sSub>
-                      <m:sSubPr>
-                        <m:ctrlPr>
-                          <a:rPr lang="en-AU" i="1">
-                            <a:latin typeface="Cambria Math" panose="02040503050406030204" pitchFamily="18" charset="0"/>
-                          </a:rPr>
-                        </m:ctrlPr>
-                      </m:sSubPr>
-                      <m:e>
-                        <m:r>
-                          <a:rPr lang="en-AU" i="1">
-                            <a:latin typeface="Cambria Math" panose="02040503050406030204" pitchFamily="18" charset="0"/>
-                          </a:rPr>
-                          <m:t>𝑥</m:t>
-                        </m:r>
-                      </m:e>
-                      <m:sub>
-                        <m:r>
-                          <a:rPr lang="en-AU" i="1">
-                            <a:latin typeface="Cambria Math" panose="02040503050406030204" pitchFamily="18" charset="0"/>
-                          </a:rPr>
-                          <m:t>1</m:t>
-                        </m:r>
-                      </m:sub>
-                    </m:sSub>
-                    <m:r>
-                      <a:rPr lang="en-AU" i="1">
-                        <a:latin typeface="Cambria Math" panose="02040503050406030204" pitchFamily="18" charset="0"/>
-                      </a:rPr>
-                      <m:t>−</m:t>
-                    </m:r>
-                    <m:r>
-                      <a:rPr lang="en-AU" i="1">
-                        <a:latin typeface="Cambria Math" panose="02040503050406030204" pitchFamily="18" charset="0"/>
-                      </a:rPr>
-                      <m:t>𝛽</m:t>
-                    </m:r>
-                    <m:r>
-                      <a:rPr lang="en-AU" i="1">
-                        <a:latin typeface="Cambria Math" panose="02040503050406030204" pitchFamily="18" charset="0"/>
-                      </a:rPr>
-                      <m:t>𝑐</m:t>
-                    </m:r>
-                  </m:oMath>
-                </a14:m>
-                <a:r>
-                  <a:rPr lang="en-AU" dirty="0"/>
-                  <a:t> (Tripp Relation)</a:t>
-                </a:r>
-              </a:p>
-              <a:p>
-                <a:endParaRPr lang="en-AU" dirty="0"/>
-              </a:p>
-              <a:p>
-                <a14:m>
-                  <m:oMath xmlns:m="http://schemas.openxmlformats.org/officeDocument/2006/math">
-                    <m:r>
-                      <m:rPr>
-                        <m:sty m:val="p"/>
-                      </m:rPr>
-                      <a:rPr lang="pl-PL" i="0" dirty="0" smtClean="0">
-                        <a:latin typeface="Cambria Math" panose="02040503050406030204" pitchFamily="18" charset="0"/>
-                      </a:rPr>
-                      <m:t>Δ</m:t>
-                    </m:r>
-                    <m:r>
-                      <a:rPr lang="pl-PL" i="1" dirty="0">
-                        <a:latin typeface="Cambria Math" panose="02040503050406030204" pitchFamily="18" charset="0"/>
-                      </a:rPr>
-                      <m:t>𝜇</m:t>
-                    </m:r>
-                    <m:r>
-                      <a:rPr lang="pl-PL" i="1" dirty="0">
-                        <a:latin typeface="Cambria Math" panose="02040503050406030204" pitchFamily="18" charset="0"/>
-                      </a:rPr>
-                      <m:t>=</m:t>
-                    </m:r>
-                    <m:sSub>
-                      <m:sSubPr>
-                        <m:ctrlPr>
-                          <a:rPr lang="pl-PL" i="1" dirty="0">
-                            <a:latin typeface="Cambria Math" panose="02040503050406030204" pitchFamily="18" charset="0"/>
-                          </a:rPr>
-                        </m:ctrlPr>
-                      </m:sSubPr>
-                      <m:e>
-                        <m:r>
-                          <a:rPr lang="pl-PL" i="1" dirty="0">
-                            <a:latin typeface="Cambria Math" panose="02040503050406030204" pitchFamily="18" charset="0"/>
-                          </a:rPr>
-                          <m:t>𝜇</m:t>
-                        </m:r>
-                      </m:e>
-                      <m:sub>
-                        <m:r>
-                          <a:rPr lang="pl-PL" i="1" dirty="0">
-                            <a:latin typeface="Cambria Math" panose="02040503050406030204" pitchFamily="18" charset="0"/>
-                          </a:rPr>
-                          <m:t>𝑜𝑏𝑠</m:t>
-                        </m:r>
-                      </m:sub>
-                    </m:sSub>
-                    <m:r>
-                      <a:rPr lang="pl-PL" i="1" dirty="0">
-                        <a:latin typeface="Cambria Math" panose="02040503050406030204" pitchFamily="18" charset="0"/>
-                      </a:rPr>
-                      <m:t>−</m:t>
-                    </m:r>
-                    <m:sSub>
-                      <m:sSubPr>
-                        <m:ctrlPr>
-                          <a:rPr lang="pl-PL" i="1" dirty="0">
-                            <a:latin typeface="Cambria Math" panose="02040503050406030204" pitchFamily="18" charset="0"/>
-                          </a:rPr>
-                        </m:ctrlPr>
-                      </m:sSubPr>
-                      <m:e>
-                        <m:r>
-                          <a:rPr lang="pl-PL" i="1" dirty="0">
-                            <a:latin typeface="Cambria Math" panose="02040503050406030204" pitchFamily="18" charset="0"/>
-                          </a:rPr>
-                          <m:t>𝜇</m:t>
-                        </m:r>
-                      </m:e>
-                      <m:sub>
-                        <m:r>
-                          <a:rPr lang="pl-PL" i="1" dirty="0">
-                            <a:latin typeface="Cambria Math" panose="02040503050406030204" pitchFamily="18" charset="0"/>
-                          </a:rPr>
-                          <m:t>𝑐𝑜𝑠</m:t>
-                        </m:r>
-                      </m:sub>
-                    </m:sSub>
-                    <m:r>
-                      <a:rPr lang="pl-PL" i="1" dirty="0">
-                        <a:latin typeface="Cambria Math" panose="02040503050406030204" pitchFamily="18" charset="0"/>
-                      </a:rPr>
-                      <m:t> </m:t>
-                    </m:r>
-                  </m:oMath>
-                </a14:m>
-                <a:r>
-                  <a:rPr lang="en-AU" dirty="0"/>
-                  <a:t>(Hubble Residuals)</a:t>
-                </a:r>
-              </a:p>
-              <a:p>
-                <a:pPr marL="0" indent="0">
-                  <a:buNone/>
-                </a:pPr>
-                <a:endParaRPr lang="en-AU" dirty="0"/>
-              </a:p>
-            </p:txBody>
-          </p:sp>
-        </mc:Choice>
-        <mc:Fallback xmlns="">
-          <p:sp>
-            <p:nvSpPr>
-              <p:cNvPr id="3" name="Content Placeholder 2">
-                <a:extLst>
-                  <a:ext uri="{FF2B5EF4-FFF2-40B4-BE49-F238E27FC236}">
-                    <a16:creationId xmlns:a16="http://schemas.microsoft.com/office/drawing/2014/main" id="{94B3334D-4971-EF70-B7DA-621DDF9409E3}"/>
-                  </a:ext>
-                </a:extLst>
-              </p:cNvPr>
-              <p:cNvSpPr>
-                <a:spLocks noGrp="1" noRot="1" noChangeAspect="1" noMove="1" noResize="1" noEditPoints="1" noAdjustHandles="1" noChangeArrowheads="1" noChangeShapeType="1" noTextEdit="1"/>
-              </p:cNvSpPr>
-              <p:nvPr>
-                <p:ph idx="1"/>
-              </p:nvPr>
-            </p:nvSpPr>
-            <p:spPr>
-              <a:blipFill>
-                <a:blip r:embed="rId3"/>
-                <a:stretch>
-                  <a:fillRect/>
-                </a:stretch>
-              </a:blipFill>
-            </p:spPr>
-            <p:txBody>
-              <a:bodyPr/>
-              <a:lstStyle/>
-              <a:p>
-                <a:r>
-                  <a:rPr lang="en-AU">
-                    <a:noFill/>
-                  </a:rPr>
-                  <a:t> </a:t>
-                </a:r>
-              </a:p>
-            </p:txBody>
-          </p:sp>
-        </mc:Fallback>
-      </mc:AlternateContent>
+              <a:t>Finding SNe Ia</a:t>
+            </a:r>
+          </a:p>
+        </p:txBody>
+      </p:sp>
+      <p:sp>
+        <p:nvSpPr>
+          <p:cNvPr id="3" name="Content Placeholder 2">
+            <a:extLst>
+              <a:ext uri="{FF2B5EF4-FFF2-40B4-BE49-F238E27FC236}">
+                <a16:creationId xmlns:a16="http://schemas.microsoft.com/office/drawing/2014/main" id="{0DE6BE5B-DA27-4C06-E559-3561B9464E7E}"/>
+              </a:ext>
+            </a:extLst>
+          </p:cNvPr>
+          <p:cNvSpPr>
+            <a:spLocks noGrp="1"/>
+          </p:cNvSpPr>
+          <p:nvPr>
+            <p:ph idx="1"/>
+          </p:nvPr>
+        </p:nvSpPr>
+        <p:spPr>
+          <a:xfrm>
+            <a:off x="838200" y="1825625"/>
+            <a:ext cx="9110472" cy="4351338"/>
+          </a:xfrm>
+        </p:spPr>
+        <p:txBody>
+          <a:bodyPr>
+            <a:normAutofit/>
+          </a:bodyPr>
+          <a:lstStyle/>
+          <a:p>
+            <a:r>
+              <a:rPr lang="en-AU" dirty="0"/>
+              <a:t>Use Fink </a:t>
+            </a:r>
+            <a:r>
+              <a:rPr lang="en-AU" dirty="0" err="1"/>
+              <a:t>SuperNNova</a:t>
+            </a:r>
+            <a:r>
+              <a:rPr lang="en-AU" dirty="0"/>
+              <a:t> and </a:t>
+            </a:r>
+            <a:r>
+              <a:rPr lang="en-AU" dirty="0" err="1"/>
+              <a:t>earlySNIa</a:t>
+            </a:r>
+            <a:r>
+              <a:rPr lang="en-AU" dirty="0"/>
+              <a:t> classifiers to identify SNe Ia candidates.</a:t>
+            </a:r>
+          </a:p>
+          <a:p>
+            <a:pPr lvl="1"/>
+            <a:r>
+              <a:rPr lang="en-AU" dirty="0"/>
+              <a:t>Through cross matching with galaxy catalogues</a:t>
+            </a:r>
+          </a:p>
+          <a:p>
+            <a:pPr lvl="1"/>
+            <a:r>
+              <a:rPr lang="en-AU" dirty="0"/>
+              <a:t>Object lacks a history of variability</a:t>
+            </a:r>
+          </a:p>
+        </p:txBody>
+      </p:sp>
     </p:spTree>
     <p:extLst>
       <p:ext uri="{BB962C8B-B14F-4D97-AF65-F5344CB8AC3E}">
-        <p14:creationId xmlns:p14="http://schemas.microsoft.com/office/powerpoint/2010/main" val="1587790386"/>
-      </p:ext>
-    </p:extLst>
-  </p:cSld>
-  <p:clrMapOvr>
-    <a:masterClrMapping/>
-  </p:clrMapOvr>
-</p:sld>
-</file>
-
-<file path=ppt/slides/slide7.xml><?xml version="1.0" encoding="utf-8"?>
-<p:sld xmlns:a="http://schemas.openxmlformats.org/drawingml/2006/main" xmlns:r="http://schemas.openxmlformats.org/officeDocument/2006/relationships" xmlns:p="http://schemas.openxmlformats.org/presentationml/2006/main">
-  <p:cSld>
-    <p:spTree>
-      <p:nvGrpSpPr>
-        <p:cNvPr id="1" name="">
-          <a:extLst>
-            <a:ext uri="{FF2B5EF4-FFF2-40B4-BE49-F238E27FC236}">
-              <a16:creationId xmlns:a16="http://schemas.microsoft.com/office/drawing/2014/main" id="{B4BAB631-A737-D733-192C-D7290CA6B29C}"/>
-            </a:ext>
-          </a:extLst>
-        </p:cNvPr>
-        <p:cNvGrpSpPr/>
-        <p:nvPr/>
-      </p:nvGrpSpPr>
-      <p:grpSpPr>
-        <a:xfrm>
-          <a:off x="0" y="0"/>
-          <a:ext cx="0" cy="0"/>
-          <a:chOff x="0" y="0"/>
-          <a:chExt cx="0" cy="0"/>
-        </a:xfrm>
-      </p:grpSpPr>
-      <p:pic>
-        <p:nvPicPr>
-          <p:cNvPr id="4" name="Picture 3">
-            <a:extLst>
-              <a:ext uri="{FF2B5EF4-FFF2-40B4-BE49-F238E27FC236}">
-                <a16:creationId xmlns:a16="http://schemas.microsoft.com/office/drawing/2014/main" id="{24557C70-8F93-DEA4-E217-DCF68797A277}"/>
-              </a:ext>
-            </a:extLst>
-          </p:cNvPr>
-          <p:cNvPicPr>
-            <a:picLocks noChangeAspect="1"/>
-          </p:cNvPicPr>
-          <p:nvPr/>
-        </p:nvPicPr>
-        <p:blipFill>
-          <a:blip r:embed="rId2">
-            <a:extLst>
-              <a:ext uri="{28A0092B-C50C-407E-A947-70E740481C1C}">
-                <a14:useLocalDpi xmlns:a14="http://schemas.microsoft.com/office/drawing/2010/main" val="0"/>
-              </a:ext>
-            </a:extLst>
-          </a:blip>
-          <a:stretch>
-            <a:fillRect/>
-          </a:stretch>
-        </p:blipFill>
-        <p:spPr>
-          <a:xfrm>
-            <a:off x="0" y="0"/>
-            <a:ext cx="12192000" cy="6858000"/>
-          </a:xfrm>
-          <a:prstGeom prst="rect">
-            <a:avLst/>
-          </a:prstGeom>
-        </p:spPr>
-      </p:pic>
-      <p:sp>
-        <p:nvSpPr>
-          <p:cNvPr id="2" name="Title 1">
-            <a:extLst>
-              <a:ext uri="{FF2B5EF4-FFF2-40B4-BE49-F238E27FC236}">
-                <a16:creationId xmlns:a16="http://schemas.microsoft.com/office/drawing/2014/main" id="{67774040-0A70-9E14-53E6-9470E616BF48}"/>
-              </a:ext>
-            </a:extLst>
-          </p:cNvPr>
-          <p:cNvSpPr>
-            <a:spLocks noGrp="1"/>
-          </p:cNvSpPr>
-          <p:nvPr>
-            <p:ph type="title"/>
-          </p:nvPr>
-        </p:nvSpPr>
-        <p:spPr/>
-        <p:txBody>
-          <a:bodyPr/>
-          <a:lstStyle/>
-          <a:p>
-            <a:r>
-              <a:rPr lang="en-AU" dirty="0"/>
-              <a:t>SNe Ia Standardisation		</a:t>
-            </a:r>
-          </a:p>
-        </p:txBody>
-      </p:sp>
-      <mc:AlternateContent xmlns:mc="http://schemas.openxmlformats.org/markup-compatibility/2006" xmlns:a14="http://schemas.microsoft.com/office/drawing/2010/main">
-        <mc:Choice Requires="a14">
-          <p:sp>
-            <p:nvSpPr>
-              <p:cNvPr id="3" name="Content Placeholder 2">
-                <a:extLst>
-                  <a:ext uri="{FF2B5EF4-FFF2-40B4-BE49-F238E27FC236}">
-                    <a16:creationId xmlns:a16="http://schemas.microsoft.com/office/drawing/2014/main" id="{E2F9D149-6C69-14C3-B581-2D0ED24CFB25}"/>
-                  </a:ext>
-                </a:extLst>
-              </p:cNvPr>
-              <p:cNvSpPr>
-                <a:spLocks noGrp="1"/>
-              </p:cNvSpPr>
-              <p:nvPr>
-                <p:ph idx="1"/>
-              </p:nvPr>
-            </p:nvSpPr>
-            <p:spPr/>
-            <p:txBody>
-              <a:bodyPr>
-                <a:normAutofit/>
-              </a:bodyPr>
-              <a:lstStyle/>
-              <a:p>
-                <a:pPr marL="0" indent="0">
-                  <a:buNone/>
-                </a:pPr>
-                <a:endParaRPr lang="en-AU" dirty="0"/>
-              </a:p>
-              <a:p>
-                <a14:m>
-                  <m:oMath xmlns:m="http://schemas.openxmlformats.org/officeDocument/2006/math">
-                    <m:sSub>
-                      <m:sSubPr>
-                        <m:ctrlPr>
-                          <a:rPr lang="en-AU" i="1">
-                            <a:latin typeface="Cambria Math" panose="02040503050406030204" pitchFamily="18" charset="0"/>
-                          </a:rPr>
-                        </m:ctrlPr>
-                      </m:sSubPr>
-                      <m:e>
-                        <m:r>
-                          <a:rPr lang="en-AU" i="1">
-                            <a:latin typeface="Cambria Math" panose="02040503050406030204" pitchFamily="18" charset="0"/>
-                          </a:rPr>
-                          <m:t>𝜇</m:t>
-                        </m:r>
-                      </m:e>
-                      <m:sub>
-                        <m:r>
-                          <a:rPr lang="en-AU" i="1">
-                            <a:latin typeface="Cambria Math" panose="02040503050406030204" pitchFamily="18" charset="0"/>
-                          </a:rPr>
-                          <m:t>𝑜𝑏𝑠</m:t>
-                        </m:r>
-                      </m:sub>
-                    </m:sSub>
-                    <m:r>
-                      <a:rPr lang="en-AU" i="1">
-                        <a:latin typeface="Cambria Math" panose="02040503050406030204" pitchFamily="18" charset="0"/>
-                      </a:rPr>
-                      <m:t>=</m:t>
-                    </m:r>
-                    <m:sSubSup>
-                      <m:sSubSupPr>
-                        <m:ctrlPr>
-                          <a:rPr lang="en-AU" i="1">
-                            <a:latin typeface="Cambria Math" panose="02040503050406030204" pitchFamily="18" charset="0"/>
-                          </a:rPr>
-                        </m:ctrlPr>
-                      </m:sSubSupPr>
-                      <m:e>
-                        <m:r>
-                          <a:rPr lang="en-AU" i="1">
-                            <a:latin typeface="Cambria Math" panose="02040503050406030204" pitchFamily="18" charset="0"/>
-                          </a:rPr>
-                          <m:t>𝑚</m:t>
-                        </m:r>
-                      </m:e>
-                      <m:sub>
-                        <m:r>
-                          <a:rPr lang="en-AU" i="1">
-                            <a:latin typeface="Cambria Math" panose="02040503050406030204" pitchFamily="18" charset="0"/>
-                          </a:rPr>
-                          <m:t>𝐵</m:t>
-                        </m:r>
-                      </m:sub>
-                      <m:sup>
-                        <m:r>
-                          <a:rPr lang="en-AU" i="1">
-                            <a:latin typeface="Cambria Math" panose="02040503050406030204" pitchFamily="18" charset="0"/>
-                          </a:rPr>
-                          <m:t>∗</m:t>
-                        </m:r>
-                      </m:sup>
-                    </m:sSubSup>
-                    <m:r>
-                      <a:rPr lang="en-AU" i="1">
-                        <a:latin typeface="Cambria Math" panose="02040503050406030204" pitchFamily="18" charset="0"/>
-                      </a:rPr>
-                      <m:t>−</m:t>
-                    </m:r>
-                    <m:sSub>
-                      <m:sSubPr>
-                        <m:ctrlPr>
-                          <a:rPr lang="en-AU" i="1">
-                            <a:latin typeface="Cambria Math" panose="02040503050406030204" pitchFamily="18" charset="0"/>
-                          </a:rPr>
-                        </m:ctrlPr>
-                      </m:sSubPr>
-                      <m:e>
-                        <m:r>
-                          <a:rPr lang="en-AU" i="1">
-                            <a:latin typeface="Cambria Math" panose="02040503050406030204" pitchFamily="18" charset="0"/>
-                          </a:rPr>
-                          <m:t>𝑀</m:t>
-                        </m:r>
-                      </m:e>
-                      <m:sub>
-                        <m:r>
-                          <a:rPr lang="en-AU" i="1">
-                            <a:latin typeface="Cambria Math" panose="02040503050406030204" pitchFamily="18" charset="0"/>
-                          </a:rPr>
-                          <m:t>𝐵</m:t>
-                        </m:r>
-                      </m:sub>
-                    </m:sSub>
-                    <m:r>
-                      <a:rPr lang="en-AU" i="1">
-                        <a:latin typeface="Cambria Math" panose="02040503050406030204" pitchFamily="18" charset="0"/>
-                      </a:rPr>
-                      <m:t>+</m:t>
-                    </m:r>
-                    <m:r>
-                      <a:rPr lang="en-AU" i="1">
-                        <a:latin typeface="Cambria Math" panose="02040503050406030204" pitchFamily="18" charset="0"/>
-                      </a:rPr>
-                      <m:t>𝛼</m:t>
-                    </m:r>
-                    <m:sSub>
-                      <m:sSubPr>
-                        <m:ctrlPr>
-                          <a:rPr lang="en-AU" i="1">
-                            <a:latin typeface="Cambria Math" panose="02040503050406030204" pitchFamily="18" charset="0"/>
-                          </a:rPr>
-                        </m:ctrlPr>
-                      </m:sSubPr>
-                      <m:e>
-                        <m:r>
-                          <a:rPr lang="en-AU" i="1">
-                            <a:latin typeface="Cambria Math" panose="02040503050406030204" pitchFamily="18" charset="0"/>
-                          </a:rPr>
-                          <m:t>𝑥</m:t>
-                        </m:r>
-                      </m:e>
-                      <m:sub>
-                        <m:r>
-                          <a:rPr lang="en-AU" i="1">
-                            <a:latin typeface="Cambria Math" panose="02040503050406030204" pitchFamily="18" charset="0"/>
-                          </a:rPr>
-                          <m:t>1</m:t>
-                        </m:r>
-                      </m:sub>
-                    </m:sSub>
-                    <m:r>
-                      <a:rPr lang="en-AU" i="1">
-                        <a:latin typeface="Cambria Math" panose="02040503050406030204" pitchFamily="18" charset="0"/>
-                      </a:rPr>
-                      <m:t>−</m:t>
-                    </m:r>
-                    <m:r>
-                      <a:rPr lang="en-AU" i="1">
-                        <a:latin typeface="Cambria Math" panose="02040503050406030204" pitchFamily="18" charset="0"/>
-                      </a:rPr>
-                      <m:t>𝛽</m:t>
-                    </m:r>
-                    <m:r>
-                      <a:rPr lang="en-AU" i="1">
-                        <a:latin typeface="Cambria Math" panose="02040503050406030204" pitchFamily="18" charset="0"/>
-                      </a:rPr>
-                      <m:t>𝑐</m:t>
-                    </m:r>
-                  </m:oMath>
-                </a14:m>
-                <a:r>
-                  <a:rPr lang="en-AU" dirty="0"/>
-                  <a:t> (Tripp Relation)</a:t>
-                </a:r>
-              </a:p>
-              <a:p>
-                <a:endParaRPr lang="en-AU" dirty="0"/>
-              </a:p>
-              <a:p>
-                <a14:m>
-                  <m:oMath xmlns:m="http://schemas.openxmlformats.org/officeDocument/2006/math">
-                    <m:r>
-                      <m:rPr>
-                        <m:sty m:val="p"/>
-                      </m:rPr>
-                      <a:rPr lang="pl-PL" i="0" dirty="0" smtClean="0">
-                        <a:latin typeface="Cambria Math" panose="02040503050406030204" pitchFamily="18" charset="0"/>
-                      </a:rPr>
-                      <m:t>Δ</m:t>
-                    </m:r>
-                    <m:r>
-                      <a:rPr lang="pl-PL" i="1" dirty="0">
-                        <a:latin typeface="Cambria Math" panose="02040503050406030204" pitchFamily="18" charset="0"/>
-                      </a:rPr>
-                      <m:t>𝜇</m:t>
-                    </m:r>
-                    <m:r>
-                      <a:rPr lang="pl-PL" i="1" dirty="0">
-                        <a:latin typeface="Cambria Math" panose="02040503050406030204" pitchFamily="18" charset="0"/>
-                      </a:rPr>
-                      <m:t>=</m:t>
-                    </m:r>
-                    <m:sSub>
-                      <m:sSubPr>
-                        <m:ctrlPr>
-                          <a:rPr lang="pl-PL" i="1" dirty="0">
-                            <a:latin typeface="Cambria Math" panose="02040503050406030204" pitchFamily="18" charset="0"/>
-                          </a:rPr>
-                        </m:ctrlPr>
-                      </m:sSubPr>
-                      <m:e>
-                        <m:r>
-                          <a:rPr lang="pl-PL" i="1" dirty="0">
-                            <a:latin typeface="Cambria Math" panose="02040503050406030204" pitchFamily="18" charset="0"/>
-                          </a:rPr>
-                          <m:t>𝜇</m:t>
-                        </m:r>
-                      </m:e>
-                      <m:sub>
-                        <m:r>
-                          <a:rPr lang="pl-PL" i="1" dirty="0">
-                            <a:latin typeface="Cambria Math" panose="02040503050406030204" pitchFamily="18" charset="0"/>
-                          </a:rPr>
-                          <m:t>𝑜𝑏𝑠</m:t>
-                        </m:r>
-                      </m:sub>
-                    </m:sSub>
-                    <m:r>
-                      <a:rPr lang="pl-PL" i="1" dirty="0">
-                        <a:latin typeface="Cambria Math" panose="02040503050406030204" pitchFamily="18" charset="0"/>
-                      </a:rPr>
-                      <m:t>−</m:t>
-                    </m:r>
-                    <m:sSub>
-                      <m:sSubPr>
-                        <m:ctrlPr>
-                          <a:rPr lang="pl-PL" i="1" dirty="0">
-                            <a:latin typeface="Cambria Math" panose="02040503050406030204" pitchFamily="18" charset="0"/>
-                          </a:rPr>
-                        </m:ctrlPr>
-                      </m:sSubPr>
-                      <m:e>
-                        <m:r>
-                          <a:rPr lang="pl-PL" i="1" dirty="0">
-                            <a:latin typeface="Cambria Math" panose="02040503050406030204" pitchFamily="18" charset="0"/>
-                          </a:rPr>
-                          <m:t>𝜇</m:t>
-                        </m:r>
-                      </m:e>
-                      <m:sub>
-                        <m:r>
-                          <a:rPr lang="pl-PL" i="1" dirty="0">
-                            <a:latin typeface="Cambria Math" panose="02040503050406030204" pitchFamily="18" charset="0"/>
-                          </a:rPr>
-                          <m:t>𝑐𝑜𝑠</m:t>
-                        </m:r>
-                      </m:sub>
-                    </m:sSub>
-                    <m:r>
-                      <a:rPr lang="pl-PL" i="1" dirty="0">
-                        <a:latin typeface="Cambria Math" panose="02040503050406030204" pitchFamily="18" charset="0"/>
-                      </a:rPr>
-                      <m:t> </m:t>
-                    </m:r>
-                  </m:oMath>
-                </a14:m>
-                <a:r>
-                  <a:rPr lang="en-AU" dirty="0"/>
-                  <a:t>(Hubble Residuals)</a:t>
-                </a:r>
-              </a:p>
-              <a:p>
-                <a:pPr marL="0" indent="0">
-                  <a:buNone/>
-                </a:pPr>
-                <a:endParaRPr lang="en-AU" dirty="0"/>
-              </a:p>
-            </p:txBody>
-          </p:sp>
-        </mc:Choice>
-        <mc:Fallback xmlns="">
-          <p:sp>
-            <p:nvSpPr>
-              <p:cNvPr id="3" name="Content Placeholder 2">
-                <a:extLst>
-                  <a:ext uri="{FF2B5EF4-FFF2-40B4-BE49-F238E27FC236}">
-                    <a16:creationId xmlns:a16="http://schemas.microsoft.com/office/drawing/2014/main" id="{94B3334D-4971-EF70-B7DA-621DDF9409E3}"/>
-                  </a:ext>
-                </a:extLst>
-              </p:cNvPr>
-              <p:cNvSpPr>
-                <a:spLocks noGrp="1" noRot="1" noChangeAspect="1" noMove="1" noResize="1" noEditPoints="1" noAdjustHandles="1" noChangeArrowheads="1" noChangeShapeType="1" noTextEdit="1"/>
-              </p:cNvSpPr>
-              <p:nvPr>
-                <p:ph idx="1"/>
-              </p:nvPr>
-            </p:nvSpPr>
-            <p:spPr>
-              <a:blipFill>
-                <a:blip r:embed="rId3"/>
-                <a:stretch>
-                  <a:fillRect/>
-                </a:stretch>
-              </a:blipFill>
-            </p:spPr>
-            <p:txBody>
-              <a:bodyPr/>
-              <a:lstStyle/>
-              <a:p>
-                <a:r>
-                  <a:rPr lang="en-AU">
-                    <a:noFill/>
-                  </a:rPr>
-                  <a:t> </a:t>
-                </a:r>
-              </a:p>
-            </p:txBody>
-          </p:sp>
-        </mc:Fallback>
-      </mc:AlternateContent>
-      <p:pic>
-        <p:nvPicPr>
-          <p:cNvPr id="11" name="Picture 10">
-            <a:extLst>
-              <a:ext uri="{FF2B5EF4-FFF2-40B4-BE49-F238E27FC236}">
-                <a16:creationId xmlns:a16="http://schemas.microsoft.com/office/drawing/2014/main" id="{79ED5915-57CD-ED50-50F3-918947306C24}"/>
-              </a:ext>
-            </a:extLst>
-          </p:cNvPr>
-          <p:cNvPicPr>
-            <a:picLocks noChangeAspect="1"/>
-          </p:cNvPicPr>
-          <p:nvPr/>
-        </p:nvPicPr>
-        <p:blipFill>
-          <a:blip r:embed="rId4">
-            <a:extLst>
-              <a:ext uri="{28A0092B-C50C-407E-A947-70E740481C1C}">
-                <a14:useLocalDpi xmlns:a14="http://schemas.microsoft.com/office/drawing/2010/main" val="0"/>
-              </a:ext>
-            </a:extLst>
-          </a:blip>
-          <a:stretch>
-            <a:fillRect/>
-          </a:stretch>
-        </p:blipFill>
-        <p:spPr>
-          <a:xfrm>
-            <a:off x="2580759" y="961898"/>
-            <a:ext cx="6686894" cy="4934204"/>
-          </a:xfrm>
-          <a:prstGeom prst="rect">
-            <a:avLst/>
-          </a:prstGeom>
-        </p:spPr>
-      </p:pic>
-      <p:sp>
-        <p:nvSpPr>
-          <p:cNvPr id="13" name="TextBox 12">
-            <a:extLst>
-              <a:ext uri="{FF2B5EF4-FFF2-40B4-BE49-F238E27FC236}">
-                <a16:creationId xmlns:a16="http://schemas.microsoft.com/office/drawing/2014/main" id="{02FC6B9C-B20A-A8BA-9743-3EF96B910415}"/>
-              </a:ext>
-            </a:extLst>
-          </p:cNvPr>
-          <p:cNvSpPr txBox="1"/>
-          <p:nvPr/>
-        </p:nvSpPr>
-        <p:spPr>
-          <a:xfrm>
-            <a:off x="2434590" y="5896102"/>
-            <a:ext cx="6167628" cy="369332"/>
-          </a:xfrm>
-          <a:prstGeom prst="rect">
-            <a:avLst/>
-          </a:prstGeom>
-          <a:noFill/>
-        </p:spPr>
-        <p:txBody>
-          <a:bodyPr wrap="square">
-            <a:spAutoFit/>
-          </a:bodyPr>
-          <a:lstStyle/>
-          <a:p>
-            <a:r>
-              <a:rPr lang="en-AU" dirty="0"/>
-              <a:t>(Martin et al., 2024)</a:t>
-            </a:r>
-          </a:p>
-        </p:txBody>
-      </p:sp>
-    </p:spTree>
-    <p:extLst>
-      <p:ext uri="{BB962C8B-B14F-4D97-AF65-F5344CB8AC3E}">
-        <p14:creationId xmlns:p14="http://schemas.microsoft.com/office/powerpoint/2010/main" val="705688405"/>
+        <p14:creationId xmlns:p14="http://schemas.microsoft.com/office/powerpoint/2010/main" val="2898617131"/>
       </p:ext>
     </p:extLst>
   </p:cSld>
@@ -6441,7 +5443,7 @@
           <p:cNvPr id="4" name="Picture 3">
             <a:extLst>
               <a:ext uri="{FF2B5EF4-FFF2-40B4-BE49-F238E27FC236}">
-                <a16:creationId xmlns:a16="http://schemas.microsoft.com/office/drawing/2014/main" id="{2C4E09F2-D5A3-5470-58F4-227C9880BE98}"/>
+                <a16:creationId xmlns:a16="http://schemas.microsoft.com/office/drawing/2014/main" id="{F6C30746-EDE1-558E-B8A0-EB4F30C63937}"/>
               </a:ext>
             </a:extLst>
           </p:cNvPr>
@@ -6477,7 +5479,7 @@
           <p:cNvPr id="2" name="Title 1">
             <a:extLst>
               <a:ext uri="{FF2B5EF4-FFF2-40B4-BE49-F238E27FC236}">
-                <a16:creationId xmlns:a16="http://schemas.microsoft.com/office/drawing/2014/main" id="{898C01F2-403E-1B28-A1A4-DB20333CCFE3}"/>
+                <a16:creationId xmlns:a16="http://schemas.microsoft.com/office/drawing/2014/main" id="{8838B81B-16EF-32C2-9AD9-40DDEF066725}"/>
               </a:ext>
             </a:extLst>
           </p:cNvPr>
@@ -6495,17 +5497,17 @@
           <a:p>
             <a:r>
               <a:rPr lang="en-AU" dirty="0"/>
-              <a:t>Early Excess Flux	</a:t>
-            </a:r>
-          </a:p>
-        </p:txBody>
-      </p:sp>
-      <p:sp>
-        <p:nvSpPr>
-          <p:cNvPr id="3" name="Content Placeholder 2">
-            <a:extLst>
-              <a:ext uri="{FF2B5EF4-FFF2-40B4-BE49-F238E27FC236}">
-                <a16:creationId xmlns:a16="http://schemas.microsoft.com/office/drawing/2014/main" id="{CB84F266-4C36-F74A-28E0-193391E8F1FE}"/>
+              <a:t>Host Galaxy Properties</a:t>
+            </a:r>
+          </a:p>
+        </p:txBody>
+      </p:sp>
+      <p:sp>
+        <p:nvSpPr>
+          <p:cNvPr id="5" name="Content Placeholder 2">
+            <a:extLst>
+              <a:ext uri="{FF2B5EF4-FFF2-40B4-BE49-F238E27FC236}">
+                <a16:creationId xmlns:a16="http://schemas.microsoft.com/office/drawing/2014/main" id="{CD963945-D928-4C40-AFD9-EF4F18DD0EBF}"/>
               </a:ext>
             </a:extLst>
           </p:cNvPr>
@@ -6519,104 +5521,45 @@
         <p:spPr>
           <a:xfrm>
             <a:off x="838200" y="1825625"/>
-            <a:ext cx="5343144" cy="4351338"/>
+            <a:ext cx="9110472" cy="4351338"/>
           </a:xfrm>
         </p:spPr>
         <p:txBody>
           <a:bodyPr>
-            <a:normAutofit lnSpcReduction="10000"/>
+            <a:normAutofit/>
           </a:bodyPr>
           <a:lstStyle/>
           <a:p>
             <a:r>
               <a:rPr lang="en-AU" dirty="0"/>
-              <a:t>In some cases, observation of SNe Ia are early and produce a bump in the light curve.</a:t>
-            </a:r>
-          </a:p>
-          <a:p>
-            <a:endParaRPr lang="en-AU" dirty="0"/>
-          </a:p>
-          <a:p>
+              <a:t>Use fits of the host galaxy fluxes in the various bands of the Vera C. Rubin telescope to determine the following properties.</a:t>
+            </a:r>
+          </a:p>
+          <a:p>
+            <a:pPr lvl="1"/>
             <a:r>
               <a:rPr lang="en-AU" dirty="0"/>
-              <a:t>Case studies have proposed companion interaction, clumping of nickel 56 and interactions with CSM (Deckers et al., 2022), (Burke et al., 2022), (Marion et al., 2016) and (Wu et al., 2026)</a:t>
-            </a:r>
-          </a:p>
-          <a:p>
-            <a:pPr marL="0" indent="0">
-              <a:buNone/>
-            </a:pPr>
-            <a:endParaRPr lang="en-AU" dirty="0"/>
-          </a:p>
-        </p:txBody>
-      </p:sp>
-      <p:pic>
-        <p:nvPicPr>
-          <p:cNvPr id="6" name="Picture 5">
-            <a:extLst>
-              <a:ext uri="{FF2B5EF4-FFF2-40B4-BE49-F238E27FC236}">
-                <a16:creationId xmlns:a16="http://schemas.microsoft.com/office/drawing/2014/main" id="{6E30B3AC-4B2C-988D-59BB-3BDF52719258}"/>
-              </a:ext>
-            </a:extLst>
-          </p:cNvPr>
-          <p:cNvPicPr>
-            <a:picLocks noChangeAspect="1"/>
-          </p:cNvPicPr>
-          <p:nvPr/>
-        </p:nvPicPr>
-        <p:blipFill>
-          <a:blip r:embed="rId3">
-            <a:extLst>
-              <a:ext uri="{28A0092B-C50C-407E-A947-70E740481C1C}">
-                <a14:useLocalDpi xmlns:a14="http://schemas.microsoft.com/office/drawing/2010/main" val="0"/>
-              </a:ext>
-            </a:extLst>
-          </a:blip>
-          <a:stretch>
-            <a:fillRect/>
-          </a:stretch>
-        </p:blipFill>
-        <p:spPr>
-          <a:xfrm>
-            <a:off x="6659118" y="1289573"/>
-            <a:ext cx="4457982" cy="4666620"/>
-          </a:xfrm>
-          <a:prstGeom prst="rect">
-            <a:avLst/>
-          </a:prstGeom>
-        </p:spPr>
-      </p:pic>
-      <p:sp>
-        <p:nvSpPr>
-          <p:cNvPr id="9" name="TextBox 8">
-            <a:extLst>
-              <a:ext uri="{FF2B5EF4-FFF2-40B4-BE49-F238E27FC236}">
-                <a16:creationId xmlns:a16="http://schemas.microsoft.com/office/drawing/2014/main" id="{78D4041E-EF53-343E-CED9-A6E511D87581}"/>
-              </a:ext>
-            </a:extLst>
-          </p:cNvPr>
-          <p:cNvSpPr txBox="1"/>
-          <p:nvPr/>
-        </p:nvSpPr>
-        <p:spPr>
-          <a:xfrm>
-            <a:off x="6659118" y="5956193"/>
-            <a:ext cx="6167628" cy="369332"/>
-          </a:xfrm>
-          <a:prstGeom prst="rect">
-            <a:avLst/>
-          </a:prstGeom>
-          <a:noFill/>
-        </p:spPr>
-        <p:txBody>
-          <a:bodyPr wrap="square">
-            <a:spAutoFit/>
-          </a:bodyPr>
-          <a:lstStyle/>
-          <a:p>
+              <a:t>SFR</a:t>
+            </a:r>
+          </a:p>
+          <a:p>
+            <a:pPr lvl="1"/>
             <a:r>
               <a:rPr lang="en-AU" dirty="0"/>
-              <a:t>(Deckers et al., 2022)</a:t>
+              <a:t>Stellar Mass</a:t>
+            </a:r>
+          </a:p>
+          <a:p>
+            <a:pPr lvl="1"/>
+            <a:r>
+              <a:rPr lang="en-AU" dirty="0"/>
+              <a:t>Colour</a:t>
+            </a:r>
+          </a:p>
+          <a:p>
+            <a:r>
+              <a:rPr lang="en-AU" dirty="0"/>
+              <a:t>Use the position of the SNe Ia to determine the DLR.</a:t>
             </a:r>
           </a:p>
         </p:txBody>
@@ -6624,7 +5567,7 @@
     </p:spTree>
     <p:extLst>
       <p:ext uri="{BB962C8B-B14F-4D97-AF65-F5344CB8AC3E}">
-        <p14:creationId xmlns:p14="http://schemas.microsoft.com/office/powerpoint/2010/main" val="2452326653"/>
+        <p14:creationId xmlns:p14="http://schemas.microsoft.com/office/powerpoint/2010/main" val="4054569954"/>
       </p:ext>
     </p:extLst>
   </p:cSld>
@@ -6656,7 +5599,7 @@
           <p:cNvPr id="4" name="Picture 3">
             <a:extLst>
               <a:ext uri="{FF2B5EF4-FFF2-40B4-BE49-F238E27FC236}">
-                <a16:creationId xmlns:a16="http://schemas.microsoft.com/office/drawing/2014/main" id="{79C67840-4287-4411-DE2F-52855A7481AD}"/>
+                <a16:creationId xmlns:a16="http://schemas.microsoft.com/office/drawing/2014/main" id="{19C14099-4909-B2F6-6B98-D56DD6C8EB73}"/>
               </a:ext>
             </a:extLst>
           </p:cNvPr>
@@ -6692,7 +5635,7 @@
           <p:cNvPr id="2" name="Title 1">
             <a:extLst>
               <a:ext uri="{FF2B5EF4-FFF2-40B4-BE49-F238E27FC236}">
-                <a16:creationId xmlns:a16="http://schemas.microsoft.com/office/drawing/2014/main" id="{818C63AB-6315-7F38-6415-DAAEFC8D1CDE}"/>
+                <a16:creationId xmlns:a16="http://schemas.microsoft.com/office/drawing/2014/main" id="{04E74744-A3E4-3B34-BBF5-7F6E0556C141}"/>
               </a:ext>
             </a:extLst>
           </p:cNvPr>
@@ -6710,7 +5653,7 @@
           <a:p>
             <a:r>
               <a:rPr lang="en-AU" dirty="0"/>
-              <a:t>Host Galaxy Environments</a:t>
+              <a:t>What’s Next</a:t>
             </a:r>
           </a:p>
         </p:txBody>
@@ -6720,7 +5663,7 @@
           <p:cNvPr id="3" name="Content Placeholder 2">
             <a:extLst>
               <a:ext uri="{FF2B5EF4-FFF2-40B4-BE49-F238E27FC236}">
-                <a16:creationId xmlns:a16="http://schemas.microsoft.com/office/drawing/2014/main" id="{6688A419-F0FC-D06B-A5A1-742608EC3F53}"/>
+                <a16:creationId xmlns:a16="http://schemas.microsoft.com/office/drawing/2014/main" id="{5FF50A3F-6108-80E6-975C-8C3F7E2CAB75}"/>
               </a:ext>
             </a:extLst>
           </p:cNvPr>
@@ -6734,7 +5677,7 @@
         <p:spPr>
           <a:xfrm>
             <a:off x="838200" y="1825625"/>
-            <a:ext cx="9293352" cy="4351338"/>
+            <a:ext cx="8624027" cy="1562086"/>
           </a:xfrm>
         </p:spPr>
         <p:txBody>
@@ -6743,123 +5686,221 @@
           <a:p>
             <a:r>
               <a:rPr lang="en-AU" dirty="0"/>
-              <a:t>To improve standardisation and understand the physics of the SNe Ia explosion, we search for correlation with the host galaxy mass, colour, distance (DLR) and SFR.</a:t>
-            </a:r>
-          </a:p>
-        </p:txBody>
-      </p:sp>
-      <p:pic>
-        <p:nvPicPr>
-          <p:cNvPr id="7" name="Picture 6">
-            <a:extLst>
-              <a:ext uri="{FF2B5EF4-FFF2-40B4-BE49-F238E27FC236}">
-                <a16:creationId xmlns:a16="http://schemas.microsoft.com/office/drawing/2014/main" id="{A7D4CAA6-AF0E-8168-E964-FD907ECBACCE}"/>
-              </a:ext>
-            </a:extLst>
-          </p:cNvPr>
-          <p:cNvPicPr>
-            <a:picLocks noChangeAspect="1"/>
-          </p:cNvPicPr>
+              <a:t>Use SALT modelled light curves to find flux residuals in the SNe Ia.</a:t>
+            </a:r>
+          </a:p>
+          <a:p>
+            <a:pPr lvl="1"/>
+            <a:r>
+              <a:rPr lang="en-AU" dirty="0"/>
+              <a:t>This may give us a sample of early excess flux SNe Ia. </a:t>
+            </a:r>
+          </a:p>
+        </p:txBody>
+      </p:sp>
+      <p:sp>
+        <p:nvSpPr>
+          <p:cNvPr id="5" name="Content Placeholder 2">
+            <a:extLst>
+              <a:ext uri="{FF2B5EF4-FFF2-40B4-BE49-F238E27FC236}">
+                <a16:creationId xmlns:a16="http://schemas.microsoft.com/office/drawing/2014/main" id="{1ECA814F-0D56-F3B5-043C-67AC0C9286EC}"/>
+              </a:ext>
+            </a:extLst>
+          </p:cNvPr>
+          <p:cNvSpPr txBox="1">
+            <a:spLocks/>
+          </p:cNvSpPr>
           <p:nvPr/>
-        </p:nvPicPr>
-        <p:blipFill>
-          <a:blip r:embed="rId3">
-            <a:extLst>
-              <a:ext uri="{28A0092B-C50C-407E-A947-70E740481C1C}">
-                <a14:useLocalDpi xmlns:a14="http://schemas.microsoft.com/office/drawing/2010/main" val="0"/>
-              </a:ext>
-            </a:extLst>
-          </a:blip>
-          <a:stretch>
-            <a:fillRect/>
-          </a:stretch>
-        </p:blipFill>
+        </p:nvSpPr>
         <p:spPr>
           <a:xfrm>
-            <a:off x="816535" y="3429000"/>
-            <a:ext cx="3022459" cy="2271042"/>
+            <a:off x="838200" y="3339555"/>
+            <a:ext cx="8624027" cy="1562086"/>
           </a:xfrm>
           <a:prstGeom prst="rect">
             <a:avLst/>
           </a:prstGeom>
         </p:spPr>
-      </p:pic>
-      <p:pic>
-        <p:nvPicPr>
-          <p:cNvPr id="9" name="Picture 8">
-            <a:extLst>
-              <a:ext uri="{FF2B5EF4-FFF2-40B4-BE49-F238E27FC236}">
-                <a16:creationId xmlns:a16="http://schemas.microsoft.com/office/drawing/2014/main" id="{01F0B274-435A-24DB-2506-66435BFEC1A4}"/>
-              </a:ext>
-            </a:extLst>
-          </p:cNvPr>
-          <p:cNvPicPr>
-            <a:picLocks noChangeAspect="1"/>
-          </p:cNvPicPr>
-          <p:nvPr/>
-        </p:nvPicPr>
-        <p:blipFill>
-          <a:blip r:embed="rId4">
-            <a:extLst>
-              <a:ext uri="{28A0092B-C50C-407E-A947-70E740481C1C}">
-                <a14:useLocalDpi xmlns:a14="http://schemas.microsoft.com/office/drawing/2010/main" val="0"/>
-              </a:ext>
-            </a:extLst>
-          </a:blip>
-          <a:stretch>
-            <a:fillRect/>
-          </a:stretch>
-        </p:blipFill>
-        <p:spPr>
-          <a:xfrm>
-            <a:off x="4584770" y="3429000"/>
-            <a:ext cx="3022459" cy="2823858"/>
-          </a:xfrm>
-          <a:prstGeom prst="rect">
-            <a:avLst/>
-          </a:prstGeom>
-        </p:spPr>
-      </p:pic>
-      <p:pic>
-        <p:nvPicPr>
-          <p:cNvPr id="11" name="Picture 10">
-            <a:extLst>
-              <a:ext uri="{FF2B5EF4-FFF2-40B4-BE49-F238E27FC236}">
-                <a16:creationId xmlns:a16="http://schemas.microsoft.com/office/drawing/2014/main" id="{5918CAA6-D564-15A9-D7D5-ED012FE9E947}"/>
-              </a:ext>
-            </a:extLst>
-          </p:cNvPr>
-          <p:cNvPicPr>
-            <a:picLocks noChangeAspect="1"/>
-          </p:cNvPicPr>
-          <p:nvPr/>
-        </p:nvPicPr>
-        <p:blipFill>
-          <a:blip r:embed="rId5">
-            <a:extLst>
-              <a:ext uri="{28A0092B-C50C-407E-A947-70E740481C1C}">
-                <a14:useLocalDpi xmlns:a14="http://schemas.microsoft.com/office/drawing/2010/main" val="0"/>
-              </a:ext>
-            </a:extLst>
-          </a:blip>
-          <a:stretch>
-            <a:fillRect/>
-          </a:stretch>
-        </p:blipFill>
-        <p:spPr>
-          <a:xfrm>
-            <a:off x="8423764" y="3429000"/>
-            <a:ext cx="3022459" cy="2405269"/>
-          </a:xfrm>
-          <a:prstGeom prst="rect">
-            <a:avLst/>
-          </a:prstGeom>
-        </p:spPr>
-      </p:pic>
+        <p:txBody>
+          <a:bodyPr vert="horz" lIns="91440" tIns="45720" rIns="91440" bIns="45720" rtlCol="0">
+            <a:normAutofit/>
+          </a:bodyPr>
+          <a:lstStyle>
+            <a:lvl1pPr marL="228600" indent="-228600" algn="l" defTabSz="914400" rtl="0" eaLnBrk="1" latinLnBrk="0" hangingPunct="1">
+              <a:lnSpc>
+                <a:spcPct val="90000"/>
+              </a:lnSpc>
+              <a:spcBef>
+                <a:spcPts val="1000"/>
+              </a:spcBef>
+              <a:buFont typeface="Arial" panose="020B0604020202020204" pitchFamily="34" charset="0"/>
+              <a:buChar char="•"/>
+              <a:defRPr sz="2800" kern="1200">
+                <a:solidFill>
+                  <a:schemeClr val="tx1"/>
+                </a:solidFill>
+                <a:latin typeface="+mn-lt"/>
+                <a:ea typeface="+mn-ea"/>
+                <a:cs typeface="+mn-cs"/>
+              </a:defRPr>
+            </a:lvl1pPr>
+            <a:lvl2pPr marL="685800" indent="-228600" algn="l" defTabSz="914400" rtl="0" eaLnBrk="1" latinLnBrk="0" hangingPunct="1">
+              <a:lnSpc>
+                <a:spcPct val="90000"/>
+              </a:lnSpc>
+              <a:spcBef>
+                <a:spcPts val="500"/>
+              </a:spcBef>
+              <a:buFont typeface="Arial" panose="020B0604020202020204" pitchFamily="34" charset="0"/>
+              <a:buChar char="•"/>
+              <a:defRPr sz="2400" kern="1200">
+                <a:solidFill>
+                  <a:schemeClr val="tx1"/>
+                </a:solidFill>
+                <a:latin typeface="+mn-lt"/>
+                <a:ea typeface="+mn-ea"/>
+                <a:cs typeface="+mn-cs"/>
+              </a:defRPr>
+            </a:lvl2pPr>
+            <a:lvl3pPr marL="1143000" indent="-228600" algn="l" defTabSz="914400" rtl="0" eaLnBrk="1" latinLnBrk="0" hangingPunct="1">
+              <a:lnSpc>
+                <a:spcPct val="90000"/>
+              </a:lnSpc>
+              <a:spcBef>
+                <a:spcPts val="500"/>
+              </a:spcBef>
+              <a:buFont typeface="Arial" panose="020B0604020202020204" pitchFamily="34" charset="0"/>
+              <a:buChar char="•"/>
+              <a:defRPr sz="2000" kern="1200">
+                <a:solidFill>
+                  <a:schemeClr val="tx1"/>
+                </a:solidFill>
+                <a:latin typeface="+mn-lt"/>
+                <a:ea typeface="+mn-ea"/>
+                <a:cs typeface="+mn-cs"/>
+              </a:defRPr>
+            </a:lvl3pPr>
+            <a:lvl4pPr marL="1600200" indent="-228600" algn="l" defTabSz="914400" rtl="0" eaLnBrk="1" latinLnBrk="0" hangingPunct="1">
+              <a:lnSpc>
+                <a:spcPct val="90000"/>
+              </a:lnSpc>
+              <a:spcBef>
+                <a:spcPts val="500"/>
+              </a:spcBef>
+              <a:buFont typeface="Arial" panose="020B0604020202020204" pitchFamily="34" charset="0"/>
+              <a:buChar char="•"/>
+              <a:defRPr sz="1800" kern="1200">
+                <a:solidFill>
+                  <a:schemeClr val="tx1"/>
+                </a:solidFill>
+                <a:latin typeface="+mn-lt"/>
+                <a:ea typeface="+mn-ea"/>
+                <a:cs typeface="+mn-cs"/>
+              </a:defRPr>
+            </a:lvl4pPr>
+            <a:lvl5pPr marL="2057400" indent="-228600" algn="l" defTabSz="914400" rtl="0" eaLnBrk="1" latinLnBrk="0" hangingPunct="1">
+              <a:lnSpc>
+                <a:spcPct val="90000"/>
+              </a:lnSpc>
+              <a:spcBef>
+                <a:spcPts val="500"/>
+              </a:spcBef>
+              <a:buFont typeface="Arial" panose="020B0604020202020204" pitchFamily="34" charset="0"/>
+              <a:buChar char="•"/>
+              <a:defRPr sz="1800" kern="1200">
+                <a:solidFill>
+                  <a:schemeClr val="tx1"/>
+                </a:solidFill>
+                <a:latin typeface="+mn-lt"/>
+                <a:ea typeface="+mn-ea"/>
+                <a:cs typeface="+mn-cs"/>
+              </a:defRPr>
+            </a:lvl5pPr>
+            <a:lvl6pPr marL="2514600" indent="-228600" algn="l" defTabSz="914400" rtl="0" eaLnBrk="1" latinLnBrk="0" hangingPunct="1">
+              <a:lnSpc>
+                <a:spcPct val="90000"/>
+              </a:lnSpc>
+              <a:spcBef>
+                <a:spcPts val="500"/>
+              </a:spcBef>
+              <a:buFont typeface="Arial" panose="020B0604020202020204" pitchFamily="34" charset="0"/>
+              <a:buChar char="•"/>
+              <a:defRPr sz="1800" kern="1200">
+                <a:solidFill>
+                  <a:schemeClr val="tx1"/>
+                </a:solidFill>
+                <a:latin typeface="+mn-lt"/>
+                <a:ea typeface="+mn-ea"/>
+                <a:cs typeface="+mn-cs"/>
+              </a:defRPr>
+            </a:lvl6pPr>
+            <a:lvl7pPr marL="2971800" indent="-228600" algn="l" defTabSz="914400" rtl="0" eaLnBrk="1" latinLnBrk="0" hangingPunct="1">
+              <a:lnSpc>
+                <a:spcPct val="90000"/>
+              </a:lnSpc>
+              <a:spcBef>
+                <a:spcPts val="500"/>
+              </a:spcBef>
+              <a:buFont typeface="Arial" panose="020B0604020202020204" pitchFamily="34" charset="0"/>
+              <a:buChar char="•"/>
+              <a:defRPr sz="1800" kern="1200">
+                <a:solidFill>
+                  <a:schemeClr val="tx1"/>
+                </a:solidFill>
+                <a:latin typeface="+mn-lt"/>
+                <a:ea typeface="+mn-ea"/>
+                <a:cs typeface="+mn-cs"/>
+              </a:defRPr>
+            </a:lvl7pPr>
+            <a:lvl8pPr marL="3429000" indent="-228600" algn="l" defTabSz="914400" rtl="0" eaLnBrk="1" latinLnBrk="0" hangingPunct="1">
+              <a:lnSpc>
+                <a:spcPct val="90000"/>
+              </a:lnSpc>
+              <a:spcBef>
+                <a:spcPts val="500"/>
+              </a:spcBef>
+              <a:buFont typeface="Arial" panose="020B0604020202020204" pitchFamily="34" charset="0"/>
+              <a:buChar char="•"/>
+              <a:defRPr sz="1800" kern="1200">
+                <a:solidFill>
+                  <a:schemeClr val="tx1"/>
+                </a:solidFill>
+                <a:latin typeface="+mn-lt"/>
+                <a:ea typeface="+mn-ea"/>
+                <a:cs typeface="+mn-cs"/>
+              </a:defRPr>
+            </a:lvl8pPr>
+            <a:lvl9pPr marL="3886200" indent="-228600" algn="l" defTabSz="914400" rtl="0" eaLnBrk="1" latinLnBrk="0" hangingPunct="1">
+              <a:lnSpc>
+                <a:spcPct val="90000"/>
+              </a:lnSpc>
+              <a:spcBef>
+                <a:spcPts val="500"/>
+              </a:spcBef>
+              <a:buFont typeface="Arial" panose="020B0604020202020204" pitchFamily="34" charset="0"/>
+              <a:buChar char="•"/>
+              <a:defRPr sz="1800" kern="1200">
+                <a:solidFill>
+                  <a:schemeClr val="tx1"/>
+                </a:solidFill>
+                <a:latin typeface="+mn-lt"/>
+                <a:ea typeface="+mn-ea"/>
+                <a:cs typeface="+mn-cs"/>
+              </a:defRPr>
+            </a:lvl9pPr>
+          </a:lstStyle>
+          <a:p>
+            <a:r>
+              <a:rPr lang="en-AU" dirty="0"/>
+              <a:t>If sample size is significant, the correlations with the host galaxy properties of the early excess flux will be found!</a:t>
+            </a:r>
+          </a:p>
+        </p:txBody>
+      </p:sp>
     </p:spTree>
     <p:extLst>
       <p:ext uri="{BB962C8B-B14F-4D97-AF65-F5344CB8AC3E}">
-        <p14:creationId xmlns:p14="http://schemas.microsoft.com/office/powerpoint/2010/main" val="3741420523"/>
+        <p14:creationId xmlns:p14="http://schemas.microsoft.com/office/powerpoint/2010/main" val="3856569849"/>
       </p:ext>
     </p:extLst>
   </p:cSld>

</xml_diff>

<commit_message>
1/05/2026: last iterations were made on the literature review and oral presentation slides they are ready for Anais to give feedback on. Data ingestion script works but is still very manual when picking filters, needs to be smoother and communicate errors better. Lastly object classification scores are working now too and I have gotten a script that collects them nicley from data_ingestion
</commit_message>
<xml_diff>
--- a/Oral_presentation/Oral_Presentation.pptx
+++ b/Oral_presentation/Oral_Presentation.pptx
@@ -205,7 +205,7 @@
           <a:p>
             <a:fld id="{CA1E58A6-B5FA-4B3B-BC1A-ECF1AECB335E}" type="datetimeFigureOut">
               <a:rPr lang="en-AU" smtClean="0"/>
-              <a:t>29/04/2026</a:t>
+              <a:t>1/05/2026</a:t>
             </a:fld>
             <a:endParaRPr lang="en-AU"/>
           </a:p>
@@ -622,7 +622,7 @@
           <a:p>
             <a:fld id="{FDFF1C0A-DBEE-4FE2-852B-82F11989E8A8}" type="datetime1">
               <a:rPr lang="en-AU" smtClean="0"/>
-              <a:t>29/04/2026</a:t>
+              <a:t>1/05/2026</a:t>
             </a:fld>
             <a:endParaRPr lang="en-AU"/>
           </a:p>
@@ -822,7 +822,7 @@
           <a:p>
             <a:fld id="{0B756B61-0096-4C58-ACC2-A1879528B12C}" type="datetime1">
               <a:rPr lang="en-AU" smtClean="0"/>
-              <a:t>29/04/2026</a:t>
+              <a:t>1/05/2026</a:t>
             </a:fld>
             <a:endParaRPr lang="en-AU"/>
           </a:p>
@@ -1032,7 +1032,7 @@
           <a:p>
             <a:fld id="{7FD94802-E000-4AA6-AAA6-10910B20F9C7}" type="datetime1">
               <a:rPr lang="en-AU" smtClean="0"/>
-              <a:t>29/04/2026</a:t>
+              <a:t>1/05/2026</a:t>
             </a:fld>
             <a:endParaRPr lang="en-AU"/>
           </a:p>
@@ -1232,7 +1232,7 @@
           <a:p>
             <a:fld id="{22904B64-59A1-43FD-A621-718A7387472C}" type="datetime1">
               <a:rPr lang="en-AU" smtClean="0"/>
-              <a:t>29/04/2026</a:t>
+              <a:t>1/05/2026</a:t>
             </a:fld>
             <a:endParaRPr lang="en-AU"/>
           </a:p>
@@ -1508,7 +1508,7 @@
           <a:p>
             <a:fld id="{99326B86-071E-4515-930A-F55E3C3EE194}" type="datetime1">
               <a:rPr lang="en-AU" smtClean="0"/>
-              <a:t>29/04/2026</a:t>
+              <a:t>1/05/2026</a:t>
             </a:fld>
             <a:endParaRPr lang="en-AU"/>
           </a:p>
@@ -1776,7 +1776,7 @@
           <a:p>
             <a:fld id="{CDC87059-F666-41C9-8FAB-AA5146F3FF07}" type="datetime1">
               <a:rPr lang="en-AU" smtClean="0"/>
-              <a:t>29/04/2026</a:t>
+              <a:t>1/05/2026</a:t>
             </a:fld>
             <a:endParaRPr lang="en-AU"/>
           </a:p>
@@ -2191,7 +2191,7 @@
           <a:p>
             <a:fld id="{4931922F-AC76-4557-B850-17936BEC57CD}" type="datetime1">
               <a:rPr lang="en-AU" smtClean="0"/>
-              <a:t>29/04/2026</a:t>
+              <a:t>1/05/2026</a:t>
             </a:fld>
             <a:endParaRPr lang="en-AU"/>
           </a:p>
@@ -2333,7 +2333,7 @@
           <a:p>
             <a:fld id="{5FD4AD57-261B-4308-8154-628BF8DC3A87}" type="datetime1">
               <a:rPr lang="en-AU" smtClean="0"/>
-              <a:t>29/04/2026</a:t>
+              <a:t>1/05/2026</a:t>
             </a:fld>
             <a:endParaRPr lang="en-AU"/>
           </a:p>
@@ -2446,7 +2446,7 @@
           <a:p>
             <a:fld id="{511D5AC2-A68E-45A5-B4B8-629D21A8D68D}" type="datetime1">
               <a:rPr lang="en-AU" smtClean="0"/>
-              <a:t>29/04/2026</a:t>
+              <a:t>1/05/2026</a:t>
             </a:fld>
             <a:endParaRPr lang="en-AU"/>
           </a:p>
@@ -2759,7 +2759,7 @@
           <a:p>
             <a:fld id="{11A0A4F9-681A-41D6-8425-C45A9FA1042F}" type="datetime1">
               <a:rPr lang="en-AU" smtClean="0"/>
-              <a:t>29/04/2026</a:t>
+              <a:t>1/05/2026</a:t>
             </a:fld>
             <a:endParaRPr lang="en-AU"/>
           </a:p>
@@ -3048,7 +3048,7 @@
           <a:p>
             <a:fld id="{6DD43FD3-C9E7-4676-B279-9A8841C441C7}" type="datetime1">
               <a:rPr lang="en-AU" smtClean="0"/>
-              <a:t>29/04/2026</a:t>
+              <a:t>1/05/2026</a:t>
             </a:fld>
             <a:endParaRPr lang="en-AU"/>
           </a:p>
@@ -3291,7 +3291,7 @@
           <a:p>
             <a:fld id="{3770AA3F-019E-456E-8699-AA2A3442A186}" type="datetime1">
               <a:rPr lang="en-AU" smtClean="0"/>
-              <a:t>29/04/2026</a:t>
+              <a:t>1/05/2026</a:t>
             </a:fld>
             <a:endParaRPr lang="en-AU"/>
           </a:p>
@@ -3711,10 +3711,13 @@
       </p:grpSpPr>
       <p:pic>
         <p:nvPicPr>
-          <p:cNvPr id="5" name="Picture 4">
+          <p:cNvPr id="5" name="Picture 4" descr="A black and white abstract digital illustration features a wavy black shape occupying the bottom right corner with small white stars and circular elements scattered within it. The rest of the space is blank white, creating a stark contrast and emphasizing the cosmic or space-themed design.&#10;&#10;AI-generated content may be incorrect.">
             <a:extLst>
               <a:ext uri="{FF2B5EF4-FFF2-40B4-BE49-F238E27FC236}">
                 <a16:creationId xmlns:a16="http://schemas.microsoft.com/office/drawing/2014/main" id="{4B62EB1F-E0B3-9602-7525-1B122AC29460}"/>
+              </a:ext>
+              <a:ext uri="{C183D7F6-B498-43B3-948B-1728B52AA6E4}">
+                <adec:decorative xmlns:adec="http://schemas.microsoft.com/office/drawing/2017/decorative" val="1"/>
               </a:ext>
             </a:extLst>
           </p:cNvPr>
@@ -3855,6 +3858,9 @@
               <a:ext uri="{FF2B5EF4-FFF2-40B4-BE49-F238E27FC236}">
                 <a16:creationId xmlns:a16="http://schemas.microsoft.com/office/drawing/2014/main" id="{BAF6EEB9-0E96-B71E-0C10-36510AE026AA}"/>
               </a:ext>
+              <a:ext uri="{C183D7F6-B498-43B3-948B-1728B52AA6E4}">
+                <adec:decorative xmlns:adec="http://schemas.microsoft.com/office/drawing/2017/decorative" val="1"/>
+              </a:ext>
             </a:extLst>
           </p:cNvPr>
           <p:cNvPicPr>
@@ -3998,7 +4004,7 @@
       </p:sp>
       <p:pic>
         <p:nvPicPr>
-          <p:cNvPr id="8" name="Picture 7">
+          <p:cNvPr id="8" name="Picture 7" descr="Photograph of a night sky with colorful star trails captured above a large observatory building on a rocky hill. Star trails create curved, streaked patterns in shades of blue, purple, and white, indicating long-exposure photography tracking Earth's rotation.">
             <a:extLst>
               <a:ext uri="{FF2B5EF4-FFF2-40B4-BE49-F238E27FC236}">
                 <a16:creationId xmlns:a16="http://schemas.microsoft.com/office/drawing/2014/main" id="{C75D2F58-A7DC-DC31-6926-E1EBF5798064}"/>
@@ -4168,6 +4174,9 @@
               <a:ext uri="{FF2B5EF4-FFF2-40B4-BE49-F238E27FC236}">
                 <a16:creationId xmlns:a16="http://schemas.microsoft.com/office/drawing/2014/main" id="{813A4E71-8744-2022-9278-0C2494916B99}"/>
               </a:ext>
+              <a:ext uri="{C183D7F6-B498-43B3-948B-1728B52AA6E4}">
+                <adec:decorative xmlns:adec="http://schemas.microsoft.com/office/drawing/2017/decorative" val="1"/>
+              </a:ext>
             </a:extLst>
           </p:cNvPr>
           <p:cNvPicPr>
@@ -4262,7 +4271,7 @@
       </p:sp>
       <p:pic>
         <p:nvPicPr>
-          <p:cNvPr id="7" name="Picture 6">
+          <p:cNvPr id="7" name="Picture 6" descr="The singel degenerate SNe Ia case ">
             <a:extLst>
               <a:ext uri="{FF2B5EF4-FFF2-40B4-BE49-F238E27FC236}">
                 <a16:creationId xmlns:a16="http://schemas.microsoft.com/office/drawing/2014/main" id="{01EBE7C4-380F-2218-8852-1D66F8B826CF}"/>
@@ -4312,7 +4321,7 @@
       </p:pic>
       <p:pic>
         <p:nvPicPr>
-          <p:cNvPr id="11" name="Picture 10">
+          <p:cNvPr id="11" name="Picture 10" descr="The double degenerate SNe Ia case">
             <a:extLst>
               <a:ext uri="{FF2B5EF4-FFF2-40B4-BE49-F238E27FC236}">
                 <a16:creationId xmlns:a16="http://schemas.microsoft.com/office/drawing/2014/main" id="{962BFC33-D111-E9FF-33B4-BC6275A9A9A6}"/>
@@ -4482,6 +4491,9 @@
               <a:ext uri="{FF2B5EF4-FFF2-40B4-BE49-F238E27FC236}">
                 <a16:creationId xmlns:a16="http://schemas.microsoft.com/office/drawing/2014/main" id="{34F08E1A-6A47-E455-29A2-A2716FE60144}"/>
               </a:ext>
+              <a:ext uri="{C183D7F6-B498-43B3-948B-1728B52AA6E4}">
+                <adec:decorative xmlns:adec="http://schemas.microsoft.com/office/drawing/2017/decorative" val="1"/>
+              </a:ext>
             </a:extLst>
           </p:cNvPr>
           <p:cNvPicPr>
@@ -4597,7 +4609,7 @@
       </p:sp>
       <p:pic>
         <p:nvPicPr>
-          <p:cNvPr id="10" name="Picture 9">
+          <p:cNvPr id="10" name="Picture 9" descr="An Example light curve of SN 2011fe">
             <a:extLst>
               <a:ext uri="{FF2B5EF4-FFF2-40B4-BE49-F238E27FC236}">
                 <a16:creationId xmlns:a16="http://schemas.microsoft.com/office/drawing/2014/main" id="{61AA9387-B3C7-E5C2-543E-8228625B60FD}"/>
@@ -4732,6 +4744,9 @@
               <a:ext uri="{FF2B5EF4-FFF2-40B4-BE49-F238E27FC236}">
                 <a16:creationId xmlns:a16="http://schemas.microsoft.com/office/drawing/2014/main" id="{2C4E09F2-D5A3-5470-58F4-227C9880BE98}"/>
               </a:ext>
+              <a:ext uri="{C183D7F6-B498-43B3-948B-1728B52AA6E4}">
+                <adec:decorative xmlns:adec="http://schemas.microsoft.com/office/drawing/2017/decorative" val="1"/>
+              </a:ext>
             </a:extLst>
           </p:cNvPr>
           <p:cNvPicPr>
@@ -4874,6 +4889,9 @@
             <a:extLst>
               <a:ext uri="{FF2B5EF4-FFF2-40B4-BE49-F238E27FC236}">
                 <a16:creationId xmlns:a16="http://schemas.microsoft.com/office/drawing/2014/main" id="{B93FB9DA-FEC2-4227-049F-B71B2E632C75}"/>
+              </a:ext>
+              <a:ext uri="{C183D7F6-B498-43B3-948B-1728B52AA6E4}">
+                <adec:decorative xmlns:adec="http://schemas.microsoft.com/office/drawing/2017/decorative" val="1"/>
               </a:ext>
             </a:extLst>
           </p:cNvPr>
@@ -4954,6 +4972,9 @@
               <a:ext uri="{FF2B5EF4-FFF2-40B4-BE49-F238E27FC236}">
                 <a16:creationId xmlns:a16="http://schemas.microsoft.com/office/drawing/2014/main" id="{7C33EBE4-4839-94D7-A47F-84723FDFC834}"/>
               </a:ext>
+              <a:ext uri="{C183D7F6-B498-43B3-948B-1728B52AA6E4}">
+                <adec:decorative xmlns:adec="http://schemas.microsoft.com/office/drawing/2017/decorative" val="1"/>
+              </a:ext>
             </a:extLst>
           </p:cNvPr>
           <p:cNvSpPr/>
@@ -5036,6 +5057,9 @@
               <a:ext uri="{FF2B5EF4-FFF2-40B4-BE49-F238E27FC236}">
                 <a16:creationId xmlns:a16="http://schemas.microsoft.com/office/drawing/2014/main" id="{79C67840-4287-4411-DE2F-52855A7481AD}"/>
               </a:ext>
+              <a:ext uri="{C183D7F6-B498-43B3-948B-1728B52AA6E4}">
+                <adec:decorative xmlns:adec="http://schemas.microsoft.com/office/drawing/2017/decorative" val="1"/>
+              </a:ext>
             </a:extLst>
           </p:cNvPr>
           <p:cNvPicPr>
@@ -5135,6 +5159,9 @@
             <a:extLst>
               <a:ext uri="{FF2B5EF4-FFF2-40B4-BE49-F238E27FC236}">
                 <a16:creationId xmlns:a16="http://schemas.microsoft.com/office/drawing/2014/main" id="{01F0B274-435A-24DB-2506-66435BFEC1A4}"/>
+              </a:ext>
+              <a:ext uri="{C183D7F6-B498-43B3-948B-1728B52AA6E4}">
+                <adec:decorative xmlns:adec="http://schemas.microsoft.com/office/drawing/2017/decorative" val="1"/>
               </a:ext>
             </a:extLst>
           </p:cNvPr>
@@ -5286,6 +5313,9 @@
               <a:ext uri="{FF2B5EF4-FFF2-40B4-BE49-F238E27FC236}">
                 <a16:creationId xmlns:a16="http://schemas.microsoft.com/office/drawing/2014/main" id="{8CF574DC-4061-64A8-AC59-2B0A2C2A1F6F}"/>
               </a:ext>
+              <a:ext uri="{C183D7F6-B498-43B3-948B-1728B52AA6E4}">
+                <adec:decorative xmlns:adec="http://schemas.microsoft.com/office/drawing/2017/decorative" val="1"/>
+              </a:ext>
             </a:extLst>
           </p:cNvPr>
           <p:cNvPicPr>
@@ -5343,71 +5373,148 @@
           </a:p>
         </p:txBody>
       </p:sp>
-      <p:sp>
-        <p:nvSpPr>
-          <p:cNvPr id="3" name="Content Placeholder 2">
-            <a:extLst>
-              <a:ext uri="{FF2B5EF4-FFF2-40B4-BE49-F238E27FC236}">
-                <a16:creationId xmlns:a16="http://schemas.microsoft.com/office/drawing/2014/main" id="{0DE6BE5B-DA27-4C06-E559-3561B9464E7E}"/>
-              </a:ext>
-            </a:extLst>
-          </p:cNvPr>
-          <p:cNvSpPr>
-            <a:spLocks noGrp="1"/>
-          </p:cNvSpPr>
-          <p:nvPr>
-            <p:ph idx="1"/>
-          </p:nvPr>
-        </p:nvSpPr>
-        <p:spPr>
-          <a:xfrm>
-            <a:off x="838200" y="1825625"/>
-            <a:ext cx="9110472" cy="4351338"/>
-          </a:xfrm>
-        </p:spPr>
-        <p:txBody>
-          <a:bodyPr>
-            <a:normAutofit/>
-          </a:bodyPr>
-          <a:lstStyle/>
-          <a:p>
-            <a:r>
-              <a:rPr lang="en-AU" dirty="0"/>
-              <a:t>Use Fink </a:t>
-            </a:r>
-            <a:r>
-              <a:rPr lang="en-AU" dirty="0" err="1"/>
-              <a:t>SuperNNova</a:t>
-            </a:r>
-            <a:r>
-              <a:rPr lang="en-AU" dirty="0"/>
-              <a:t> and </a:t>
-            </a:r>
-            <a:r>
-              <a:rPr lang="en-AU" dirty="0" err="1"/>
-              <a:t>earlySNIa</a:t>
-            </a:r>
-            <a:r>
-              <a:rPr lang="en-AU" dirty="0"/>
-              <a:t> classifiers to identify SNe Ia candidates.</a:t>
-            </a:r>
-          </a:p>
-          <a:p>
-            <a:pPr lvl="1"/>
-            <a:r>
-              <a:rPr lang="en-AU" dirty="0"/>
-              <a:t>Through cross matching with galaxy catalogues</a:t>
-            </a:r>
-          </a:p>
-          <a:p>
-            <a:pPr lvl="1"/>
-            <a:r>
-              <a:rPr lang="en-AU" dirty="0"/>
-              <a:t>Object lacks a history of variability</a:t>
-            </a:r>
-          </a:p>
-        </p:txBody>
-      </p:sp>
+      <mc:AlternateContent xmlns:mc="http://schemas.openxmlformats.org/markup-compatibility/2006">
+        <mc:Choice xmlns:a14="http://schemas.microsoft.com/office/drawing/2010/main" Requires="a14">
+          <p:sp>
+            <p:nvSpPr>
+              <p:cNvPr id="3" name="Content Placeholder 2">
+                <a:extLst>
+                  <a:ext uri="{FF2B5EF4-FFF2-40B4-BE49-F238E27FC236}">
+                    <a16:creationId xmlns:a16="http://schemas.microsoft.com/office/drawing/2014/main" id="{0DE6BE5B-DA27-4C06-E559-3561B9464E7E}"/>
+                  </a:ext>
+                </a:extLst>
+              </p:cNvPr>
+              <p:cNvSpPr>
+                <a:spLocks noGrp="1"/>
+              </p:cNvSpPr>
+              <p:nvPr>
+                <p:ph idx="1"/>
+              </p:nvPr>
+            </p:nvSpPr>
+            <p:spPr>
+              <a:xfrm>
+                <a:off x="838200" y="1825625"/>
+                <a:ext cx="6315872" cy="4351338"/>
+              </a:xfrm>
+            </p:spPr>
+            <p:txBody>
+              <a:bodyPr>
+                <a:normAutofit/>
+              </a:bodyPr>
+              <a:lstStyle/>
+              <a:p>
+                <a:r>
+                  <a:rPr lang="en-AU" dirty="0"/>
+                  <a:t>Use Fink </a:t>
+                </a:r>
+                <a:r>
+                  <a:rPr lang="en-AU" dirty="0" err="1"/>
+                  <a:t>SuperNNova</a:t>
+                </a:r>
+                <a:r>
+                  <a:rPr lang="en-AU" dirty="0"/>
+                  <a:t> and </a:t>
+                </a:r>
+                <a:r>
+                  <a:rPr lang="en-AU" dirty="0" err="1"/>
+                  <a:t>earlySNIa</a:t>
+                </a:r>
+                <a:r>
+                  <a:rPr lang="en-AU" dirty="0"/>
+                  <a:t> classifiers to identify SNe Ia candidates.</a:t>
+                </a:r>
+              </a:p>
+              <a:p>
+                <a:pPr lvl="1"/>
+                <a:r>
+                  <a:rPr lang="en-AU" dirty="0"/>
+                  <a:t>Through cross matching with galaxy catalogues</a:t>
+                </a:r>
+              </a:p>
+              <a:p>
+                <a:pPr lvl="1"/>
+                <a:r>
+                  <a:rPr lang="en-AU" dirty="0"/>
+                  <a:t>Galactic latitude cuts of </a:t>
+                </a:r>
+                <a14:m>
+                  <m:oMath xmlns:m="http://schemas.openxmlformats.org/officeDocument/2006/math">
+                    <m:d>
+                      <m:dPr>
+                        <m:begChr m:val="|"/>
+                        <m:endChr m:val="|"/>
+                        <m:ctrlPr>
+                          <a:rPr lang="en-AU" i="1" smtClean="0">
+                            <a:latin typeface="Cambria Math" panose="02040503050406030204" pitchFamily="18" charset="0"/>
+                          </a:rPr>
+                        </m:ctrlPr>
+                      </m:dPr>
+                      <m:e>
+                        <m:r>
+                          <a:rPr lang="en-AU" i="1">
+                            <a:latin typeface="Cambria Math" panose="02040503050406030204" pitchFamily="18" charset="0"/>
+                          </a:rPr>
+                          <m:t>𝑏</m:t>
+                        </m:r>
+                      </m:e>
+                    </m:d>
+                    <m:r>
+                      <a:rPr lang="en-AU" i="1">
+                        <a:latin typeface="Cambria Math" panose="02040503050406030204" pitchFamily="18" charset="0"/>
+                      </a:rPr>
+                      <m:t>&gt;20°</m:t>
+                    </m:r>
+                  </m:oMath>
+                </a14:m>
+                <a:endParaRPr lang="en-AU" dirty="0"/>
+              </a:p>
+            </p:txBody>
+          </p:sp>
+        </mc:Choice>
+        <mc:Fallback>
+          <p:sp>
+            <p:nvSpPr>
+              <p:cNvPr id="3" name="Content Placeholder 2">
+                <a:extLst>
+                  <a:ext uri="{FF2B5EF4-FFF2-40B4-BE49-F238E27FC236}">
+                    <a16:creationId xmlns:a16="http://schemas.microsoft.com/office/drawing/2014/main" id="{0DE6BE5B-DA27-4C06-E559-3561B9464E7E}"/>
+                  </a:ext>
+                </a:extLst>
+              </p:cNvPr>
+              <p:cNvSpPr>
+                <a:spLocks noGrp="1" noRot="1" noChangeAspect="1" noMove="1" noResize="1" noEditPoints="1" noAdjustHandles="1" noChangeArrowheads="1" noChangeShapeType="1" noTextEdit="1"/>
+              </p:cNvSpPr>
+              <p:nvPr>
+                <p:ph idx="1"/>
+              </p:nvPr>
+            </p:nvSpPr>
+            <p:spPr>
+              <a:xfrm>
+                <a:off x="838200" y="1825625"/>
+                <a:ext cx="6315872" cy="4351338"/>
+              </a:xfrm>
+              <a:blipFill>
+                <a:blip r:embed="rId3"/>
+                <a:stretch>
+                  <a:fillRect l="-1737" t="-2381"/>
+                </a:stretch>
+              </a:blipFill>
+            </p:spPr>
+            <p:txBody>
+              <a:bodyPr/>
+              <a:lstStyle/>
+              <a:p>
+                <a:r>
+                  <a:rPr lang="en-AU">
+                    <a:noFill/>
+                  </a:rPr>
+                  <a:t> </a:t>
+                </a:r>
+              </a:p>
+            </p:txBody>
+          </p:sp>
+        </mc:Fallback>
+      </mc:AlternateContent>
     </p:spTree>
     <p:extLst>
       <p:ext uri="{BB962C8B-B14F-4D97-AF65-F5344CB8AC3E}">
@@ -5445,6 +5552,9 @@
               <a:ext uri="{FF2B5EF4-FFF2-40B4-BE49-F238E27FC236}">
                 <a16:creationId xmlns:a16="http://schemas.microsoft.com/office/drawing/2014/main" id="{F6C30746-EDE1-558E-B8A0-EB4F30C63937}"/>
               </a:ext>
+              <a:ext uri="{C183D7F6-B498-43B3-948B-1728B52AA6E4}">
+                <adec:decorative xmlns:adec="http://schemas.microsoft.com/office/drawing/2017/decorative" val="1"/>
+              </a:ext>
             </a:extLst>
           </p:cNvPr>
           <p:cNvPicPr>
@@ -5532,7 +5642,7 @@
           <a:p>
             <a:r>
               <a:rPr lang="en-AU" dirty="0"/>
-              <a:t>Use fits of the host galaxy fluxes in the various bands of the Vera C. Rubin telescope to determine the following properties.</a:t>
+              <a:t>Use fits of the host galaxy fluxes in the g and r bands of the Vera C. Rubin telescope to determine the following properties.</a:t>
             </a:r>
           </a:p>
           <a:p>
@@ -5600,6 +5710,9 @@
             <a:extLst>
               <a:ext uri="{FF2B5EF4-FFF2-40B4-BE49-F238E27FC236}">
                 <a16:creationId xmlns:a16="http://schemas.microsoft.com/office/drawing/2014/main" id="{19C14099-4909-B2F6-6B98-D56DD6C8EB73}"/>
+              </a:ext>
+              <a:ext uri="{C183D7F6-B498-43B3-948B-1728B52AA6E4}">
+                <adec:decorative xmlns:adec="http://schemas.microsoft.com/office/drawing/2017/decorative" val="1"/>
               </a:ext>
             </a:extLst>
           </p:cNvPr>
@@ -5892,7 +6005,7 @@
           <a:p>
             <a:r>
               <a:rPr lang="en-AU" dirty="0"/>
-              <a:t>If sample size is significant, the correlations with the host galaxy properties of the early excess flux will be found!</a:t>
+              <a:t>If sample size is significant, the correlations with the host galaxy properties of the early excess flux can be found!</a:t>
             </a:r>
           </a:p>
         </p:txBody>

</xml_diff>